<commit_message>
Simplify the slides and refresh the review package
</commit_message>
<xml_diff>
--- a/docs/a2/review-slides.pptx
+++ b/docs/a2/review-slides.pptx
@@ -2,18 +2,18 @@
 <file path=ppt/presentation.xml><?xml version="1.0" encoding="utf-8"?>
 <p:presentation xmlns:p="http://schemas.openxmlformats.org/presentationml/2006/main">
   <p:sldMasterIdLst>
-    <p:sldMasterId xmlns:r="http://schemas.openxmlformats.org/officeDocument/2006/relationships" id="2147483648" r:id="R2a8356f434544542"/>
+    <p:sldMasterId xmlns:r="http://schemas.openxmlformats.org/officeDocument/2006/relationships" id="2147483648" r:id="R1cbec950bbb64b34"/>
   </p:sldMasterIdLst>
   <p:notesMasterIdLst>
-    <p:notesMasterId xmlns:r="http://schemas.openxmlformats.org/officeDocument/2006/relationships" r:id="R6ae82ba1e22d4153"/>
+    <p:notesMasterId xmlns:r="http://schemas.openxmlformats.org/officeDocument/2006/relationships" r:id="R81fa132806b44ce0"/>
   </p:notesMasterIdLst>
   <p:sldIdLst>
-    <p:sldId xmlns:r="http://schemas.openxmlformats.org/officeDocument/2006/relationships" id="256" r:id="R81661f1bc8b749b0"/>
-    <p:sldId xmlns:r="http://schemas.openxmlformats.org/officeDocument/2006/relationships" id="257" r:id="Rd5862e65a7004a7d"/>
-    <p:sldId xmlns:r="http://schemas.openxmlformats.org/officeDocument/2006/relationships" id="258" r:id="R32fc346783034ccf"/>
-    <p:sldId xmlns:r="http://schemas.openxmlformats.org/officeDocument/2006/relationships" id="259" r:id="R1838da2740ca48f0"/>
-    <p:sldId xmlns:r="http://schemas.openxmlformats.org/officeDocument/2006/relationships" id="260" r:id="R8cd0a00a92a1433a"/>
-    <p:sldId xmlns:r="http://schemas.openxmlformats.org/officeDocument/2006/relationships" id="261" r:id="R82e3a7e49fbc4b76"/>
+    <p:sldId xmlns:r="http://schemas.openxmlformats.org/officeDocument/2006/relationships" id="256" r:id="R7eee7cbc15354cab"/>
+    <p:sldId xmlns:r="http://schemas.openxmlformats.org/officeDocument/2006/relationships" id="257" r:id="R5dbead02a6b94ae3"/>
+    <p:sldId xmlns:r="http://schemas.openxmlformats.org/officeDocument/2006/relationships" id="258" r:id="Rb2d5635c027b4f3c"/>
+    <p:sldId xmlns:r="http://schemas.openxmlformats.org/officeDocument/2006/relationships" id="259" r:id="R5b5e87f5f4fc4a6c"/>
+    <p:sldId xmlns:r="http://schemas.openxmlformats.org/officeDocument/2006/relationships" id="260" r:id="Rd521127404e246a7"/>
+    <p:sldId xmlns:r="http://schemas.openxmlformats.org/officeDocument/2006/relationships" id="261" r:id="R69930f8cc4c247dc"/>
   </p:sldIdLst>
   <p:sldSz cx="12192000" cy="6858000"/>
   <p:notesSz cx="6858000" cy="9144000"/>
@@ -450,6 +450,18 @@
               <a:t>Shaun, 30 seconds. Source: docs/a2/dossier.md section 1; docs/a2/evidence/forecast.json. Synthetic labels and fictional permits. Public ingestion is a parser smoke test. The current collateral stress field is an on-site consumption proxy. Assigned day is pending.</a:t>
             </a:r>
           </a:p>
+          <a:p xmlns:a="http://schemas.openxmlformats.org/drawingml/2006/main">
+            <a:r>
+              <a:t>
+Plain-English talk:
+ECOllateral estimates how much water a proposed data center would use for cooling.
+A researcher or planner enters facility size, cooling type, watershed, and month.
+The system returns water use, calculated physical limits, a prediction range, warnings,
+and permit quotations for the location. Water is measured in million gallons per day.
+The local prototype works, but our water-use targets are made-up test data. We have
+not shown accuracy at real facilities yet.</a:t>
+            </a:r>
+          </a:p>
         </p:txBody>
       </p:sp>
       <p:sp>
@@ -520,6 +532,18 @@
               <a:t>Shaun, 30 seconds. Sources: src/models/regression.py, src/rules/thermodynamic.py, src/grounding/store.py, src/grounding/generator.py; docs/a2/evidence E3/E4 JSON. Rules also use capacity and ambient features. Fault injection -1/1e6 MGD clips to 0/0.446484 MGD for 40 MW, 30 C dry, 20 C wet. Four fictional retrieval cases pass. No LLM arithmetic or legal compliance decision.</a:t>
             </a:r>
           </a:p>
+          <a:p xmlns:a="http://schemas.openxmlformats.org/drawingml/2006/main">
+            <a:r>
+              <a:t>
+Plain-English talk:
+The top path handles numbers. Weather, river flow, drought, season, and facility size
+become six inputs. A tree-based AI model predicts water use. Separate engineering
+rules check the number and warn if it needs adjusting. The bottom path handles permit
+text. We search words, check the location, and return original quotations. Tests showed
+the physical limits and four location cases work. No language model calculates the
+water estimate or decides legal compliance.</a:t>
+            </a:r>
+          </a:p>
         </p:txBody>
       </p:sp>
       <p:sp>
@@ -590,6 +614,20 @@
               <a:t>Shaun, 45 seconds. Source: docs/a2/evidence/regression-comparison.csv and benchmark.json. 1,600 synthetic rows per type, six years, seed 42. Selected tower R2 .99808, direct .99728. No field generalization claim. Model selection and interval sizing reuse calibration partition.</a:t>
             </a:r>
           </a:p>
+          <a:p xmlns:a="http://schemas.openxmlformats.org/drawingml/2006/main">
+            <a:r>
+              <a:t>
+Plain-English talk:
+We compared RandomForest and XGBoost using the same made-up inputs and water-use targets.
+We split dates in time order: 60 percent to train, 20 percent to choose the model and
+set its range, and 20 percent to test. XGBoost lowered average error for towers from
+about 0.00489 to 0.00367 million gallons per day. For direct evaporation, it improved
+from 0.00384 to 0.00319. Each test group has 333 rows. We kept XGBoost and retained
+RandomForest for comparison. Dry air cooling has zero on-site water use in our scope.
+These scores show we learned the generated pattern; real water-use measurements are
+still the main gap.</a:t>
+            </a:r>
+          </a:p>
         </p:txBody>
       </p:sp>
       <p:sp>
@@ -660,6 +698,19 @@
               <a:t>Troy, 40 seconds. Main data source: missingness-summary.csv. Bar values are exact variance multiplied by 1e8. Random gaps, fixed trained model, seed 42. Biased diagnostic: +100 MGD donors, 40% gaps, 20 repeats, predictor=.01*flow, spatial coverage .603305785, linear .985950413. Not a fitted-model failure rate. Interpolation is retrospective; sensitivity bands are not forecast intervals.</a:t>
             </a:r>
           </a:p>
+          <a:p xmlns:a="http://schemas.openxmlformats.org/drawingml/2006/main">
+            <a:r>
+              <a:t>
+Plain-English talk:
+We removed 10, 25, and 40 percent of drought readings and repeated each test 50 times.
+Filling gaps from a nearby station or a straight line through time kept forecasts within
+0.05 million gallons per day of the complete-data result. But our made-up stations
+behave similarly. In a separate test, we raised neighboring flow by 100 million gallons
+per day. Nearby-station filling then passed only 60.3 percent of the tolerance checks.
+That test uses a simple formula, not the fitted AI model. We need tests with biased
+neighbors, long gaps, and several stations losing data together.</a:t>
+            </a:r>
+          </a:p>
         </p:txBody>
       </p:sp>
       <p:sp>
@@ -730,6 +781,18 @@
               <a:t>Troy, 35 seconds. Sources: interval-coverage.csv; src/models/regression.py. Tower 294/333, direct 293/333, nominal .9. Selection and radius share calibration set. Chronological dependence complicates exchangeability. These finite samples do not establish statistical significance. R2 is not confidence; air zero target excluded.</a:t>
             </a:r>
           </a:p>
+          <a:p xmlns:a="http://schemas.openxmlformats.org/drawingml/2006/main">
+            <a:r>
+              <a:t>
+Plain-English talk:
+The models fit the made-up data well, but their prediction ranges missed our goal.
+Ranges intended to include 90 percent of test values included 88.3 percent for towers
+and 88.0 percent for direct evaporation. These are finite test samples, not proof of
+a statistically significant failure. We also used the same data to choose the model
+and set its range. We will separate those jobs and test by facility, time, and drought.
+R-squared measures fit; it is not the chance a prediction is right.</a:t>
+            </a:r>
+          </a:p>
         </p:txBody>
       </p:sp>
       <p:sp>
@@ -798,6 +861,22 @@
           <a:p xmlns:a="http://schemas.openxmlformats.org/drawingml/2006/main">
             <a:r>
               <a:t>Scott, 60 seconds. Source: docs/a2/dossier.md sections 7-8, evidence-summary.csv, team-contributions.md. No neural/LLM comparison run. Shaun majority coding is confirmed; Troy/Scott supporting responsibilities are assigned, not certified completed. Next measured-label study needs facility holdouts, verified station maps, real permit relevance, MAE/RMSE/R2/coverage/width. Course date, deadline, office hours and instructor access remain pending.</a:t>
+            </a:r>
+          </a:p>
+          <a:p xmlns:a="http://schemas.openxmlformats.org/drawingml/2006/main">
+            <a:r>
+              <a:t>
+Plain-English talk:
+We will keep the tree models, physical limits, and permit location checks. We will
+improve the missing-data tests and how prediction ranges are set. We reject using
+R-squared as confidence, and we will wait on neural or generative language models
+because we have not compared them and they do not solve the missing-label problem.
+Our next question is whether the system works at a real facility it has never seen
+during drought, with enough values inside its prediction range. Shaun leads code
+and separate calibration. Troy checks environmental locations and drought tests.
+Scott checks real permits and prepares the evidence. These supporting roles are
+assigned; we still need to confirm actual completed contributions. The dossier keeps
+the full methods, results, limits, and remaining course steps.</a:t>
             </a:r>
           </a:p>
         </p:txBody>
@@ -865,7 +944,7 @@
   </p:cSld>
   <p:clrMap bg1="lt1" tx1="dk1" bg2="lt2" tx2="dk2" accent1="accent1" accent2="accent2" accent3="accent3" accent4="accent4" accent5="accent5" accent6="accent6" hlink="hlink" folHlink="folHlink"/>
   <p:sldLayoutIdLst>
-    <p:sldLayoutId xmlns:r="http://schemas.openxmlformats.org/officeDocument/2006/relationships" id="2147483649" r:id="R793cc338b9a848fe"/>
+    <p:sldLayoutId xmlns:r="http://schemas.openxmlformats.org/officeDocument/2006/relationships" id="2147483649" r:id="Rcc124fd1a9444b5d"/>
   </p:sldLayoutIdLst>
   <p:txStyles>
     <p:titleStyle>
@@ -1578,7 +1657,7 @@
                     <a:ea typeface="Arial"/>
                     <a:cs typeface="Arial"/>
                   </a:rPr>
-                  <a:t>Mean absolute error (MGD)</a:t>
+                  <a:t>Average error (MAE, MGD)</a:t>
                 </a:r>
               </a:p>
             </c:rich>
@@ -1683,7 +1762,7 @@
           <c:idx val="0"/>
           <c:order val="0"/>
           <c:tx>
-            <c:v>Spatial nearest</c:v>
+            <c:v>Nearby station</c:v>
           </c:tx>
           <c:spPr>
             <a:solidFill xmlns:a="http://schemas.openxmlformats.org/drawingml/2006/main">
@@ -1730,7 +1809,7 @@
           <c:idx val="1"/>
           <c:order val="1"/>
           <c:tx>
-            <c:v>Linear time</c:v>
+            <c:v>Straight line</c:v>
           </c:tx>
           <c:spPr>
             <a:solidFill xmlns:a="http://schemas.openxmlformats.org/drawingml/2006/main">
@@ -1868,7 +1947,7 @@
                     <a:ea typeface="Arial"/>
                     <a:cs typeface="Arial"/>
                   </a:rPr>
-                  <a:t>Variance (10^-8 MGD2)</a:t>
+                  <a:t>Prediction spread (10^-8 MGD2)</a:t>
                 </a:r>
               </a:p>
             </c:rich>
@@ -2001,7 +2080,7 @@
                   <c:v>Direct XGB</c:v>
                 </c:pt>
                 <c:pt idx="2">
-                  <c:v>Nominal</c:v>
+                  <c:v>Goal</c:v>
                 </c:pt>
               </c:strCache>
             </c:strRef>
@@ -2120,7 +2199,7 @@
                     <a:ea typeface="Arial"/>
                     <a:cs typeface="Arial"/>
                   </a:rPr>
-                  <a:t>Labels inside interval</a:t>
+                  <a:t>Test values inside range</a:t>
                 </a:r>
               </a:p>
             </c:rich>
@@ -2216,7 +2295,7 @@
           <p:cNvPr id="11" name="">
             <a:extLst xmlns:a="http://schemas.openxmlformats.org/drawingml/2006/main">
               <a:ext uri="{FF2B5EF4-FFF2-40B4-BE49-F238E27FC236}">
-                <a16:creationId xmlns:a16="http://schemas.microsoft.com/office/drawing/2014/main" id="{FA063376-A92F-4DC0-81CC-F24BD0A157CB}"/>
+                <a16:creationId xmlns:a16="http://schemas.microsoft.com/office/drawing/2014/main" id="{400D2397-D5DD-4B06-985F-5A2474E2D3E8}"/>
               </a:ext>
             </a:extLst>
           </p:cNvPr>
@@ -2273,7 +2352,7 @@
           <p:cNvPr id="2" name="">
             <a:extLst xmlns:a="http://schemas.openxmlformats.org/drawingml/2006/main">
               <a:ext uri="{FF2B5EF4-FFF2-40B4-BE49-F238E27FC236}">
-                <a16:creationId xmlns:a16="http://schemas.microsoft.com/office/drawing/2014/main" id="{1FB7BC9F-23DC-4785-84C4-DB989A1C3892}"/>
+                <a16:creationId xmlns:a16="http://schemas.microsoft.com/office/drawing/2014/main" id="{4A72FBBB-9DF2-4C9E-9AB5-65E75084CC3E}"/>
               </a:ext>
             </a:extLst>
           </p:cNvPr>
@@ -2320,7 +2399,7 @@
                 <a:ea typeface="Arial"/>
                 <a:cs typeface="Arial"/>
               </a:rPr>
-              <a:t>How much water does a cooling scenario consume?</a:t>
+              <a:t>Estimate the water a data center uses for cooling</a:t>
             </a:r>
           </a:p>
         </p:txBody>
@@ -2330,7 +2409,7 @@
           <p:cNvPr id="3" name="">
             <a:extLst xmlns:a="http://schemas.openxmlformats.org/drawingml/2006/main">
               <a:ext uri="{FF2B5EF4-FFF2-40B4-BE49-F238E27FC236}">
-                <a16:creationId xmlns:a16="http://schemas.microsoft.com/office/drawing/2014/main" id="{538DF6E4-7324-4738-9AC3-4DDABEF26D9E}"/>
+                <a16:creationId xmlns:a16="http://schemas.microsoft.com/office/drawing/2014/main" id="{58254A26-DABA-4A1B-AF73-423604261F36}"/>
               </a:ext>
             </a:extLst>
           </p:cNvPr>
@@ -2377,7 +2456,7 @@
                 <a:ea typeface="Arial"/>
                 <a:cs typeface="Arial"/>
               </a:rPr>
-              <a:t>Snapshot: October 7, 2026 | Synthetic labels; field validation pending</a:t>
+              <a:t>October 7, 2026 snapshot | Made-up test data; real-facility accuracy still unverified</a:t>
             </a:r>
           </a:p>
         </p:txBody>
@@ -2387,7 +2466,7 @@
           <p:cNvPr id="4" name="">
             <a:extLst xmlns:a="http://schemas.openxmlformats.org/drawingml/2006/main">
               <a:ext uri="{FF2B5EF4-FFF2-40B4-BE49-F238E27FC236}">
-                <a16:creationId xmlns:a16="http://schemas.microsoft.com/office/drawing/2014/main" id="{D661152D-70B6-4FDB-9A2F-A7BB52B9F683}"/>
+                <a16:creationId xmlns:a16="http://schemas.microsoft.com/office/drawing/2014/main" id="{B606856B-5B09-47CE-9103-B12E8C77AB58}"/>
               </a:ext>
             </a:extLst>
           </p:cNvPr>
@@ -2444,7 +2523,7 @@
           <p:cNvPr id="5" name="">
             <a:extLst xmlns:a="http://schemas.openxmlformats.org/drawingml/2006/main">
               <a:ext uri="{FF2B5EF4-FFF2-40B4-BE49-F238E27FC236}">
-                <a16:creationId xmlns:a16="http://schemas.microsoft.com/office/drawing/2014/main" id="{F92BCE69-DEBA-4F90-B5A8-BBFBA2CC8739}"/>
+                <a16:creationId xmlns:a16="http://schemas.microsoft.com/office/drawing/2014/main" id="{3D37B68B-9CA7-48B4-9F34-110847AC9C3D}"/>
               </a:ext>
             </a:extLst>
           </p:cNvPr>
@@ -2501,7 +2580,7 @@
           <p:cNvPr id="6" name="">
             <a:extLst xmlns:a="http://schemas.openxmlformats.org/drawingml/2006/main">
               <a:ext uri="{FF2B5EF4-FFF2-40B4-BE49-F238E27FC236}">
-                <a16:creationId xmlns:a16="http://schemas.microsoft.com/office/drawing/2014/main" id="{74B73C1F-58F8-45C2-8FD5-E9BA28725975}"/>
+                <a16:creationId xmlns:a16="http://schemas.microsoft.com/office/drawing/2014/main" id="{FF398380-C7CF-4AAE-A691-25E2CB7CC9FD}"/>
               </a:ext>
             </a:extLst>
           </p:cNvPr>
@@ -2558,7 +2637,7 @@
           <p:cNvPr id="7" name="">
             <a:extLst xmlns:a="http://schemas.openxmlformats.org/drawingml/2006/main">
               <a:ext uri="{FF2B5EF4-FFF2-40B4-BE49-F238E27FC236}">
-                <a16:creationId xmlns:a16="http://schemas.microsoft.com/office/drawing/2014/main" id="{B500648A-EAD8-456B-B474-210638917F21}"/>
+                <a16:creationId xmlns:a16="http://schemas.microsoft.com/office/drawing/2014/main" id="{06C10FFD-CE01-409D-8853-D5628C2D82DB}"/>
               </a:ext>
             </a:extLst>
           </p:cNvPr>
@@ -2605,7 +2684,7 @@
                 <a:ea typeface="Arial"/>
                 <a:cs typeface="Arial"/>
               </a:rPr>
-              <a:t>Capacity (MW)</a:t>
+              <a:t>IT size (megawatts)</a:t>
             </a:r>
           </a:p>
           <a:p xmlns:a="http://schemas.openxmlformats.org/drawingml/2006/main">
@@ -2661,7 +2740,7 @@
           <p:cNvPr id="8" name="">
             <a:extLst xmlns:a="http://schemas.openxmlformats.org/drawingml/2006/main">
               <a:ext uri="{FF2B5EF4-FFF2-40B4-BE49-F238E27FC236}">
-                <a16:creationId xmlns:a16="http://schemas.microsoft.com/office/drawing/2014/main" id="{AA900CA8-7914-42D5-B757-C3A1CC433F4E}"/>
+                <a16:creationId xmlns:a16="http://schemas.microsoft.com/office/drawing/2014/main" id="{8707A8B7-3240-43DF-B8EA-6EFEB9C7ABB1}"/>
               </a:ext>
             </a:extLst>
           </p:cNvPr>
@@ -2718,7 +2797,7 @@
           <p:cNvPr id="9" name="">
             <a:extLst xmlns:a="http://schemas.openxmlformats.org/drawingml/2006/main">
               <a:ext uri="{FF2B5EF4-FFF2-40B4-BE49-F238E27FC236}">
-                <a16:creationId xmlns:a16="http://schemas.microsoft.com/office/drawing/2014/main" id="{CA119C8C-A143-495E-9403-00B9F7E6ABC9}"/>
+                <a16:creationId xmlns:a16="http://schemas.microsoft.com/office/drawing/2014/main" id="{BDC51567-F7DC-43B4-9619-BF3F469E6EED}"/>
               </a:ext>
             </a:extLst>
           </p:cNvPr>
@@ -2765,7 +2844,7 @@
                 <a:ea typeface="Arial"/>
                 <a:cs typeface="Arial"/>
               </a:rPr>
-              <a:t>Consumption (MGD) + bounds</a:t>
+              <a:t>Water use + physical limits</a:t>
             </a:r>
           </a:p>
           <a:p xmlns:a="http://schemas.openxmlformats.org/drawingml/2006/main">
@@ -2788,7 +2867,7 @@
                 <a:ea typeface="Arial"/>
                 <a:cs typeface="Arial"/>
               </a:rPr>
-              <a:t>Interval + quality warnings</a:t>
+              <a:t>Prediction range + warnings</a:t>
             </a:r>
           </a:p>
           <a:p xmlns:a="http://schemas.openxmlformats.org/drawingml/2006/main">
@@ -2811,7 +2890,7 @@
                 <a:ea typeface="Arial"/>
                 <a:cs typeface="Arial"/>
               </a:rPr>
-              <a:t>Geographic permit quotations</a:t>
+              <a:t>Permit quotes for the location</a:t>
             </a:r>
           </a:p>
         </p:txBody>
@@ -2821,7 +2900,7 @@
           <p:cNvPr id="10" name="">
             <a:extLst xmlns:a="http://schemas.openxmlformats.org/drawingml/2006/main">
               <a:ext uri="{FF2B5EF4-FFF2-40B4-BE49-F238E27FC236}">
-                <a16:creationId xmlns:a16="http://schemas.microsoft.com/office/drawing/2014/main" id="{41765647-0511-4EB5-BD50-8738C425BE7F}"/>
+                <a16:creationId xmlns:a16="http://schemas.microsoft.com/office/drawing/2014/main" id="{77D6933F-9A43-4AF8-A8E5-3E2BBC6E508B}"/>
               </a:ext>
             </a:extLst>
           </p:cNvPr>
@@ -2876,7 +2955,7 @@
     </p:spTree>
     <p:extLst>
       <p:ext uri="{BB962C8B-B14F-4D97-AF65-F5344CB8AC3E}">
-        <p14:creationId xmlns:p14="http://schemas.microsoft.com/office/powerpoint/2010/main" val="1632564706"/>
+        <p14:creationId xmlns:p14="http://schemas.microsoft.com/office/powerpoint/2010/main" val="1112185057"/>
       </p:ext>
     </p:extLst>
   </p:cSld>
@@ -2907,7 +2986,7 @@
           <p:cNvPr id="47" name="">
             <a:extLst xmlns:a="http://schemas.openxmlformats.org/drawingml/2006/main">
               <a:ext uri="{FF2B5EF4-FFF2-40B4-BE49-F238E27FC236}">
-                <a16:creationId xmlns:a16="http://schemas.microsoft.com/office/drawing/2014/main" id="{095DCC60-A8F0-4DA2-9CE5-B74BD27A392F}"/>
+                <a16:creationId xmlns:a16="http://schemas.microsoft.com/office/drawing/2014/main" id="{2C19866A-13E0-45F9-B43A-10561CFD556C}"/>
               </a:ext>
             </a:extLst>
           </p:cNvPr>
@@ -2964,7 +3043,7 @@
           <p:cNvPr id="2" name="">
             <a:extLst xmlns:a="http://schemas.openxmlformats.org/drawingml/2006/main">
               <a:ext uri="{FF2B5EF4-FFF2-40B4-BE49-F238E27FC236}">
-                <a16:creationId xmlns:a16="http://schemas.microsoft.com/office/drawing/2014/main" id="{EBECCDE9-408B-452D-A1E0-B014CB5C1221}"/>
+                <a16:creationId xmlns:a16="http://schemas.microsoft.com/office/drawing/2014/main" id="{76C29430-CE6D-4066-9CBA-76E1E74176BA}"/>
               </a:ext>
             </a:extLst>
           </p:cNvPr>
@@ -3011,7 +3090,7 @@
                 <a:ea typeface="Arial"/>
                 <a:cs typeface="Arial"/>
               </a:rPr>
-              <a:t>Meaning lives in features, rules, vectors, and scope</a:t>
+              <a:t>Two paths: predict water use and find permit quotes</a:t>
             </a:r>
           </a:p>
         </p:txBody>
@@ -3021,7 +3100,7 @@
           <p:cNvPr id="3" name="">
             <a:extLst xmlns:a="http://schemas.openxmlformats.org/drawingml/2006/main">
               <a:ext uri="{FF2B5EF4-FFF2-40B4-BE49-F238E27FC236}">
-                <a16:creationId xmlns:a16="http://schemas.microsoft.com/office/drawing/2014/main" id="{029BF3D4-5551-4BBB-9033-F22661DD4477}"/>
+                <a16:creationId xmlns:a16="http://schemas.microsoft.com/office/drawing/2014/main" id="{7B2BAEA1-3591-4F7D-8874-7D40DB2A4B5B}"/>
               </a:ext>
             </a:extLst>
           </p:cNvPr>
@@ -3078,7 +3157,7 @@
           <p:cNvPr id="4" name="">
             <a:extLst xmlns:a="http://schemas.openxmlformats.org/drawingml/2006/main">
               <a:ext uri="{FF2B5EF4-FFF2-40B4-BE49-F238E27FC236}">
-                <a16:creationId xmlns:a16="http://schemas.microsoft.com/office/drawing/2014/main" id="{08465D1A-028B-4064-91F8-B4437025148E}"/>
+                <a16:creationId xmlns:a16="http://schemas.microsoft.com/office/drawing/2014/main" id="{3955E0CF-1F19-45C4-BECE-71335E0FFDAC}"/>
               </a:ext>
             </a:extLst>
           </p:cNvPr>
@@ -3135,7 +3214,7 @@
           <p:cNvPr id="5" name="">
             <a:extLst xmlns:a="http://schemas.openxmlformats.org/drawingml/2006/main">
               <a:ext uri="{FF2B5EF4-FFF2-40B4-BE49-F238E27FC236}">
-                <a16:creationId xmlns:a16="http://schemas.microsoft.com/office/drawing/2014/main" id="{FD5E0E73-39A8-4AC8-BE13-59EC1E2196D4}"/>
+                <a16:creationId xmlns:a16="http://schemas.microsoft.com/office/drawing/2014/main" id="{398D1565-57F5-4BB0-A847-DF4CB2A01DFA}"/>
               </a:ext>
             </a:extLst>
           </p:cNvPr>
@@ -3182,7 +3261,7 @@
                 <a:ea typeface="Arial"/>
                 <a:cs typeface="Arial"/>
               </a:rPr>
-              <a:t>Request: MW, cooling type, HUC8, month; optional facility coordinates</a:t>
+              <a:t>Enter IT size, cooling type, watershed code (HUC8), and month; coordinates optional</a:t>
             </a:r>
           </a:p>
         </p:txBody>
@@ -3192,7 +3271,7 @@
           <p:cNvPr id="6" name="">
             <a:extLst xmlns:a="http://schemas.openxmlformats.org/drawingml/2006/main">
               <a:ext uri="{FF2B5EF4-FFF2-40B4-BE49-F238E27FC236}">
-                <a16:creationId xmlns:a16="http://schemas.microsoft.com/office/drawing/2014/main" id="{A3134F79-40F0-44D9-8B93-428774E9012A}"/>
+                <a16:creationId xmlns:a16="http://schemas.microsoft.com/office/drawing/2014/main" id="{422CEC0B-D200-4640-B2EA-65BF543B7092}"/>
               </a:ext>
             </a:extLst>
           </p:cNvPr>
@@ -3204,7 +3283,7 @@
         <p:spPr>
           <a:xfrm xmlns:a="http://schemas.openxmlformats.org/drawingml/2006/main">
             <a:off x="619125" y="2257425"/>
-            <a:ext cx="1857375" cy="1104900"/>
+            <a:ext cx="1857375" cy="1238250"/>
           </a:xfrm>
           <a:prstGeom xmlns:a="http://schemas.openxmlformats.org/drawingml/2006/main" prst="rect">
             <a:avLst/>
@@ -3224,7 +3303,7 @@
           <p:cNvPr id="7" name="">
             <a:extLst xmlns:a="http://schemas.openxmlformats.org/drawingml/2006/main">
               <a:ext uri="{FF2B5EF4-FFF2-40B4-BE49-F238E27FC236}">
-                <a16:creationId xmlns:a16="http://schemas.microsoft.com/office/drawing/2014/main" id="{C841683D-8A79-45A7-8368-62DD9A594036}"/>
+                <a16:creationId xmlns:a16="http://schemas.microsoft.com/office/drawing/2014/main" id="{FFC209C0-F7A0-49C1-9B78-D1668E3D65F6}"/>
               </a:ext>
             </a:extLst>
           </p:cNvPr>
@@ -3281,19 +3360,19 @@
           <p:cNvPr id="8" name="">
             <a:extLst xmlns:a="http://schemas.openxmlformats.org/drawingml/2006/main">
               <a:ext uri="{FF2B5EF4-FFF2-40B4-BE49-F238E27FC236}">
-                <a16:creationId xmlns:a16="http://schemas.microsoft.com/office/drawing/2014/main" id="{D03276B2-2477-41C0-B269-FE894CCFC7B1}"/>
-              </a:ext>
-            </a:extLst>
-          </p:cNvPr>
-          <p:cNvSpPr>
-            <a:spLocks xmlns:a="http://schemas.openxmlformats.org/drawingml/2006/main" noGrp="1"/>
-          </p:cNvSpPr>
-          <p:nvPr/>
-        </p:nvSpPr>
-        <p:spPr>
-          <a:xfrm xmlns:a="http://schemas.openxmlformats.org/drawingml/2006/main">
-            <a:off x="714375" y="2743200"/>
-            <a:ext cx="1685925" cy="619125"/>
+                <a16:creationId xmlns:a16="http://schemas.microsoft.com/office/drawing/2014/main" id="{02407753-8477-42C9-930C-751E79F0407C}"/>
+              </a:ext>
+            </a:extLst>
+          </p:cNvPr>
+          <p:cNvSpPr>
+            <a:spLocks xmlns:a="http://schemas.openxmlformats.org/drawingml/2006/main" noGrp="1"/>
+          </p:cNvSpPr>
+          <p:nvPr/>
+        </p:nvSpPr>
+        <p:spPr>
+          <a:xfrm xmlns:a="http://schemas.openxmlformats.org/drawingml/2006/main">
+            <a:off x="714375" y="2686050"/>
+            <a:ext cx="1685925" cy="800100"/>
           </a:xfrm>
           <a:prstGeom xmlns:a="http://schemas.openxmlformats.org/drawingml/2006/main" prst="rect">
             <a:avLst/>
@@ -3351,7 +3430,7 @@
                 <a:ea typeface="Arial"/>
                 <a:cs typeface="Arial"/>
               </a:rPr>
-              <a:t>values + units</a:t>
+              <a:t>units + dates</a:t>
             </a:r>
           </a:p>
         </p:txBody>
@@ -3361,7 +3440,7 @@
           <p:cNvPr id="9" name="">
             <a:extLst xmlns:a="http://schemas.openxmlformats.org/drawingml/2006/main">
               <a:ext uri="{FF2B5EF4-FFF2-40B4-BE49-F238E27FC236}">
-                <a16:creationId xmlns:a16="http://schemas.microsoft.com/office/drawing/2014/main" id="{3A213BBC-5FA1-422E-92A9-D7AAE8C61578}"/>
+                <a16:creationId xmlns:a16="http://schemas.microsoft.com/office/drawing/2014/main" id="{61934EB5-6EE3-436C-A40C-409BF3A0B28F}"/>
               </a:ext>
             </a:extLst>
           </p:cNvPr>
@@ -3373,7 +3452,7 @@
         <p:spPr>
           <a:xfrm xmlns:a="http://schemas.openxmlformats.org/drawingml/2006/main">
             <a:off x="2857500" y="2257425"/>
-            <a:ext cx="1857375" cy="1104900"/>
+            <a:ext cx="1857375" cy="1238250"/>
           </a:xfrm>
           <a:prstGeom xmlns:a="http://schemas.openxmlformats.org/drawingml/2006/main" prst="rect">
             <a:avLst/>
@@ -3393,7 +3472,7 @@
           <p:cNvPr id="10" name="">
             <a:extLst xmlns:a="http://schemas.openxmlformats.org/drawingml/2006/main">
               <a:ext uri="{FF2B5EF4-FFF2-40B4-BE49-F238E27FC236}">
-                <a16:creationId xmlns:a16="http://schemas.microsoft.com/office/drawing/2014/main" id="{397735BC-59EF-44BA-AE28-B78178A121DC}"/>
+                <a16:creationId xmlns:a16="http://schemas.microsoft.com/office/drawing/2014/main" id="{9B4A0D04-D1E0-414D-AE04-17A0CFF469CC}"/>
               </a:ext>
             </a:extLst>
           </p:cNvPr>
@@ -3440,7 +3519,7 @@
                 <a:ea typeface="Arial"/>
                 <a:cs typeface="Arial"/>
               </a:rPr>
-              <a:t>Six features</a:t>
+              <a:t>6 inputs</a:t>
             </a:r>
           </a:p>
         </p:txBody>
@@ -3450,19 +3529,19 @@
           <p:cNvPr id="11" name="">
             <a:extLst xmlns:a="http://schemas.openxmlformats.org/drawingml/2006/main">
               <a:ext uri="{FF2B5EF4-FFF2-40B4-BE49-F238E27FC236}">
-                <a16:creationId xmlns:a16="http://schemas.microsoft.com/office/drawing/2014/main" id="{19806995-359D-4DC3-9B4B-3A95BA623F4C}"/>
-              </a:ext>
-            </a:extLst>
-          </p:cNvPr>
-          <p:cNvSpPr>
-            <a:spLocks xmlns:a="http://schemas.openxmlformats.org/drawingml/2006/main" noGrp="1"/>
-          </p:cNvSpPr>
-          <p:nvPr/>
-        </p:nvSpPr>
-        <p:spPr>
-          <a:xfrm xmlns:a="http://schemas.openxmlformats.org/drawingml/2006/main">
-            <a:off x="2952750" y="2743200"/>
-            <a:ext cx="1685925" cy="619125"/>
+                <a16:creationId xmlns:a16="http://schemas.microsoft.com/office/drawing/2014/main" id="{65C7430E-22C4-4A59-ADB7-EF5E95C08EF5}"/>
+              </a:ext>
+            </a:extLst>
+          </p:cNvPr>
+          <p:cNvSpPr>
+            <a:spLocks xmlns:a="http://schemas.openxmlformats.org/drawingml/2006/main" noGrp="1"/>
+          </p:cNvSpPr>
+          <p:nvPr/>
+        </p:nvSpPr>
+        <p:spPr>
+          <a:xfrm xmlns:a="http://schemas.openxmlformats.org/drawingml/2006/main">
+            <a:off x="2952750" y="2686050"/>
+            <a:ext cx="1685925" cy="800100"/>
           </a:xfrm>
           <a:prstGeom xmlns:a="http://schemas.openxmlformats.org/drawingml/2006/main" prst="rect">
             <a:avLst/>
@@ -3497,7 +3576,7 @@
                 <a:ea typeface="Arial"/>
                 <a:cs typeface="Arial"/>
               </a:rPr>
-              <a:t>MW, C, MGD</a:t>
+              <a:t>size, dry/wet C</a:t>
             </a:r>
           </a:p>
           <a:p xmlns:a="http://schemas.openxmlformats.org/drawingml/2006/main">
@@ -3520,7 +3599,7 @@
                 <a:ea typeface="Arial"/>
                 <a:cs typeface="Arial"/>
               </a:rPr>
-              <a:t>PDSI + season</a:t>
+              <a:t>flow, PDSI, season</a:t>
             </a:r>
           </a:p>
         </p:txBody>
@@ -3530,7 +3609,7 @@
           <p:cNvPr id="12" name="">
             <a:extLst xmlns:a="http://schemas.openxmlformats.org/drawingml/2006/main">
               <a:ext uri="{FF2B5EF4-FFF2-40B4-BE49-F238E27FC236}">
-                <a16:creationId xmlns:a16="http://schemas.microsoft.com/office/drawing/2014/main" id="{7BEDEC60-C531-44AE-A6E3-D4C704DAAE82}"/>
+                <a16:creationId xmlns:a16="http://schemas.microsoft.com/office/drawing/2014/main" id="{1304B4EE-FCC1-4EF3-AA8D-257C5CEC8556}"/>
               </a:ext>
             </a:extLst>
           </p:cNvPr>
@@ -3542,7 +3621,7 @@
         <p:spPr>
           <a:xfrm xmlns:a="http://schemas.openxmlformats.org/drawingml/2006/main">
             <a:off x="5095875" y="2257425"/>
-            <a:ext cx="1857375" cy="1104900"/>
+            <a:ext cx="1857375" cy="1238250"/>
           </a:xfrm>
           <a:prstGeom xmlns:a="http://schemas.openxmlformats.org/drawingml/2006/main" prst="rect">
             <a:avLst/>
@@ -3562,7 +3641,7 @@
           <p:cNvPr id="13" name="">
             <a:extLst xmlns:a="http://schemas.openxmlformats.org/drawingml/2006/main">
               <a:ext uri="{FF2B5EF4-FFF2-40B4-BE49-F238E27FC236}">
-                <a16:creationId xmlns:a16="http://schemas.microsoft.com/office/drawing/2014/main" id="{DE3A569E-3E29-4E42-BAEE-E7D7ADCE2C64}"/>
+                <a16:creationId xmlns:a16="http://schemas.microsoft.com/office/drawing/2014/main" id="{0F367BF2-1319-4768-AFC1-B4C62EE9BABE}"/>
               </a:ext>
             </a:extLst>
           </p:cNvPr>
@@ -3609,7 +3688,7 @@
                 <a:ea typeface="Arial"/>
                 <a:cs typeface="Arial"/>
               </a:rPr>
-              <a:t>Regressor</a:t>
+              <a:t>AI model</a:t>
             </a:r>
           </a:p>
         </p:txBody>
@@ -3619,19 +3698,19 @@
           <p:cNvPr id="14" name="">
             <a:extLst xmlns:a="http://schemas.openxmlformats.org/drawingml/2006/main">
               <a:ext uri="{FF2B5EF4-FFF2-40B4-BE49-F238E27FC236}">
-                <a16:creationId xmlns:a16="http://schemas.microsoft.com/office/drawing/2014/main" id="{EE4A1179-4F71-46C4-B66D-5301A4BFDEC2}"/>
-              </a:ext>
-            </a:extLst>
-          </p:cNvPr>
-          <p:cNvSpPr>
-            <a:spLocks xmlns:a="http://schemas.openxmlformats.org/drawingml/2006/main" noGrp="1"/>
-          </p:cNvSpPr>
-          <p:nvPr/>
-        </p:nvSpPr>
-        <p:spPr>
-          <a:xfrm xmlns:a="http://schemas.openxmlformats.org/drawingml/2006/main">
-            <a:off x="5191125" y="2743200"/>
-            <a:ext cx="1685925" cy="619125"/>
+                <a16:creationId xmlns:a16="http://schemas.microsoft.com/office/drawing/2014/main" id="{0BDFB15F-4436-4E01-B75C-0F6164FB18E6}"/>
+              </a:ext>
+            </a:extLst>
+          </p:cNvPr>
+          <p:cNvSpPr>
+            <a:spLocks xmlns:a="http://schemas.openxmlformats.org/drawingml/2006/main" noGrp="1"/>
+          </p:cNvSpPr>
+          <p:nvPr/>
+        </p:nvSpPr>
+        <p:spPr>
+          <a:xfrm xmlns:a="http://schemas.openxmlformats.org/drawingml/2006/main">
+            <a:off x="5191125" y="2686050"/>
+            <a:ext cx="1685925" cy="800100"/>
           </a:xfrm>
           <a:prstGeom xmlns:a="http://schemas.openxmlformats.org/drawingml/2006/main" prst="rect">
             <a:avLst/>
@@ -3689,7 +3768,7 @@
                 <a:ea typeface="Arial"/>
                 <a:cs typeface="Arial"/>
               </a:rPr>
-              <a:t>learned trees</a:t>
+              <a:t>predict a number</a:t>
             </a:r>
           </a:p>
         </p:txBody>
@@ -3699,7 +3778,7 @@
           <p:cNvPr id="15" name="">
             <a:extLst xmlns:a="http://schemas.openxmlformats.org/drawingml/2006/main">
               <a:ext uri="{FF2B5EF4-FFF2-40B4-BE49-F238E27FC236}">
-                <a16:creationId xmlns:a16="http://schemas.microsoft.com/office/drawing/2014/main" id="{23917948-B730-492B-93D9-07FD832DF151}"/>
+                <a16:creationId xmlns:a16="http://schemas.microsoft.com/office/drawing/2014/main" id="{6A6BBC0E-258A-49C6-A0EE-8A24EA1EC93D}"/>
               </a:ext>
             </a:extLst>
           </p:cNvPr>
@@ -3711,7 +3790,7 @@
         <p:spPr>
           <a:xfrm xmlns:a="http://schemas.openxmlformats.org/drawingml/2006/main">
             <a:off x="7334250" y="2257425"/>
-            <a:ext cx="1857375" cy="1104900"/>
+            <a:ext cx="1857375" cy="1238250"/>
           </a:xfrm>
           <a:prstGeom xmlns:a="http://schemas.openxmlformats.org/drawingml/2006/main" prst="rect">
             <a:avLst/>
@@ -3731,7 +3810,7 @@
           <p:cNvPr id="16" name="">
             <a:extLst xmlns:a="http://schemas.openxmlformats.org/drawingml/2006/main">
               <a:ext uri="{FF2B5EF4-FFF2-40B4-BE49-F238E27FC236}">
-                <a16:creationId xmlns:a16="http://schemas.microsoft.com/office/drawing/2014/main" id="{579493B6-59C2-443B-AE9E-A3520AE92777}"/>
+                <a16:creationId xmlns:a16="http://schemas.microsoft.com/office/drawing/2014/main" id="{434226B6-4245-41A9-84EB-7B04DF74A497}"/>
               </a:ext>
             </a:extLst>
           </p:cNvPr>
@@ -3778,7 +3857,7 @@
                 <a:ea typeface="Arial"/>
                 <a:cs typeface="Arial"/>
               </a:rPr>
-              <a:t>Thermal rules</a:t>
+              <a:t>Heat rules</a:t>
             </a:r>
           </a:p>
         </p:txBody>
@@ -3788,19 +3867,19 @@
           <p:cNvPr id="17" name="">
             <a:extLst xmlns:a="http://schemas.openxmlformats.org/drawingml/2006/main">
               <a:ext uri="{FF2B5EF4-FFF2-40B4-BE49-F238E27FC236}">
-                <a16:creationId xmlns:a16="http://schemas.microsoft.com/office/drawing/2014/main" id="{26099714-5C8C-4A7D-A8FA-C275DD026C92}"/>
-              </a:ext>
-            </a:extLst>
-          </p:cNvPr>
-          <p:cNvSpPr>
-            <a:spLocks xmlns:a="http://schemas.openxmlformats.org/drawingml/2006/main" noGrp="1"/>
-          </p:cNvSpPr>
-          <p:nvPr/>
-        </p:nvSpPr>
-        <p:spPr>
-          <a:xfrm xmlns:a="http://schemas.openxmlformats.org/drawingml/2006/main">
-            <a:off x="7429500" y="2743200"/>
-            <a:ext cx="1685925" cy="619125"/>
+                <a16:creationId xmlns:a16="http://schemas.microsoft.com/office/drawing/2014/main" id="{EECD323E-B175-4B5B-9D37-5FB7C8A4B8D4}"/>
+              </a:ext>
+            </a:extLst>
+          </p:cNvPr>
+          <p:cNvSpPr>
+            <a:spLocks xmlns:a="http://schemas.openxmlformats.org/drawingml/2006/main" noGrp="1"/>
+          </p:cNvSpPr>
+          <p:nvPr/>
+        </p:nvSpPr>
+        <p:spPr>
+          <a:xfrm xmlns:a="http://schemas.openxmlformats.org/drawingml/2006/main">
+            <a:off x="7429500" y="2686050"/>
+            <a:ext cx="1685925" cy="800100"/>
           </a:xfrm>
           <a:prstGeom xmlns:a="http://schemas.openxmlformats.org/drawingml/2006/main" prst="rect">
             <a:avLst/>
@@ -3835,7 +3914,7 @@
                 <a:ea typeface="Arial"/>
                 <a:cs typeface="Arial"/>
               </a:rPr>
-              <a:t>clip + flag</a:t>
+              <a:t>size + weather</a:t>
             </a:r>
           </a:p>
           <a:p xmlns:a="http://schemas.openxmlformats.org/drawingml/2006/main">
@@ -3858,7 +3937,7 @@
                 <a:ea typeface="Arial"/>
                 <a:cs typeface="Arial"/>
               </a:rPr>
-              <a:t>capacity/ambient</a:t>
+              <a:t>limits + warnings</a:t>
             </a:r>
           </a:p>
         </p:txBody>
@@ -3868,7 +3947,7 @@
           <p:cNvPr id="18" name="">
             <a:extLst xmlns:a="http://schemas.openxmlformats.org/drawingml/2006/main">
               <a:ext uri="{FF2B5EF4-FFF2-40B4-BE49-F238E27FC236}">
-                <a16:creationId xmlns:a16="http://schemas.microsoft.com/office/drawing/2014/main" id="{A417A775-167A-400C-8225-29DB4AB4A8C8}"/>
+                <a16:creationId xmlns:a16="http://schemas.microsoft.com/office/drawing/2014/main" id="{F1CA427A-0973-47C8-8391-11F37FEACCEC}"/>
               </a:ext>
             </a:extLst>
           </p:cNvPr>
@@ -3880,7 +3959,7 @@
         <p:spPr>
           <a:xfrm xmlns:a="http://schemas.openxmlformats.org/drawingml/2006/main">
             <a:off x="9572625" y="2257425"/>
-            <a:ext cx="1857375" cy="1104900"/>
+            <a:ext cx="1857375" cy="1238250"/>
           </a:xfrm>
           <a:prstGeom xmlns:a="http://schemas.openxmlformats.org/drawingml/2006/main" prst="rect">
             <a:avLst/>
@@ -3900,7 +3979,7 @@
           <p:cNvPr id="19" name="">
             <a:extLst xmlns:a="http://schemas.openxmlformats.org/drawingml/2006/main">
               <a:ext uri="{FF2B5EF4-FFF2-40B4-BE49-F238E27FC236}">
-                <a16:creationId xmlns:a16="http://schemas.microsoft.com/office/drawing/2014/main" id="{C88E6251-43BD-488C-A6F3-5959E1E21B0C}"/>
+                <a16:creationId xmlns:a16="http://schemas.microsoft.com/office/drawing/2014/main" id="{01407CFB-26E9-4506-B4BA-9B35E6E4A380}"/>
               </a:ext>
             </a:extLst>
           </p:cNvPr>
@@ -3947,7 +4026,7 @@
                 <a:ea typeface="Arial"/>
                 <a:cs typeface="Arial"/>
               </a:rPr>
-              <a:t>Forecast</a:t>
+              <a:t>Response</a:t>
             </a:r>
           </a:p>
         </p:txBody>
@@ -3957,19 +4036,19 @@
           <p:cNvPr id="20" name="">
             <a:extLst xmlns:a="http://schemas.openxmlformats.org/drawingml/2006/main">
               <a:ext uri="{FF2B5EF4-FFF2-40B4-BE49-F238E27FC236}">
-                <a16:creationId xmlns:a16="http://schemas.microsoft.com/office/drawing/2014/main" id="{693C38AF-AFEB-4F5E-BB2E-BA49807CBA1C}"/>
-              </a:ext>
-            </a:extLst>
-          </p:cNvPr>
-          <p:cNvSpPr>
-            <a:spLocks xmlns:a="http://schemas.openxmlformats.org/drawingml/2006/main" noGrp="1"/>
-          </p:cNvSpPr>
-          <p:nvPr/>
-        </p:nvSpPr>
-        <p:spPr>
-          <a:xfrm xmlns:a="http://schemas.openxmlformats.org/drawingml/2006/main">
-            <a:off x="9667875" y="2743200"/>
-            <a:ext cx="1685925" cy="619125"/>
+                <a16:creationId xmlns:a16="http://schemas.microsoft.com/office/drawing/2014/main" id="{F61A1735-1A39-4F5F-9574-30561501F70B}"/>
+              </a:ext>
+            </a:extLst>
+          </p:cNvPr>
+          <p:cNvSpPr>
+            <a:spLocks xmlns:a="http://schemas.openxmlformats.org/drawingml/2006/main" noGrp="1"/>
+          </p:cNvSpPr>
+          <p:nvPr/>
+        </p:nvSpPr>
+        <p:spPr>
+          <a:xfrm xmlns:a="http://schemas.openxmlformats.org/drawingml/2006/main">
+            <a:off x="9667875" y="2686050"/>
+            <a:ext cx="1685925" cy="800100"/>
           </a:xfrm>
           <a:prstGeom xmlns:a="http://schemas.openxmlformats.org/drawingml/2006/main" prst="rect">
             <a:avLst/>
@@ -4004,7 +4083,7 @@
                 <a:ea typeface="Arial"/>
                 <a:cs typeface="Arial"/>
               </a:rPr>
-              <a:t>MGD + interval</a:t>
+              <a:t>MGD + range</a:t>
             </a:r>
           </a:p>
           <a:p xmlns:a="http://schemas.openxmlformats.org/drawingml/2006/main">
@@ -4027,7 +4106,7 @@
                 <a:ea typeface="Arial"/>
                 <a:cs typeface="Arial"/>
               </a:rPr>
-              <a:t>bounds + flags</a:t>
+              <a:t>limits + warnings</a:t>
             </a:r>
           </a:p>
         </p:txBody>
@@ -4037,7 +4116,7 @@
           <p:cNvPr id="21" name="">
             <a:extLst xmlns:a="http://schemas.openxmlformats.org/drawingml/2006/main">
               <a:ext uri="{FF2B5EF4-FFF2-40B4-BE49-F238E27FC236}">
-                <a16:creationId xmlns:a16="http://schemas.microsoft.com/office/drawing/2014/main" id="{27707879-210E-4C33-90F2-9EFCBD549AB1}"/>
+                <a16:creationId xmlns:a16="http://schemas.microsoft.com/office/drawing/2014/main" id="{805C3F17-C517-47A4-8216-6DD8DDEF914C}"/>
               </a:ext>
             </a:extLst>
           </p:cNvPr>
@@ -4049,7 +4128,7 @@
         <p:spPr>
           <a:xfrm xmlns:a="http://schemas.openxmlformats.org/drawingml/2006/main">
             <a:off x="619125" y="3838575"/>
-            <a:ext cx="1857375" cy="1104900"/>
+            <a:ext cx="1857375" cy="1238250"/>
           </a:xfrm>
           <a:prstGeom xmlns:a="http://schemas.openxmlformats.org/drawingml/2006/main" prst="rect">
             <a:avLst/>
@@ -4069,7 +4148,7 @@
           <p:cNvPr id="22" name="">
             <a:extLst xmlns:a="http://schemas.openxmlformats.org/drawingml/2006/main">
               <a:ext uri="{FF2B5EF4-FFF2-40B4-BE49-F238E27FC236}">
-                <a16:creationId xmlns:a16="http://schemas.microsoft.com/office/drawing/2014/main" id="{97145F8F-583D-4DE3-B99E-E948936A5F02}"/>
+                <a16:creationId xmlns:a16="http://schemas.microsoft.com/office/drawing/2014/main" id="{37E78055-85DA-4922-9000-109915969775}"/>
               </a:ext>
             </a:extLst>
           </p:cNvPr>
@@ -4126,19 +4205,19 @@
           <p:cNvPr id="23" name="">
             <a:extLst xmlns:a="http://schemas.openxmlformats.org/drawingml/2006/main">
               <a:ext uri="{FF2B5EF4-FFF2-40B4-BE49-F238E27FC236}">
-                <a16:creationId xmlns:a16="http://schemas.microsoft.com/office/drawing/2014/main" id="{89D9F77C-9145-4E09-905D-7DC0D74294B8}"/>
-              </a:ext>
-            </a:extLst>
-          </p:cNvPr>
-          <p:cNvSpPr>
-            <a:spLocks xmlns:a="http://schemas.openxmlformats.org/drawingml/2006/main" noGrp="1"/>
-          </p:cNvSpPr>
-          <p:nvPr/>
-        </p:nvSpPr>
-        <p:spPr>
-          <a:xfrm xmlns:a="http://schemas.openxmlformats.org/drawingml/2006/main">
-            <a:off x="714375" y="4324350"/>
-            <a:ext cx="1685925" cy="619125"/>
+                <a16:creationId xmlns:a16="http://schemas.microsoft.com/office/drawing/2014/main" id="{63D47467-401F-483E-B967-40DD38739819}"/>
+              </a:ext>
+            </a:extLst>
+          </p:cNvPr>
+          <p:cNvSpPr>
+            <a:spLocks xmlns:a="http://schemas.openxmlformats.org/drawingml/2006/main" noGrp="1"/>
+          </p:cNvSpPr>
+          <p:nvPr/>
+        </p:nvSpPr>
+        <p:spPr>
+          <a:xfrm xmlns:a="http://schemas.openxmlformats.org/drawingml/2006/main">
+            <a:off x="714375" y="4267200"/>
+            <a:ext cx="1685925" cy="800100"/>
           </a:xfrm>
           <a:prstGeom xmlns:a="http://schemas.openxmlformats.org/drawingml/2006/main" prst="rect">
             <a:avLst/>
@@ -4196,7 +4275,7 @@
                 <a:ea typeface="Arial"/>
                 <a:cs typeface="Arial"/>
               </a:rPr>
-              <a:t>exact excerpt</a:t>
+              <a:t>original words</a:t>
             </a:r>
           </a:p>
         </p:txBody>
@@ -4206,7 +4285,7 @@
           <p:cNvPr id="24" name="">
             <a:extLst xmlns:a="http://schemas.openxmlformats.org/drawingml/2006/main">
               <a:ext uri="{FF2B5EF4-FFF2-40B4-BE49-F238E27FC236}">
-                <a16:creationId xmlns:a16="http://schemas.microsoft.com/office/drawing/2014/main" id="{2E3E7D94-56BB-49AC-99C9-4A68C6948F58}"/>
+                <a16:creationId xmlns:a16="http://schemas.microsoft.com/office/drawing/2014/main" id="{1B47EC90-F76D-4301-8B34-6389BAB297EC}"/>
               </a:ext>
             </a:extLst>
           </p:cNvPr>
@@ -4218,7 +4297,7 @@
         <p:spPr>
           <a:xfrm xmlns:a="http://schemas.openxmlformats.org/drawingml/2006/main">
             <a:off x="2857500" y="3838575"/>
-            <a:ext cx="1857375" cy="1104900"/>
+            <a:ext cx="1857375" cy="1238250"/>
           </a:xfrm>
           <a:prstGeom xmlns:a="http://schemas.openxmlformats.org/drawingml/2006/main" prst="rect">
             <a:avLst/>
@@ -4238,7 +4317,7 @@
           <p:cNvPr id="25" name="">
             <a:extLst xmlns:a="http://schemas.openxmlformats.org/drawingml/2006/main">
               <a:ext uri="{FF2B5EF4-FFF2-40B4-BE49-F238E27FC236}">
-                <a16:creationId xmlns:a16="http://schemas.microsoft.com/office/drawing/2014/main" id="{65A11A51-EC63-4242-A83E-4CE18E652530}"/>
+                <a16:creationId xmlns:a16="http://schemas.microsoft.com/office/drawing/2014/main" id="{E575477E-3F18-43BB-85DC-45AD3420B715}"/>
               </a:ext>
             </a:extLst>
           </p:cNvPr>
@@ -4285,7 +4364,7 @@
                 <a:ea typeface="Arial"/>
                 <a:cs typeface="Arial"/>
               </a:rPr>
-              <a:t>Metadata</a:t>
+              <a:t>Doc info</a:t>
             </a:r>
           </a:p>
         </p:txBody>
@@ -4295,19 +4374,19 @@
           <p:cNvPr id="26" name="">
             <a:extLst xmlns:a="http://schemas.openxmlformats.org/drawingml/2006/main">
               <a:ext uri="{FF2B5EF4-FFF2-40B4-BE49-F238E27FC236}">
-                <a16:creationId xmlns:a16="http://schemas.microsoft.com/office/drawing/2014/main" id="{E768CD77-6976-4AE8-B8EF-E3DBC4D87E1F}"/>
-              </a:ext>
-            </a:extLst>
-          </p:cNvPr>
-          <p:cNvSpPr>
-            <a:spLocks xmlns:a="http://schemas.openxmlformats.org/drawingml/2006/main" noGrp="1"/>
-          </p:cNvSpPr>
-          <p:nvPr/>
-        </p:nvSpPr>
-        <p:spPr>
-          <a:xfrm xmlns:a="http://schemas.openxmlformats.org/drawingml/2006/main">
-            <a:off x="2952750" y="4324350"/>
-            <a:ext cx="1685925" cy="619125"/>
+                <a16:creationId xmlns:a16="http://schemas.microsoft.com/office/drawing/2014/main" id="{8D6630D9-3B3F-4FBF-898F-8B458579FF30}"/>
+              </a:ext>
+            </a:extLst>
+          </p:cNvPr>
+          <p:cNvSpPr>
+            <a:spLocks xmlns:a="http://schemas.openxmlformats.org/drawingml/2006/main" noGrp="1"/>
+          </p:cNvSpPr>
+          <p:nvPr/>
+        </p:nvSpPr>
+        <p:spPr>
+          <a:xfrm xmlns:a="http://schemas.openxmlformats.org/drawingml/2006/main">
+            <a:off x="2952750" y="4267200"/>
+            <a:ext cx="1685925" cy="800100"/>
           </a:xfrm>
           <a:prstGeom xmlns:a="http://schemas.openxmlformats.org/drawingml/2006/main" prst="rect">
             <a:avLst/>
@@ -4365,7 +4444,7 @@
                 <a:ea typeface="Arial"/>
                 <a:cs typeface="Arial"/>
               </a:rPr>
-              <a:t>identifiers</a:t>
+              <a:t>section IDs</a:t>
             </a:r>
           </a:p>
         </p:txBody>
@@ -4375,7 +4454,7 @@
           <p:cNvPr id="27" name="">
             <a:extLst xmlns:a="http://schemas.openxmlformats.org/drawingml/2006/main">
               <a:ext uri="{FF2B5EF4-FFF2-40B4-BE49-F238E27FC236}">
-                <a16:creationId xmlns:a16="http://schemas.microsoft.com/office/drawing/2014/main" id="{ECC07279-5919-4CF6-BDAD-9C629E921CBC}"/>
+                <a16:creationId xmlns:a16="http://schemas.microsoft.com/office/drawing/2014/main" id="{B87CA46E-D03F-466C-8E29-9E1702C934A3}"/>
               </a:ext>
             </a:extLst>
           </p:cNvPr>
@@ -4387,7 +4466,7 @@
         <p:spPr>
           <a:xfrm xmlns:a="http://schemas.openxmlformats.org/drawingml/2006/main">
             <a:off x="5095875" y="3838575"/>
-            <a:ext cx="1857375" cy="1104900"/>
+            <a:ext cx="1857375" cy="1238250"/>
           </a:xfrm>
           <a:prstGeom xmlns:a="http://schemas.openxmlformats.org/drawingml/2006/main" prst="rect">
             <a:avLst/>
@@ -4407,7 +4486,7 @@
           <p:cNvPr id="28" name="">
             <a:extLst xmlns:a="http://schemas.openxmlformats.org/drawingml/2006/main">
               <a:ext uri="{FF2B5EF4-FFF2-40B4-BE49-F238E27FC236}">
-                <a16:creationId xmlns:a16="http://schemas.microsoft.com/office/drawing/2014/main" id="{1A1D2226-24E6-472F-9032-7FED169C9508}"/>
+                <a16:creationId xmlns:a16="http://schemas.microsoft.com/office/drawing/2014/main" id="{06BED786-B67C-48A1-BFE9-3D999587A274}"/>
               </a:ext>
             </a:extLst>
           </p:cNvPr>
@@ -4454,7 +4533,7 @@
                 <a:ea typeface="Arial"/>
                 <a:cs typeface="Arial"/>
               </a:rPr>
-              <a:t>TF-IDF</a:t>
+              <a:t>Word search</a:t>
             </a:r>
           </a:p>
         </p:txBody>
@@ -4464,19 +4543,19 @@
           <p:cNvPr id="29" name="">
             <a:extLst xmlns:a="http://schemas.openxmlformats.org/drawingml/2006/main">
               <a:ext uri="{FF2B5EF4-FFF2-40B4-BE49-F238E27FC236}">
-                <a16:creationId xmlns:a16="http://schemas.microsoft.com/office/drawing/2014/main" id="{A513B2EE-3FE0-4F84-BCF2-8199678DBADC}"/>
-              </a:ext>
-            </a:extLst>
-          </p:cNvPr>
-          <p:cNvSpPr>
-            <a:spLocks xmlns:a="http://schemas.openxmlformats.org/drawingml/2006/main" noGrp="1"/>
-          </p:cNvSpPr>
-          <p:nvPr/>
-        </p:nvSpPr>
-        <p:spPr>
-          <a:xfrm xmlns:a="http://schemas.openxmlformats.org/drawingml/2006/main">
-            <a:off x="5191125" y="4324350"/>
-            <a:ext cx="1685925" cy="619125"/>
+                <a16:creationId xmlns:a16="http://schemas.microsoft.com/office/drawing/2014/main" id="{5F70B296-8726-479B-8567-6B51A2B108D4}"/>
+              </a:ext>
+            </a:extLst>
+          </p:cNvPr>
+          <p:cNvSpPr>
+            <a:spLocks xmlns:a="http://schemas.openxmlformats.org/drawingml/2006/main" noGrp="1"/>
+          </p:cNvSpPr>
+          <p:nvPr/>
+        </p:nvSpPr>
+        <p:spPr>
+          <a:xfrm xmlns:a="http://schemas.openxmlformats.org/drawingml/2006/main">
+            <a:off x="5191125" y="4267200"/>
+            <a:ext cx="1685925" cy="800100"/>
           </a:xfrm>
           <a:prstGeom xmlns:a="http://schemas.openxmlformats.org/drawingml/2006/main" prst="rect">
             <a:avLst/>
@@ -4511,7 +4590,7 @@
                 <a:ea typeface="Arial"/>
                 <a:cs typeface="Arial"/>
               </a:rPr>
-              <a:t>FAISS ranking</a:t>
+              <a:t>TF-IDF / FAISS</a:t>
             </a:r>
           </a:p>
           <a:p xmlns:a="http://schemas.openxmlformats.org/drawingml/2006/main">
@@ -4534,7 +4613,7 @@
                 <a:ea typeface="Arial"/>
                 <a:cs typeface="Arial"/>
               </a:rPr>
-              <a:t>lexical vectors</a:t>
+              <a:t>rank word matches</a:t>
             </a:r>
           </a:p>
         </p:txBody>
@@ -4544,7 +4623,7 @@
           <p:cNvPr id="30" name="">
             <a:extLst xmlns:a="http://schemas.openxmlformats.org/drawingml/2006/main">
               <a:ext uri="{FF2B5EF4-FFF2-40B4-BE49-F238E27FC236}">
-                <a16:creationId xmlns:a16="http://schemas.microsoft.com/office/drawing/2014/main" id="{EDD501BB-1A27-495B-979C-3D799039EE04}"/>
+                <a16:creationId xmlns:a16="http://schemas.microsoft.com/office/drawing/2014/main" id="{A15C3691-3B17-4CE8-B095-FB9318B5ADAD}"/>
               </a:ext>
             </a:extLst>
           </p:cNvPr>
@@ -4556,7 +4635,7 @@
         <p:spPr>
           <a:xfrm xmlns:a="http://schemas.openxmlformats.org/drawingml/2006/main">
             <a:off x="7334250" y="3838575"/>
-            <a:ext cx="1857375" cy="1104900"/>
+            <a:ext cx="1857375" cy="1238250"/>
           </a:xfrm>
           <a:prstGeom xmlns:a="http://schemas.openxmlformats.org/drawingml/2006/main" prst="rect">
             <a:avLst/>
@@ -4576,7 +4655,7 @@
           <p:cNvPr id="31" name="">
             <a:extLst xmlns:a="http://schemas.openxmlformats.org/drawingml/2006/main">
               <a:ext uri="{FF2B5EF4-FFF2-40B4-BE49-F238E27FC236}">
-                <a16:creationId xmlns:a16="http://schemas.microsoft.com/office/drawing/2014/main" id="{D36D3062-47AB-406E-87DE-64D72D26F895}"/>
+                <a16:creationId xmlns:a16="http://schemas.microsoft.com/office/drawing/2014/main" id="{2A514A05-5FAA-4F83-BF6C-3F8867382442}"/>
               </a:ext>
             </a:extLst>
           </p:cNvPr>
@@ -4623,7 +4702,7 @@
                 <a:ea typeface="Arial"/>
                 <a:cs typeface="Arial"/>
               </a:rPr>
-              <a:t>Geo filter</a:t>
+              <a:t>Location</a:t>
             </a:r>
           </a:p>
         </p:txBody>
@@ -4633,19 +4712,19 @@
           <p:cNvPr id="32" name="">
             <a:extLst xmlns:a="http://schemas.openxmlformats.org/drawingml/2006/main">
               <a:ext uri="{FF2B5EF4-FFF2-40B4-BE49-F238E27FC236}">
-                <a16:creationId xmlns:a16="http://schemas.microsoft.com/office/drawing/2014/main" id="{F131BF72-6075-407A-9D85-F37AC6E25946}"/>
-              </a:ext>
-            </a:extLst>
-          </p:cNvPr>
-          <p:cNvSpPr>
-            <a:spLocks xmlns:a="http://schemas.openxmlformats.org/drawingml/2006/main" noGrp="1"/>
-          </p:cNvSpPr>
-          <p:nvPr/>
-        </p:nvSpPr>
-        <p:spPr>
-          <a:xfrm xmlns:a="http://schemas.openxmlformats.org/drawingml/2006/main">
-            <a:off x="7429500" y="4324350"/>
-            <a:ext cx="1685925" cy="619125"/>
+                <a16:creationId xmlns:a16="http://schemas.microsoft.com/office/drawing/2014/main" id="{C422CE82-3223-4C7C-ABF8-937179ECEB1D}"/>
+              </a:ext>
+            </a:extLst>
+          </p:cNvPr>
+          <p:cNvSpPr>
+            <a:spLocks xmlns:a="http://schemas.openxmlformats.org/drawingml/2006/main" noGrp="1"/>
+          </p:cNvSpPr>
+          <p:nvPr/>
+        </p:nvSpPr>
+        <p:spPr>
+          <a:xfrm xmlns:a="http://schemas.openxmlformats.org/drawingml/2006/main">
+            <a:off x="7429500" y="4267200"/>
+            <a:ext cx="1685925" cy="800100"/>
           </a:xfrm>
           <a:prstGeom xmlns:a="http://schemas.openxmlformats.org/drawingml/2006/main" prst="rect">
             <a:avLst/>
@@ -4680,7 +4759,7 @@
                 <a:ea typeface="Arial"/>
                 <a:cs typeface="Arial"/>
               </a:rPr>
-              <a:t>scope match</a:t>
+              <a:t>HUC or radius</a:t>
             </a:r>
           </a:p>
           <a:p xmlns:a="http://schemas.openxmlformats.org/drawingml/2006/main">
@@ -4703,7 +4782,7 @@
                 <a:ea typeface="Arial"/>
                 <a:cs typeface="Arial"/>
               </a:rPr>
-              <a:t>before top-k</a:t>
+              <a:t>keep eligible k</a:t>
             </a:r>
           </a:p>
         </p:txBody>
@@ -4713,7 +4792,7 @@
           <p:cNvPr id="33" name="">
             <a:extLst xmlns:a="http://schemas.openxmlformats.org/drawingml/2006/main">
               <a:ext uri="{FF2B5EF4-FFF2-40B4-BE49-F238E27FC236}">
-                <a16:creationId xmlns:a16="http://schemas.microsoft.com/office/drawing/2014/main" id="{118230A0-B57F-4E06-8517-3344F1CC53E0}"/>
+                <a16:creationId xmlns:a16="http://schemas.microsoft.com/office/drawing/2014/main" id="{AAD48E17-9517-41D8-A50E-D80974CC5FE3}"/>
               </a:ext>
             </a:extLst>
           </p:cNvPr>
@@ -4725,7 +4804,7 @@
         <p:spPr>
           <a:xfrm xmlns:a="http://schemas.openxmlformats.org/drawingml/2006/main">
             <a:off x="9572625" y="3838575"/>
-            <a:ext cx="1857375" cy="1104900"/>
+            <a:ext cx="1857375" cy="1238250"/>
           </a:xfrm>
           <a:prstGeom xmlns:a="http://schemas.openxmlformats.org/drawingml/2006/main" prst="rect">
             <a:avLst/>
@@ -4745,7 +4824,7 @@
           <p:cNvPr id="34" name="">
             <a:extLst xmlns:a="http://schemas.openxmlformats.org/drawingml/2006/main">
               <a:ext uri="{FF2B5EF4-FFF2-40B4-BE49-F238E27FC236}">
-                <a16:creationId xmlns:a16="http://schemas.microsoft.com/office/drawing/2014/main" id="{DD48176A-5AAA-4734-899E-548D54E75C5E}"/>
+                <a16:creationId xmlns:a16="http://schemas.microsoft.com/office/drawing/2014/main" id="{B92CBC4E-C6B7-44CB-868F-2C47A2D0BA26}"/>
               </a:ext>
             </a:extLst>
           </p:cNvPr>
@@ -4792,7 +4871,7 @@
                 <a:ea typeface="Arial"/>
                 <a:cs typeface="Arial"/>
               </a:rPr>
-              <a:t>Quotations</a:t>
+              <a:t>Quotes</a:t>
             </a:r>
           </a:p>
         </p:txBody>
@@ -4802,19 +4881,19 @@
           <p:cNvPr id="35" name="">
             <a:extLst xmlns:a="http://schemas.openxmlformats.org/drawingml/2006/main">
               <a:ext uri="{FF2B5EF4-FFF2-40B4-BE49-F238E27FC236}">
-                <a16:creationId xmlns:a16="http://schemas.microsoft.com/office/drawing/2014/main" id="{DCC19007-A504-47C6-AF92-8C301516BF9B}"/>
-              </a:ext>
-            </a:extLst>
-          </p:cNvPr>
-          <p:cNvSpPr>
-            <a:spLocks xmlns:a="http://schemas.openxmlformats.org/drawingml/2006/main" noGrp="1"/>
-          </p:cNvSpPr>
-          <p:nvPr/>
-        </p:nvSpPr>
-        <p:spPr>
-          <a:xfrm xmlns:a="http://schemas.openxmlformats.org/drawingml/2006/main">
-            <a:off x="9667875" y="4324350"/>
-            <a:ext cx="1685925" cy="619125"/>
+                <a16:creationId xmlns:a16="http://schemas.microsoft.com/office/drawing/2014/main" id="{226414DA-C797-448F-9D02-A27FF6974D3C}"/>
+              </a:ext>
+            </a:extLst>
+          </p:cNvPr>
+          <p:cNvSpPr>
+            <a:spLocks xmlns:a="http://schemas.openxmlformats.org/drawingml/2006/main" noGrp="1"/>
+          </p:cNvSpPr>
+          <p:nvPr/>
+        </p:nvSpPr>
+        <p:spPr>
+          <a:xfrm xmlns:a="http://schemas.openxmlformats.org/drawingml/2006/main">
+            <a:off x="9667875" y="4267200"/>
+            <a:ext cx="1685925" cy="800100"/>
           </a:xfrm>
           <a:prstGeom xmlns:a="http://schemas.openxmlformats.org/drawingml/2006/main" prst="rect">
             <a:avLst/>
@@ -4872,7 +4951,7 @@
                 <a:ea typeface="Arial"/>
                 <a:cs typeface="Arial"/>
               </a:rPr>
-              <a:t>extractive text</a:t>
+              <a:t>exact quotations</a:t>
             </a:r>
           </a:p>
         </p:txBody>
@@ -4888,7 +4967,7 @@
         </p:nvCxnSpPr>
         <p:spPr>
           <a:xfrm xmlns:a="http://schemas.openxmlformats.org/drawingml/2006/main">
-            <a:off x="2476500" y="2809875"/>
+            <a:off x="2476500" y="2876550"/>
             <a:ext cx="381000" cy="0"/>
           </a:xfrm>
           <a:prstGeom xmlns:a="http://schemas.openxmlformats.org/drawingml/2006/main" prst="straightConnector1">
@@ -4913,7 +4992,7 @@
         </p:nvCxnSpPr>
         <p:spPr>
           <a:xfrm xmlns:a="http://schemas.openxmlformats.org/drawingml/2006/main">
-            <a:off x="4714875" y="2809875"/>
+            <a:off x="4714875" y="2876550"/>
             <a:ext cx="381000" cy="0"/>
           </a:xfrm>
           <a:prstGeom xmlns:a="http://schemas.openxmlformats.org/drawingml/2006/main" prst="straightConnector1">
@@ -4938,7 +5017,7 @@
         </p:nvCxnSpPr>
         <p:spPr>
           <a:xfrm xmlns:a="http://schemas.openxmlformats.org/drawingml/2006/main">
-            <a:off x="6953250" y="2809875"/>
+            <a:off x="6953250" y="2876550"/>
             <a:ext cx="381000" cy="0"/>
           </a:xfrm>
           <a:prstGeom xmlns:a="http://schemas.openxmlformats.org/drawingml/2006/main" prst="straightConnector1">
@@ -4963,7 +5042,7 @@
         </p:nvCxnSpPr>
         <p:spPr>
           <a:xfrm xmlns:a="http://schemas.openxmlformats.org/drawingml/2006/main">
-            <a:off x="9191625" y="2809875"/>
+            <a:off x="9191625" y="2876550"/>
             <a:ext cx="381000" cy="0"/>
           </a:xfrm>
           <a:prstGeom xmlns:a="http://schemas.openxmlformats.org/drawingml/2006/main" prst="straightConnector1">
@@ -4988,7 +5067,7 @@
         </p:nvCxnSpPr>
         <p:spPr>
           <a:xfrm xmlns:a="http://schemas.openxmlformats.org/drawingml/2006/main">
-            <a:off x="2476500" y="4391025"/>
+            <a:off x="2476500" y="4457700"/>
             <a:ext cx="381000" cy="0"/>
           </a:xfrm>
           <a:prstGeom xmlns:a="http://schemas.openxmlformats.org/drawingml/2006/main" prst="straightConnector1">
@@ -5013,7 +5092,7 @@
         </p:nvCxnSpPr>
         <p:spPr>
           <a:xfrm xmlns:a="http://schemas.openxmlformats.org/drawingml/2006/main">
-            <a:off x="4714875" y="4391025"/>
+            <a:off x="4714875" y="4457700"/>
             <a:ext cx="381000" cy="0"/>
           </a:xfrm>
           <a:prstGeom xmlns:a="http://schemas.openxmlformats.org/drawingml/2006/main" prst="straightConnector1">
@@ -5038,7 +5117,7 @@
         </p:nvCxnSpPr>
         <p:spPr>
           <a:xfrm xmlns:a="http://schemas.openxmlformats.org/drawingml/2006/main">
-            <a:off x="6953250" y="4391025"/>
+            <a:off x="6953250" y="4457700"/>
             <a:ext cx="381000" cy="0"/>
           </a:xfrm>
           <a:prstGeom xmlns:a="http://schemas.openxmlformats.org/drawingml/2006/main" prst="straightConnector1">
@@ -5063,7 +5142,7 @@
         </p:nvCxnSpPr>
         <p:spPr>
           <a:xfrm xmlns:a="http://schemas.openxmlformats.org/drawingml/2006/main">
-            <a:off x="9191625" y="4391025"/>
+            <a:off x="9191625" y="4457700"/>
             <a:ext cx="381000" cy="0"/>
           </a:xfrm>
           <a:prstGeom xmlns:a="http://schemas.openxmlformats.org/drawingml/2006/main" prst="straightConnector1">
@@ -5088,8 +5167,8 @@
         </p:nvCxnSpPr>
         <p:spPr>
           <a:xfrm xmlns:a="http://schemas.openxmlformats.org/drawingml/2006/main" flipV="1">
-            <a:off x="10501313" y="3362325"/>
-            <a:ext cx="0" cy="476250"/>
+            <a:off x="10501313" y="3495675"/>
+            <a:ext cx="0" cy="342900"/>
           </a:xfrm>
           <a:prstGeom xmlns:a="http://schemas.openxmlformats.org/drawingml/2006/main" prst="straightConnector1">
             <a:avLst/>
@@ -5107,7 +5186,7 @@
           <p:cNvPr id="45" name="">
             <a:extLst xmlns:a="http://schemas.openxmlformats.org/drawingml/2006/main">
               <a:ext uri="{FF2B5EF4-FFF2-40B4-BE49-F238E27FC236}">
-                <a16:creationId xmlns:a16="http://schemas.microsoft.com/office/drawing/2014/main" id="{20CE05B1-9FEE-41D3-81C4-BFCD52DE0046}"/>
+                <a16:creationId xmlns:a16="http://schemas.microsoft.com/office/drawing/2014/main" id="{D66FA5D0-D5D2-46AD-9A43-DA2E5F0F15E4}"/>
               </a:ext>
             </a:extLst>
           </p:cNvPr>
@@ -5154,7 +5233,7 @@
                 <a:ea typeface="Arial"/>
                 <a:cs typeface="Arial"/>
               </a:rPr>
-              <a:t>Offline: synthetic consumption labels -&gt; chronological train / calibration / test</a:t>
+              <a:t>Before use: train on made-up water use; choose, set ranges, and test by date.</a:t>
             </a:r>
           </a:p>
         </p:txBody>
@@ -5164,7 +5243,7 @@
           <p:cNvPr id="46" name="">
             <a:extLst xmlns:a="http://schemas.openxmlformats.org/drawingml/2006/main">
               <a:ext uri="{FF2B5EF4-FFF2-40B4-BE49-F238E27FC236}">
-                <a16:creationId xmlns:a16="http://schemas.microsoft.com/office/drawing/2014/main" id="{EE10977E-9169-47A1-B57F-BE6289E247DB}"/>
+                <a16:creationId xmlns:a16="http://schemas.microsoft.com/office/drawing/2014/main" id="{41B5F89D-E2B9-48F4-9768-903F488E09B5}"/>
               </a:ext>
             </a:extLst>
           </p:cNvPr>
@@ -5211,7 +5290,7 @@
                 <a:ea typeface="Arial"/>
                 <a:cs typeface="Arial"/>
               </a:rPr>
-              <a:t>Bounds flag injected errors; four geographic retrieval cases pass.</a:t>
+              <a:t>Forced wrong numbers trigger warnings. Four permit-location tests pass.</a:t>
             </a:r>
           </a:p>
         </p:txBody>
@@ -5219,7 +5298,7 @@
     </p:spTree>
     <p:extLst>
       <p:ext uri="{BB962C8B-B14F-4D97-AF65-F5344CB8AC3E}">
-        <p14:creationId xmlns:p14="http://schemas.microsoft.com/office/powerpoint/2010/main" val="1690788109"/>
+        <p14:creationId xmlns:p14="http://schemas.microsoft.com/office/powerpoint/2010/main" val="641603661"/>
       </p:ext>
     </p:extLst>
   </p:cSld>
@@ -5250,7 +5329,7 @@
           <p:cNvPr id="10" name="">
             <a:extLst xmlns:a="http://schemas.openxmlformats.org/drawingml/2006/main">
               <a:ext uri="{FF2B5EF4-FFF2-40B4-BE49-F238E27FC236}">
-                <a16:creationId xmlns:a16="http://schemas.microsoft.com/office/drawing/2014/main" id="{350AC35C-C4D8-4C16-906A-4611034E9265}"/>
+                <a16:creationId xmlns:a16="http://schemas.microsoft.com/office/drawing/2014/main" id="{8AA1D7C3-91EC-4126-8F00-8E9503534921}"/>
               </a:ext>
             </a:extLst>
           </p:cNvPr>
@@ -5307,7 +5386,7 @@
           <p:cNvPr id="2" name="">
             <a:extLst xmlns:a="http://schemas.openxmlformats.org/drawingml/2006/main">
               <a:ext uri="{FF2B5EF4-FFF2-40B4-BE49-F238E27FC236}">
-                <a16:creationId xmlns:a16="http://schemas.microsoft.com/office/drawing/2014/main" id="{FAF74BF9-398F-44F8-89D9-9C17A13327C8}"/>
+                <a16:creationId xmlns:a16="http://schemas.microsoft.com/office/drawing/2014/main" id="{AD7D2D55-8FF0-4200-BED2-61CC038A4DA3}"/>
               </a:ext>
             </a:extLst>
           </p:cNvPr>
@@ -5354,7 +5433,7 @@
                 <a:ea typeface="Arial"/>
                 <a:cs typeface="Arial"/>
               </a:rPr>
-              <a:t>XGBoost reduced error on the synthetic benchmark</a:t>
+              <a:t>XGBoost made smaller errors on our test data</a:t>
             </a:r>
           </a:p>
         </p:txBody>
@@ -5364,7 +5443,7 @@
           <p:cNvPr id="3" name="">
             <a:extLst xmlns:a="http://schemas.openxmlformats.org/drawingml/2006/main">
               <a:ext uri="{FF2B5EF4-FFF2-40B4-BE49-F238E27FC236}">
-                <a16:creationId xmlns:a16="http://schemas.microsoft.com/office/drawing/2014/main" id="{7A464F7B-C380-4328-945E-63B1541395B1}"/>
+                <a16:creationId xmlns:a16="http://schemas.microsoft.com/office/drawing/2014/main" id="{6D9D8A38-572B-4C84-BA7D-884CAC35179F}"/>
               </a:ext>
             </a:extLst>
           </p:cNvPr>
@@ -5411,7 +5490,7 @@
                 <a:ea typeface="Arial"/>
                 <a:cs typeface="Arial"/>
               </a:rPr>
-              <a:t>E1: regression-comparison.csv | 333 test rows per evaporative type | MAE in MGD</a:t>
+              <a:t>E1: regression-comparison.csv | 333 test rows per evaporative type | MGD = million US gallons/day</a:t>
             </a:r>
           </a:p>
         </p:txBody>
@@ -5421,7 +5500,7 @@
           <p:cNvPr id="4" name="">
             <a:extLst xmlns:a="http://schemas.openxmlformats.org/drawingml/2006/main">
               <a:ext uri="{FF2B5EF4-FFF2-40B4-BE49-F238E27FC236}">
-                <a16:creationId xmlns:a16="http://schemas.microsoft.com/office/drawing/2014/main" id="{B75ACBFD-998D-4A6E-AC72-AFA8BB939E2C}"/>
+                <a16:creationId xmlns:a16="http://schemas.microsoft.com/office/drawing/2014/main" id="{38108FA1-E13F-4967-8E29-FE0D44743EBE}"/>
               </a:ext>
             </a:extLst>
           </p:cNvPr>
@@ -5485,7 +5564,7 @@
         </p:xfrm>
         <a:graphic xmlns:a="http://schemas.openxmlformats.org/drawingml/2006/main">
           <a:graphicData uri="http://schemas.openxmlformats.org/drawingml/2006/chart">
-            <c:chart xmlns:r="http://schemas.openxmlformats.org/officeDocument/2006/relationships" xmlns:c="http://schemas.openxmlformats.org/drawingml/2006/chart" r:id="Rc75981fa259f44a4"/>
+            <c:chart xmlns:r="http://schemas.openxmlformats.org/officeDocument/2006/relationships" xmlns:c="http://schemas.openxmlformats.org/drawingml/2006/chart" r:id="Rf6d4ac31fd7d4f43"/>
           </a:graphicData>
         </a:graphic>
       </p:graphicFrame>
@@ -5494,7 +5573,7 @@
           <p:cNvPr id="6" name="">
             <a:extLst xmlns:a="http://schemas.openxmlformats.org/drawingml/2006/main">
               <a:ext uri="{FF2B5EF4-FFF2-40B4-BE49-F238E27FC236}">
-                <a16:creationId xmlns:a16="http://schemas.microsoft.com/office/drawing/2014/main" id="{BF5DA105-B6C7-43F0-9837-DF2B65E789C5}"/>
+                <a16:creationId xmlns:a16="http://schemas.microsoft.com/office/drawing/2014/main" id="{33ED56CB-DD81-47A9-8836-A654E4F03D0A}"/>
               </a:ext>
             </a:extLst>
           </p:cNvPr>
@@ -5541,7 +5620,7 @@
                 <a:ea typeface="Arial"/>
                 <a:cs typeface="Arial"/>
               </a:rPr>
-              <a:t>Adopt</a:t>
+              <a:t>Keep XGBoost</a:t>
             </a:r>
           </a:p>
         </p:txBody>
@@ -5551,7 +5630,7 @@
           <p:cNvPr id="7" name="">
             <a:extLst xmlns:a="http://schemas.openxmlformats.org/drawingml/2006/main">
               <a:ext uri="{FF2B5EF4-FFF2-40B4-BE49-F238E27FC236}">
-                <a16:creationId xmlns:a16="http://schemas.microsoft.com/office/drawing/2014/main" id="{758A2A18-8501-445A-9A72-E1A4A6C3DBC2}"/>
+                <a16:creationId xmlns:a16="http://schemas.microsoft.com/office/drawing/2014/main" id="{26D6E0D5-64BA-409A-AB4B-B2F79C902EC6}"/>
               </a:ext>
             </a:extLst>
           </p:cNvPr>
@@ -5598,7 +5677,7 @@
                 <a:ea typeface="Arial"/>
                 <a:cs typeface="Arial"/>
               </a:rPr>
-              <a:t>Select by calibration RMSE.</a:t>
+              <a:t>Choose with RMSE on</a:t>
             </a:r>
           </a:p>
           <a:p xmlns:a="http://schemas.openxmlformats.org/drawingml/2006/main">
@@ -5621,7 +5700,30 @@
                 <a:ea typeface="Arial"/>
                 <a:cs typeface="Arial"/>
               </a:rPr>
-              <a:t>Keep RF as the baseline.</a:t>
+              <a:t>the middle date group.</a:t>
+            </a:r>
+          </a:p>
+          <a:p xmlns:a="http://schemas.openxmlformats.org/drawingml/2006/main">
+            <a:pPr>
+              <a:defRPr sz="2175" b="0">
+                <a:solidFill>
+                  <a:srgbClr val="142D42"/>
+                </a:solidFill>
+                <a:latin typeface="Arial"/>
+                <a:ea typeface="Arial"/>
+                <a:cs typeface="Arial"/>
+              </a:defRPr>
+            </a:pPr>
+            <a:r>
+              <a:rPr sz="2175" b="0">
+                <a:solidFill>
+                  <a:srgbClr val="142D42"/>
+                </a:solidFill>
+                <a:latin typeface="Arial"/>
+                <a:ea typeface="Arial"/>
+                <a:cs typeface="Arial"/>
+              </a:rPr>
+              <a:t>Keep RF for comparison.</a:t>
             </a:r>
           </a:p>
         </p:txBody>
@@ -5631,7 +5733,7 @@
           <p:cNvPr id="8" name="">
             <a:extLst xmlns:a="http://schemas.openxmlformats.org/drawingml/2006/main">
               <a:ext uri="{FF2B5EF4-FFF2-40B4-BE49-F238E27FC236}">
-                <a16:creationId xmlns:a16="http://schemas.microsoft.com/office/drawing/2014/main" id="{2F600261-3C5B-45F5-99E8-6FE6BFB8CBA4}"/>
+                <a16:creationId xmlns:a16="http://schemas.microsoft.com/office/drawing/2014/main" id="{2650F514-DBDA-403C-949F-E342893F145F}"/>
               </a:ext>
             </a:extLst>
           </p:cNvPr>
@@ -5678,7 +5780,7 @@
                 <a:ea typeface="Arial"/>
                 <a:cs typeface="Arial"/>
               </a:rPr>
-              <a:t>Measured facility labels</a:t>
+              <a:t>Next: measured water</a:t>
             </a:r>
           </a:p>
           <a:p xmlns:a="http://schemas.openxmlformats.org/drawingml/2006/main">
@@ -5701,7 +5803,7 @@
                 <a:ea typeface="Arial"/>
                 <a:cs typeface="Arial"/>
               </a:rPr>
-              <a:t>remain the main gap.</a:t>
+              <a:t>use at real facilities.</a:t>
             </a:r>
           </a:p>
         </p:txBody>
@@ -5711,19 +5813,19 @@
           <p:cNvPr id="9" name="">
             <a:extLst xmlns:a="http://schemas.openxmlformats.org/drawingml/2006/main">
               <a:ext uri="{FF2B5EF4-FFF2-40B4-BE49-F238E27FC236}">
-                <a16:creationId xmlns:a16="http://schemas.microsoft.com/office/drawing/2014/main" id="{0B89E280-5593-44C7-8D9F-AD2B1FA20CDA}"/>
-              </a:ext>
-            </a:extLst>
-          </p:cNvPr>
-          <p:cNvSpPr>
-            <a:spLocks xmlns:a="http://schemas.openxmlformats.org/drawingml/2006/main" noGrp="1"/>
-          </p:cNvSpPr>
-          <p:nvPr/>
-        </p:nvSpPr>
-        <p:spPr>
-          <a:xfrm xmlns:a="http://schemas.openxmlformats.org/drawingml/2006/main">
-            <a:off x="619125" y="5657850"/>
-            <a:ext cx="10858500" cy="457200"/>
+                <a16:creationId xmlns:a16="http://schemas.microsoft.com/office/drawing/2014/main" id="{8AE5931F-D6B1-4BC1-859C-55918F0D517C}"/>
+              </a:ext>
+            </a:extLst>
+          </p:cNvPr>
+          <p:cNvSpPr>
+            <a:spLocks xmlns:a="http://schemas.openxmlformats.org/drawingml/2006/main" noGrp="1"/>
+          </p:cNvSpPr>
+          <p:nvPr/>
+        </p:nvSpPr>
+        <p:spPr>
+          <a:xfrm xmlns:a="http://schemas.openxmlformats.org/drawingml/2006/main">
+            <a:off x="619125" y="5514975"/>
+            <a:ext cx="10858500" cy="619125"/>
           </a:xfrm>
           <a:prstGeom xmlns:a="http://schemas.openxmlformats.org/drawingml/2006/main" prst="rect">
             <a:avLst/>
@@ -5740,25 +5842,48 @@
           <a:lstStyle xmlns:a="http://schemas.openxmlformats.org/drawingml/2006/main"/>
           <a:p xmlns:a="http://schemas.openxmlformats.org/drawingml/2006/main">
             <a:pPr>
-              <a:defRPr sz="1800" b="0">
-                <a:solidFill>
-                  <a:srgbClr val="142D42"/>
-                </a:solidFill>
-                <a:latin typeface="Arial"/>
-                <a:ea typeface="Arial"/>
-                <a:cs typeface="Arial"/>
-              </a:defRPr>
-            </a:pPr>
-            <a:r>
-              <a:rPr sz="1800" b="0">
-                <a:solidFill>
-                  <a:srgbClr val="142D42"/>
-                </a:solidFill>
-                <a:latin typeface="Arial"/>
-                <a:ea typeface="Arial"/>
-                <a:cs typeface="Arial"/>
-              </a:rPr>
-              <a:t>Chronological 60/20/20 dates | Dry air cooling: zero target, undefined R2</a:t>
+              <a:defRPr sz="1725" b="0">
+                <a:solidFill>
+                  <a:srgbClr val="142D42"/>
+                </a:solidFill>
+                <a:latin typeface="Arial"/>
+                <a:ea typeface="Arial"/>
+                <a:cs typeface="Arial"/>
+              </a:defRPr>
+            </a:pPr>
+            <a:r>
+              <a:rPr sz="1725" b="0">
+                <a:solidFill>
+                  <a:srgbClr val="142D42"/>
+                </a:solidFill>
+                <a:latin typeface="Arial"/>
+                <a:ea typeface="Arial"/>
+                <a:cs typeface="Arial"/>
+              </a:rPr>
+              <a:t>Dates: train 60% / choose + set ranges 20% / test 20%</a:t>
+            </a:r>
+          </a:p>
+          <a:p xmlns:a="http://schemas.openxmlformats.org/drawingml/2006/main">
+            <a:pPr>
+              <a:defRPr sz="1725" b="0">
+                <a:solidFill>
+                  <a:srgbClr val="142D42"/>
+                </a:solidFill>
+                <a:latin typeface="Arial"/>
+                <a:ea typeface="Arial"/>
+                <a:cs typeface="Arial"/>
+              </a:defRPr>
+            </a:pPr>
+            <a:r>
+              <a:rPr sz="1725" b="0">
+                <a:solidFill>
+                  <a:srgbClr val="142D42"/>
+                </a:solidFill>
+                <a:latin typeface="Arial"/>
+                <a:ea typeface="Arial"/>
+                <a:cs typeface="Arial"/>
+              </a:rPr>
+              <a:t>Dry air cooling: zero water target; R2 is undefined.</a:t>
             </a:r>
           </a:p>
         </p:txBody>
@@ -5766,7 +5891,7 @@
     </p:spTree>
     <p:extLst>
       <p:ext uri="{BB962C8B-B14F-4D97-AF65-F5344CB8AC3E}">
-        <p14:creationId xmlns:p14="http://schemas.microsoft.com/office/powerpoint/2010/main" val="990821756"/>
+        <p14:creationId xmlns:p14="http://schemas.microsoft.com/office/powerpoint/2010/main" val="1874639382"/>
       </p:ext>
     </p:extLst>
   </p:cSld>
@@ -5797,7 +5922,7 @@
           <p:cNvPr id="10" name="">
             <a:extLst xmlns:a="http://schemas.openxmlformats.org/drawingml/2006/main">
               <a:ext uri="{FF2B5EF4-FFF2-40B4-BE49-F238E27FC236}">
-                <a16:creationId xmlns:a16="http://schemas.microsoft.com/office/drawing/2014/main" id="{9247472D-5C58-4E92-8AC2-4EC51E9ACA76}"/>
+                <a16:creationId xmlns:a16="http://schemas.microsoft.com/office/drawing/2014/main" id="{39AA476A-73E9-4A43-89CE-D4E4FC2C462F}"/>
               </a:ext>
             </a:extLst>
           </p:cNvPr>
@@ -5854,7 +5979,7 @@
           <p:cNvPr id="2" name="">
             <a:extLst xmlns:a="http://schemas.openxmlformats.org/drawingml/2006/main">
               <a:ext uri="{FF2B5EF4-FFF2-40B4-BE49-F238E27FC236}">
-                <a16:creationId xmlns:a16="http://schemas.microsoft.com/office/drawing/2014/main" id="{4278DD30-81D4-4EB4-8E3F-C5BEFF6D4F40}"/>
+                <a16:creationId xmlns:a16="http://schemas.microsoft.com/office/drawing/2014/main" id="{3AF596BE-AB97-4AD7-BFE2-9C7348E8C84D}"/>
               </a:ext>
             </a:extLst>
           </p:cNvPr>
@@ -5901,7 +6026,7 @@
                 <a:ea typeface="Arial"/>
                 <a:cs typeface="Arial"/>
               </a:rPr>
-              <a:t>Correlated donors made drought gaps easy to fill</a:t>
+              <a:t>Similar nearby stations made gaps easier to fill</a:t>
             </a:r>
           </a:p>
         </p:txBody>
@@ -5911,7 +6036,7 @@
           <p:cNvPr id="3" name="">
             <a:extLst xmlns:a="http://schemas.openxmlformats.org/drawingml/2006/main">
               <a:ext uri="{FF2B5EF4-FFF2-40B4-BE49-F238E27FC236}">
-                <a16:creationId xmlns:a16="http://schemas.microsoft.com/office/drawing/2014/main" id="{6ECC74D5-32D1-42B7-87B0-E0503C7C9C0E}"/>
+                <a16:creationId xmlns:a16="http://schemas.microsoft.com/office/drawing/2014/main" id="{11A1E130-26C8-4EBF-A13F-817AD9A82BAD}"/>
               </a:ext>
             </a:extLst>
           </p:cNvPr>
@@ -5958,7 +6083,7 @@
                 <a:ea typeface="Arial"/>
                 <a:cs typeface="Arial"/>
               </a:rPr>
-              <a:t>E2: missingness-summary.csv; biased-donor-diagnostic.csv | Main test: fitted model, synthetic hydrology</a:t>
+              <a:t>E2: missingness-summary.csv; biased-donor-diagnostic.csv | Main test uses trained AI and made-up river data</a:t>
             </a:r>
           </a:p>
         </p:txBody>
@@ -5968,7 +6093,7 @@
           <p:cNvPr id="4" name="">
             <a:extLst xmlns:a="http://schemas.openxmlformats.org/drawingml/2006/main">
               <a:ext uri="{FF2B5EF4-FFF2-40B4-BE49-F238E27FC236}">
-                <a16:creationId xmlns:a16="http://schemas.microsoft.com/office/drawing/2014/main" id="{0492EE63-8D52-41FB-98E8-C422210A5B2B}"/>
+                <a16:creationId xmlns:a16="http://schemas.microsoft.com/office/drawing/2014/main" id="{B45DC02A-A5B4-4342-B51B-E9701F1026F0}"/>
               </a:ext>
             </a:extLst>
           </p:cNvPr>
@@ -6032,7 +6157,7 @@
         </p:xfrm>
         <a:graphic xmlns:a="http://schemas.openxmlformats.org/drawingml/2006/main">
           <a:graphicData uri="http://schemas.openxmlformats.org/drawingml/2006/chart">
-            <c:chart xmlns:r="http://schemas.openxmlformats.org/officeDocument/2006/relationships" xmlns:c="http://schemas.openxmlformats.org/drawingml/2006/chart" r:id="Rc55868dfeb2747e7"/>
+            <c:chart xmlns:r="http://schemas.openxmlformats.org/officeDocument/2006/relationships" xmlns:c="http://schemas.openxmlformats.org/drawingml/2006/chart" r:id="Rfd01fd8c0fa94b9b"/>
           </a:graphicData>
         </a:graphic>
       </p:graphicFrame>
@@ -6041,7 +6166,7 @@
           <p:cNvPr id="6" name="">
             <a:extLst xmlns:a="http://schemas.openxmlformats.org/drawingml/2006/main">
               <a:ext uri="{FF2B5EF4-FFF2-40B4-BE49-F238E27FC236}">
-                <a16:creationId xmlns:a16="http://schemas.microsoft.com/office/drawing/2014/main" id="{F1265422-F52C-4221-AAC2-7D8CD81C1293}"/>
+                <a16:creationId xmlns:a16="http://schemas.microsoft.com/office/drawing/2014/main" id="{A43CA34C-5C87-4941-A6B8-E52920478BE8}"/>
               </a:ext>
             </a:extLst>
           </p:cNvPr>
@@ -6088,7 +6213,7 @@
                 <a:ea typeface="Arial"/>
                 <a:cs typeface="Arial"/>
               </a:rPr>
-              <a:t>100% within tolerance</a:t>
+              <a:t>All main cases passed</a:t>
             </a:r>
           </a:p>
         </p:txBody>
@@ -6098,7 +6223,7 @@
           <p:cNvPr id="7" name="">
             <a:extLst xmlns:a="http://schemas.openxmlformats.org/drawingml/2006/main">
               <a:ext uri="{FF2B5EF4-FFF2-40B4-BE49-F238E27FC236}">
-                <a16:creationId xmlns:a16="http://schemas.microsoft.com/office/drawing/2014/main" id="{9B29CC82-00E8-4CC3-8D06-6082BCDDDA08}"/>
+                <a16:creationId xmlns:a16="http://schemas.microsoft.com/office/drawing/2014/main" id="{7EE19EB8-4864-4764-9DDC-BB758A842C0A}"/>
               </a:ext>
             </a:extLst>
           </p:cNvPr>
@@ -6145,7 +6270,7 @@
                 <a:ea typeface="Arial"/>
                 <a:cs typeface="Arial"/>
               </a:rPr>
-              <a:t>+/-0.05 MGD</a:t>
+              <a:t>Change within +/-0.05 MGD</a:t>
             </a:r>
           </a:p>
           <a:p xmlns:a="http://schemas.openxmlformats.org/drawingml/2006/main">
@@ -6178,7 +6303,7 @@
           <p:cNvPr id="8" name="">
             <a:extLst xmlns:a="http://schemas.openxmlformats.org/drawingml/2006/main">
               <a:ext uri="{FF2B5EF4-FFF2-40B4-BE49-F238E27FC236}">
-                <a16:creationId xmlns:a16="http://schemas.microsoft.com/office/drawing/2014/main" id="{7BD53BA3-609B-46B6-8BCE-60D6347D652B}"/>
+                <a16:creationId xmlns:a16="http://schemas.microsoft.com/office/drawing/2014/main" id="{5AE7652A-6BB3-4658-BD69-0522B25C37C5}"/>
               </a:ext>
             </a:extLst>
           </p:cNvPr>
@@ -6225,7 +6350,7 @@
                 <a:ea typeface="Arial"/>
                 <a:cs typeface="Arial"/>
               </a:rPr>
-              <a:t>Biased-donor diagnostic:</a:t>
+              <a:t>Biased-neighbor test:</a:t>
             </a:r>
           </a:p>
           <a:p xmlns:a="http://schemas.openxmlformats.org/drawingml/2006/main">
@@ -6248,7 +6373,7 @@
                 <a:ea typeface="Arial"/>
                 <a:cs typeface="Arial"/>
               </a:rPr>
-              <a:t>spatial coverage 60.3%</a:t>
+              <a:t>only 60.3% within limits</a:t>
             </a:r>
           </a:p>
         </p:txBody>
@@ -6258,7 +6383,7 @@
           <p:cNvPr id="9" name="">
             <a:extLst xmlns:a="http://schemas.openxmlformats.org/drawingml/2006/main">
               <a:ext uri="{FF2B5EF4-FFF2-40B4-BE49-F238E27FC236}">
-                <a16:creationId xmlns:a16="http://schemas.microsoft.com/office/drawing/2014/main" id="{6CDFFCF9-F3C4-413A-B936-30701A15D161}"/>
+                <a16:creationId xmlns:a16="http://schemas.microsoft.com/office/drawing/2014/main" id="{8EEED59D-C4A9-4759-B710-BE49B60E9816}"/>
               </a:ext>
             </a:extLst>
           </p:cNvPr>
@@ -6305,7 +6430,7 @@
                 <a:ea typeface="Arial"/>
                 <a:cs typeface="Arial"/>
               </a:rPr>
-              <a:t>Modify: validate donors and shared outages; diagnostic uses a separate simple predictor.</a:t>
+              <a:t>Improve: check neighbors and shared outages. The biased test uses a separate simple formula.</a:t>
             </a:r>
           </a:p>
         </p:txBody>
@@ -6313,7 +6438,7 @@
     </p:spTree>
     <p:extLst>
       <p:ext uri="{BB962C8B-B14F-4D97-AF65-F5344CB8AC3E}">
-        <p14:creationId xmlns:p14="http://schemas.microsoft.com/office/powerpoint/2010/main" val="602921208"/>
+        <p14:creationId xmlns:p14="http://schemas.microsoft.com/office/powerpoint/2010/main" val="1672105811"/>
       </p:ext>
     </p:extLst>
   </p:cSld>
@@ -6344,7 +6469,7 @@
           <p:cNvPr id="10" name="">
             <a:extLst xmlns:a="http://schemas.openxmlformats.org/drawingml/2006/main">
               <a:ext uri="{FF2B5EF4-FFF2-40B4-BE49-F238E27FC236}">
-                <a16:creationId xmlns:a16="http://schemas.microsoft.com/office/drawing/2014/main" id="{49A47C0F-EC55-4BE1-8AA7-6FEAFBC27A68}"/>
+                <a16:creationId xmlns:a16="http://schemas.microsoft.com/office/drawing/2014/main" id="{4407A99F-D813-4EF2-B0E7-76F452FEA61A}"/>
               </a:ext>
             </a:extLst>
           </p:cNvPr>
@@ -6401,7 +6526,7 @@
           <p:cNvPr id="2" name="">
             <a:extLst xmlns:a="http://schemas.openxmlformats.org/drawingml/2006/main">
               <a:ext uri="{FF2B5EF4-FFF2-40B4-BE49-F238E27FC236}">
-                <a16:creationId xmlns:a16="http://schemas.microsoft.com/office/drawing/2014/main" id="{58ED60F7-62FF-466F-A372-5F87C45BA87F}"/>
+                <a16:creationId xmlns:a16="http://schemas.microsoft.com/office/drawing/2014/main" id="{3B38BC86-0809-4B20-AB2F-185E4FF6450D}"/>
               </a:ext>
             </a:extLst>
           </p:cNvPr>
@@ -6448,7 +6573,7 @@
                 <a:ea typeface="Arial"/>
                 <a:cs typeface="Arial"/>
               </a:rPr>
-              <a:t>High R2 did not establish 90% interval coverage</a:t>
+              <a:t>The prediction ranges missed our 90% goal</a:t>
             </a:r>
           </a:p>
         </p:txBody>
@@ -6458,7 +6583,7 @@
           <p:cNvPr id="3" name="">
             <a:extLst xmlns:a="http://schemas.openxmlformats.org/drawingml/2006/main">
               <a:ext uri="{FF2B5EF4-FFF2-40B4-BE49-F238E27FC236}">
-                <a16:creationId xmlns:a16="http://schemas.microsoft.com/office/drawing/2014/main" id="{E22D7227-300C-4301-8225-ADE02D8F198C}"/>
+                <a16:creationId xmlns:a16="http://schemas.microsoft.com/office/drawing/2014/main" id="{10A46460-4E1D-42A9-A098-906E2DA790A3}"/>
               </a:ext>
             </a:extLst>
           </p:cNvPr>
@@ -6505,7 +6630,7 @@
                 <a:ea typeface="Arial"/>
                 <a:cs typeface="Arial"/>
               </a:rPr>
-              <a:t>E5: interval-coverage.csv; benchmark.json | Synthetic held-out samples, 333 per model</a:t>
+              <a:t>E5: interval-coverage.csv; benchmark.json | Made-up test values; 333 per model</a:t>
             </a:r>
           </a:p>
         </p:txBody>
@@ -6515,7 +6640,7 @@
           <p:cNvPr id="4" name="">
             <a:extLst xmlns:a="http://schemas.openxmlformats.org/drawingml/2006/main">
               <a:ext uri="{FF2B5EF4-FFF2-40B4-BE49-F238E27FC236}">
-                <a16:creationId xmlns:a16="http://schemas.microsoft.com/office/drawing/2014/main" id="{2BA184F7-C70E-4A55-A666-5B3E8F2B065F}"/>
+                <a16:creationId xmlns:a16="http://schemas.microsoft.com/office/drawing/2014/main" id="{5F42C563-6870-4746-88B8-31387D59CBB7}"/>
               </a:ext>
             </a:extLst>
           </p:cNvPr>
@@ -6579,7 +6704,7 @@
         </p:xfrm>
         <a:graphic xmlns:a="http://schemas.openxmlformats.org/drawingml/2006/main">
           <a:graphicData uri="http://schemas.openxmlformats.org/drawingml/2006/chart">
-            <c:chart xmlns:r="http://schemas.openxmlformats.org/officeDocument/2006/relationships" xmlns:c="http://schemas.openxmlformats.org/drawingml/2006/chart" r:id="R1785d9c3c09740a3"/>
+            <c:chart xmlns:r="http://schemas.openxmlformats.org/officeDocument/2006/relationships" xmlns:c="http://schemas.openxmlformats.org/drawingml/2006/chart" r:id="R3f873a36d6da4540"/>
           </a:graphicData>
         </a:graphic>
       </p:graphicFrame>
@@ -6588,7 +6713,7 @@
           <p:cNvPr id="6" name="">
             <a:extLst xmlns:a="http://schemas.openxmlformats.org/drawingml/2006/main">
               <a:ext uri="{FF2B5EF4-FFF2-40B4-BE49-F238E27FC236}">
-                <a16:creationId xmlns:a16="http://schemas.microsoft.com/office/drawing/2014/main" id="{D1BAA977-0F81-4BF5-A4A7-AE0EAC21E1CB}"/>
+                <a16:creationId xmlns:a16="http://schemas.microsoft.com/office/drawing/2014/main" id="{2F927745-57BB-4DE1-B30D-FD8BE9D913A8}"/>
               </a:ext>
             </a:extLst>
           </p:cNvPr>
@@ -6645,7 +6770,7 @@
           <p:cNvPr id="7" name="">
             <a:extLst xmlns:a="http://schemas.openxmlformats.org/drawingml/2006/main">
               <a:ext uri="{FF2B5EF4-FFF2-40B4-BE49-F238E27FC236}">
-                <a16:creationId xmlns:a16="http://schemas.microsoft.com/office/drawing/2014/main" id="{263BB4FA-0E72-4E54-81AC-8FF164E61B18}"/>
+                <a16:creationId xmlns:a16="http://schemas.microsoft.com/office/drawing/2014/main" id="{0C4C826C-7138-4A3B-AC5C-72615945183F}"/>
               </a:ext>
             </a:extLst>
           </p:cNvPr>
@@ -6715,7 +6840,7 @@
                 <a:ea typeface="Arial"/>
                 <a:cs typeface="Arial"/>
               </a:rPr>
-              <a:t>Coverage misses the</a:t>
+              <a:t>Good fit does not prove</a:t>
             </a:r>
           </a:p>
           <a:p xmlns:a="http://schemas.openxmlformats.org/drawingml/2006/main">
@@ -6738,7 +6863,7 @@
                 <a:ea typeface="Arial"/>
                 <a:cs typeface="Arial"/>
               </a:rPr>
-              <a:t>observed 90% gate.</a:t>
+              <a:t>the range is reliable.</a:t>
             </a:r>
           </a:p>
         </p:txBody>
@@ -6748,19 +6873,19 @@
           <p:cNvPr id="8" name="">
             <a:extLst xmlns:a="http://schemas.openxmlformats.org/drawingml/2006/main">
               <a:ext uri="{FF2B5EF4-FFF2-40B4-BE49-F238E27FC236}">
-                <a16:creationId xmlns:a16="http://schemas.microsoft.com/office/drawing/2014/main" id="{78379844-48FE-4A71-B3D7-5A661FE49126}"/>
-              </a:ext>
-            </a:extLst>
-          </p:cNvPr>
-          <p:cNvSpPr>
-            <a:spLocks xmlns:a="http://schemas.openxmlformats.org/drawingml/2006/main" noGrp="1"/>
-          </p:cNvSpPr>
-          <p:nvPr/>
-        </p:nvSpPr>
-        <p:spPr>
-          <a:xfrm xmlns:a="http://schemas.openxmlformats.org/drawingml/2006/main">
-            <a:off x="8210550" y="4562475"/>
-            <a:ext cx="3286125" cy="933450"/>
+                <a16:creationId xmlns:a16="http://schemas.microsoft.com/office/drawing/2014/main" id="{87A195A5-724B-43DE-AE2C-09B24417571B}"/>
+              </a:ext>
+            </a:extLst>
+          </p:cNvPr>
+          <p:cNvSpPr>
+            <a:spLocks xmlns:a="http://schemas.openxmlformats.org/drawingml/2006/main" noGrp="1"/>
+          </p:cNvSpPr>
+          <p:nvPr/>
+        </p:nvSpPr>
+        <p:spPr>
+          <a:xfrm xmlns:a="http://schemas.openxmlformats.org/drawingml/2006/main">
+            <a:off x="8210550" y="4429125"/>
+            <a:ext cx="3286125" cy="1162050"/>
           </a:xfrm>
           <a:prstGeom xmlns:a="http://schemas.openxmlformats.org/drawingml/2006/main" prst="rect">
             <a:avLst/>
@@ -6795,7 +6920,7 @@
                 <a:ea typeface="Arial"/>
                 <a:cs typeface="Arial"/>
               </a:rPr>
-              <a:t>Modify: separate tuning</a:t>
+              <a:t>Improve: use separate</a:t>
             </a:r>
           </a:p>
           <a:p xmlns:a="http://schemas.openxmlformats.org/drawingml/2006/main">
@@ -6818,7 +6943,30 @@
                 <a:ea typeface="Arial"/>
                 <a:cs typeface="Arial"/>
               </a:rPr>
-              <a:t>and interval calibration.</a:t>
+              <a:t>data to choose models</a:t>
+            </a:r>
+          </a:p>
+          <a:p xmlns:a="http://schemas.openxmlformats.org/drawingml/2006/main">
+            <a:pPr>
+              <a:defRPr sz="2100" b="1">
+                <a:solidFill>
+                  <a:srgbClr val="142D42"/>
+                </a:solidFill>
+                <a:latin typeface="Arial"/>
+                <a:ea typeface="Arial"/>
+                <a:cs typeface="Arial"/>
+              </a:defRPr>
+            </a:pPr>
+            <a:r>
+              <a:rPr sz="2100" b="1">
+                <a:solidFill>
+                  <a:srgbClr val="142D42"/>
+                </a:solidFill>
+                <a:latin typeface="Arial"/>
+                <a:ea typeface="Arial"/>
+                <a:cs typeface="Arial"/>
+              </a:rPr>
+              <a:t>and set ranges.</a:t>
             </a:r>
           </a:p>
         </p:txBody>
@@ -6828,7 +6976,7 @@
           <p:cNvPr id="9" name="">
             <a:extLst xmlns:a="http://schemas.openxmlformats.org/drawingml/2006/main">
               <a:ext uri="{FF2B5EF4-FFF2-40B4-BE49-F238E27FC236}">
-                <a16:creationId xmlns:a16="http://schemas.microsoft.com/office/drawing/2014/main" id="{A5EE7AC5-8516-40F8-A5F5-C38CC78958F3}"/>
+                <a16:creationId xmlns:a16="http://schemas.microsoft.com/office/drawing/2014/main" id="{7F1FD246-E230-44F9-8103-DC76EF15F2AE}"/>
               </a:ext>
             </a:extLst>
           </p:cNvPr>
@@ -6875,7 +7023,7 @@
                 <a:ea typeface="Arial"/>
                 <a:cs typeface="Arial"/>
               </a:rPr>
-              <a:t>Finite samples; no significance test or independently validated coverage guarantee.</a:t>
+              <a:t>Limited samples; no statistical significance test or independently verified coverage guarantee.</a:t>
             </a:r>
           </a:p>
         </p:txBody>
@@ -6883,7 +7031,7 @@
     </p:spTree>
     <p:extLst>
       <p:ext uri="{BB962C8B-B14F-4D97-AF65-F5344CB8AC3E}">
-        <p14:creationId xmlns:p14="http://schemas.microsoft.com/office/powerpoint/2010/main" val="1592249739"/>
+        <p14:creationId xmlns:p14="http://schemas.microsoft.com/office/powerpoint/2010/main" val="1968549873"/>
       </p:ext>
     </p:extLst>
   </p:cSld>
@@ -6914,7 +7062,7 @@
           <p:cNvPr id="13" name="">
             <a:extLst xmlns:a="http://schemas.openxmlformats.org/drawingml/2006/main">
               <a:ext uri="{FF2B5EF4-FFF2-40B4-BE49-F238E27FC236}">
-                <a16:creationId xmlns:a16="http://schemas.microsoft.com/office/drawing/2014/main" id="{3FF2CA0E-3DD2-4F6B-876C-CB9CBCDEDB5C}"/>
+                <a16:creationId xmlns:a16="http://schemas.microsoft.com/office/drawing/2014/main" id="{5DBF0B23-8AD4-4013-8675-ECD8209525F8}"/>
               </a:ext>
             </a:extLst>
           </p:cNvPr>
@@ -6971,7 +7119,7 @@
           <p:cNvPr id="2" name="">
             <a:extLst xmlns:a="http://schemas.openxmlformats.org/drawingml/2006/main">
               <a:ext uri="{FF2B5EF4-FFF2-40B4-BE49-F238E27FC236}">
-                <a16:creationId xmlns:a16="http://schemas.microsoft.com/office/drawing/2014/main" id="{E188B1B3-D313-4F7B-AB40-1855EDF51E85}"/>
+                <a16:creationId xmlns:a16="http://schemas.microsoft.com/office/drawing/2014/main" id="{01300D50-8FEA-46CA-AF08-35D4EC53F826}"/>
               </a:ext>
             </a:extLst>
           </p:cNvPr>
@@ -7018,7 +7166,7 @@
                 <a:ea typeface="Arial"/>
                 <a:cs typeface="Arial"/>
               </a:rPr>
-              <a:t>Next: test measured consumption at an unseen facility</a:t>
+              <a:t>Next: test real water use at a new facility</a:t>
             </a:r>
           </a:p>
         </p:txBody>
@@ -7028,7 +7176,7 @@
           <p:cNvPr id="3" name="">
             <a:extLst xmlns:a="http://schemas.openxmlformats.org/drawingml/2006/main">
               <a:ext uri="{FF2B5EF4-FFF2-40B4-BE49-F238E27FC236}">
-                <a16:creationId xmlns:a16="http://schemas.microsoft.com/office/drawing/2014/main" id="{62550E8B-B418-4E81-8F3F-0E488AC57730}"/>
+                <a16:creationId xmlns:a16="http://schemas.microsoft.com/office/drawing/2014/main" id="{8DFF8C25-F7B8-432D-AED5-5E522E73CB11}"/>
               </a:ext>
             </a:extLst>
           </p:cNvPr>
@@ -7085,7 +7233,7 @@
           <p:cNvPr id="4" name="">
             <a:extLst xmlns:a="http://schemas.openxmlformats.org/drawingml/2006/main">
               <a:ext uri="{FF2B5EF4-FFF2-40B4-BE49-F238E27FC236}">
-                <a16:creationId xmlns:a16="http://schemas.microsoft.com/office/drawing/2014/main" id="{3606378F-8284-4EDB-BD63-945AB8A12F64}"/>
+                <a16:creationId xmlns:a16="http://schemas.microsoft.com/office/drawing/2014/main" id="{2FDB3030-406E-4A21-827B-E6082333FFCA}"/>
               </a:ext>
             </a:extLst>
           </p:cNvPr>
@@ -7142,7 +7290,7 @@
           <p:cNvPr id="5" name="">
             <a:extLst xmlns:a="http://schemas.openxmlformats.org/drawingml/2006/main">
               <a:ext uri="{FF2B5EF4-FFF2-40B4-BE49-F238E27FC236}">
-                <a16:creationId xmlns:a16="http://schemas.microsoft.com/office/drawing/2014/main" id="{0AB520B9-F31D-4E81-8702-00744BD8C65C}"/>
+                <a16:creationId xmlns:a16="http://schemas.microsoft.com/office/drawing/2014/main" id="{BB94E6C4-4265-4428-85D3-BC789ADD2B3F}"/>
               </a:ext>
             </a:extLst>
           </p:cNvPr>
@@ -7171,7 +7319,7 @@
           <a:lstStyle xmlns:a="http://schemas.openxmlformats.org/drawingml/2006/main"/>
           <a:p xmlns:a="http://schemas.openxmlformats.org/drawingml/2006/main">
             <a:pPr>
-              <a:defRPr sz="2325" b="1">
+              <a:defRPr sz="2175" b="1">
                 <a:solidFill>
                   <a:srgbClr val="167D8D"/>
                 </a:solidFill>
@@ -7181,7 +7329,7 @@
               </a:defRPr>
             </a:pPr>
             <a:r>
-              <a:rPr sz="2325" b="1">
+              <a:rPr sz="2175" b="1">
                 <a:solidFill>
                   <a:srgbClr val="167D8D"/>
                 </a:solidFill>
@@ -7189,7 +7337,7 @@
                 <a:ea typeface="Arial"/>
                 <a:cs typeface="Arial"/>
               </a:rPr>
-              <a:t>Adopt</a:t>
+              <a:t>Keep (Adopt)</a:t>
             </a:r>
           </a:p>
         </p:txBody>
@@ -7199,7 +7347,7 @@
           <p:cNvPr id="6" name="">
             <a:extLst xmlns:a="http://schemas.openxmlformats.org/drawingml/2006/main">
               <a:ext uri="{FF2B5EF4-FFF2-40B4-BE49-F238E27FC236}">
-                <a16:creationId xmlns:a16="http://schemas.microsoft.com/office/drawing/2014/main" id="{A2413D4F-794F-48D8-812C-38BDE4604F11}"/>
+                <a16:creationId xmlns:a16="http://schemas.microsoft.com/office/drawing/2014/main" id="{27DDDE7E-4B7C-4DDC-A7CE-36CB379BDF2F}"/>
               </a:ext>
             </a:extLst>
           </p:cNvPr>
@@ -7246,7 +7394,7 @@
                 <a:ea typeface="Arial"/>
                 <a:cs typeface="Arial"/>
               </a:rPr>
-              <a:t>Tree baselines, independent rules, geography-aware quotations</a:t>
+              <a:t>Tree models, physical limits, permit-location checks</a:t>
             </a:r>
           </a:p>
         </p:txBody>
@@ -7256,7 +7404,7 @@
           <p:cNvPr id="7" name="">
             <a:extLst xmlns:a="http://schemas.openxmlformats.org/drawingml/2006/main">
               <a:ext uri="{FF2B5EF4-FFF2-40B4-BE49-F238E27FC236}">
-                <a16:creationId xmlns:a16="http://schemas.microsoft.com/office/drawing/2014/main" id="{6E79793D-EAF8-4F10-9772-782027CF1F76}"/>
+                <a16:creationId xmlns:a16="http://schemas.microsoft.com/office/drawing/2014/main" id="{E4FF9178-FC1F-4811-A05F-E7B3F0D521EF}"/>
               </a:ext>
             </a:extLst>
           </p:cNvPr>
@@ -7268,7 +7416,7 @@
         <p:spPr>
           <a:xfrm xmlns:a="http://schemas.openxmlformats.org/drawingml/2006/main">
             <a:off x="619125" y="2695575"/>
-            <a:ext cx="2000250" cy="438150"/>
+            <a:ext cx="2000250" cy="619125"/>
           </a:xfrm>
           <a:prstGeom xmlns:a="http://schemas.openxmlformats.org/drawingml/2006/main" prst="rect">
             <a:avLst/>
@@ -7285,7 +7433,7 @@
           <a:lstStyle xmlns:a="http://schemas.openxmlformats.org/drawingml/2006/main"/>
           <a:p xmlns:a="http://schemas.openxmlformats.org/drawingml/2006/main">
             <a:pPr>
-              <a:defRPr sz="2325" b="1">
+              <a:defRPr sz="1950" b="1">
                 <a:solidFill>
                   <a:srgbClr val="BD622B"/>
                 </a:solidFill>
@@ -7295,7 +7443,7 @@
               </a:defRPr>
             </a:pPr>
             <a:r>
-              <a:rPr sz="2325" b="1">
+              <a:rPr sz="1950" b="1">
                 <a:solidFill>
                   <a:srgbClr val="BD622B"/>
                 </a:solidFill>
@@ -7303,7 +7451,7 @@
                 <a:ea typeface="Arial"/>
                 <a:cs typeface="Arial"/>
               </a:rPr>
-              <a:t>Modify</a:t>
+              <a:t>Improve (Modify)</a:t>
             </a:r>
           </a:p>
         </p:txBody>
@@ -7313,7 +7461,7 @@
           <p:cNvPr id="8" name="">
             <a:extLst xmlns:a="http://schemas.openxmlformats.org/drawingml/2006/main">
               <a:ext uri="{FF2B5EF4-FFF2-40B4-BE49-F238E27FC236}">
-                <a16:creationId xmlns:a16="http://schemas.microsoft.com/office/drawing/2014/main" id="{B468FAE8-D672-423F-A5CA-851BFCEB4F8C}"/>
+                <a16:creationId xmlns:a16="http://schemas.microsoft.com/office/drawing/2014/main" id="{7D0609C6-E461-49E3-A43F-27D7100E8E5D}"/>
               </a:ext>
             </a:extLst>
           </p:cNvPr>
@@ -7360,7 +7508,7 @@
                 <a:ea typeface="Arial"/>
                 <a:cs typeface="Arial"/>
               </a:rPr>
-              <a:t>Donor validation, shared outages, independent interval calibration</a:t>
+              <a:t>Check neighbors, shared outages, and prediction ranges</a:t>
             </a:r>
           </a:p>
         </p:txBody>
@@ -7370,7 +7518,7 @@
           <p:cNvPr id="9" name="">
             <a:extLst xmlns:a="http://schemas.openxmlformats.org/drawingml/2006/main">
               <a:ext uri="{FF2B5EF4-FFF2-40B4-BE49-F238E27FC236}">
-                <a16:creationId xmlns:a16="http://schemas.microsoft.com/office/drawing/2014/main" id="{A61A3B6E-9D71-455E-BC0E-7470C2FF51DF}"/>
+                <a16:creationId xmlns:a16="http://schemas.microsoft.com/office/drawing/2014/main" id="{87545420-0C29-4B4B-AEA5-40BC00799078}"/>
               </a:ext>
             </a:extLst>
           </p:cNvPr>
@@ -7427,7 +7575,7 @@
           <p:cNvPr id="10" name="">
             <a:extLst xmlns:a="http://schemas.openxmlformats.org/drawingml/2006/main">
               <a:ext uri="{FF2B5EF4-FFF2-40B4-BE49-F238E27FC236}">
-                <a16:creationId xmlns:a16="http://schemas.microsoft.com/office/drawing/2014/main" id="{073E9ECC-75EF-4863-939D-C1D7F1C8FE90}"/>
+                <a16:creationId xmlns:a16="http://schemas.microsoft.com/office/drawing/2014/main" id="{71B13DC1-8330-4D08-BFD8-5DE1C9A45329}"/>
               </a:ext>
             </a:extLst>
           </p:cNvPr>
@@ -7474,7 +7622,7 @@
                 <a:ea typeface="Arial"/>
                 <a:cs typeface="Arial"/>
               </a:rPr>
-              <a:t>Reject R2-as-confidence; defer neural and generative LLM models</a:t>
+              <a:t>R2 is not confidence; wait on neural and generative LLM models</a:t>
             </a:r>
           </a:p>
         </p:txBody>
@@ -7484,7 +7632,7 @@
           <p:cNvPr id="11" name="">
             <a:extLst xmlns:a="http://schemas.openxmlformats.org/drawingml/2006/main">
               <a:ext uri="{FF2B5EF4-FFF2-40B4-BE49-F238E27FC236}">
-                <a16:creationId xmlns:a16="http://schemas.microsoft.com/office/drawing/2014/main" id="{6F21882E-FE29-41D4-AB44-FA9D97159F21}"/>
+                <a16:creationId xmlns:a16="http://schemas.microsoft.com/office/drawing/2014/main" id="{933ABCF6-FA24-4DEE-8D32-9B49CB91828C}"/>
               </a:ext>
             </a:extLst>
           </p:cNvPr>
@@ -7531,7 +7679,7 @@
                 <a:ea typeface="Arial"/>
                 <a:cs typeface="Arial"/>
               </a:rPr>
-              <a:t>Can the constrained model generalize during drought with adequate coverage?</a:t>
+              <a:t>Will it work during drought at an unseen facility, with reliable prediction ranges?</a:t>
             </a:r>
           </a:p>
         </p:txBody>
@@ -7541,7 +7689,7 @@
           <p:cNvPr id="12" name="">
             <a:extLst xmlns:a="http://schemas.openxmlformats.org/drawingml/2006/main">
               <a:ext uri="{FF2B5EF4-FFF2-40B4-BE49-F238E27FC236}">
-                <a16:creationId xmlns:a16="http://schemas.microsoft.com/office/drawing/2014/main" id="{405E722B-9FAC-4DF6-97AD-75CECC41C003}"/>
+                <a16:creationId xmlns:a16="http://schemas.microsoft.com/office/drawing/2014/main" id="{93E00068-4CFF-4C5D-AB56-D61D1602645F}"/>
               </a:ext>
             </a:extLst>
           </p:cNvPr>
@@ -7588,7 +7736,7 @@
                 <a:ea typeface="Arial"/>
                 <a:cs typeface="Arial"/>
               </a:rPr>
-              <a:t>Shaun: code + calibration    Troy: data + drought    Scott: permits + evidence</a:t>
+              <a:t>Shaun: code + ranges    Troy: data + drought    Scott: permits + evidence</a:t>
             </a:r>
           </a:p>
         </p:txBody>
@@ -7596,7 +7744,7 @@
     </p:spTree>
     <p:extLst>
       <p:ext uri="{BB962C8B-B14F-4D97-AF65-F5344CB8AC3E}">
-        <p14:creationId xmlns:p14="http://schemas.microsoft.com/office/powerpoint/2010/main" val="576537790"/>
+        <p14:creationId xmlns:p14="http://schemas.microsoft.com/office/powerpoint/2010/main" val="1072101969"/>
       </p:ext>
     </p:extLst>
   </p:cSld>

</xml_diff>

<commit_message>
Remove purple slide decorations and refresh the A2 package
</commit_message>
<xml_diff>
--- a/docs/a2/review-slides.pptx
+++ b/docs/a2/review-slides.pptx
@@ -2,18 +2,18 @@
 <file path=ppt/presentation.xml><?xml version="1.0" encoding="utf-8"?>
 <p:presentation xmlns:p="http://schemas.openxmlformats.org/presentationml/2006/main">
   <p:sldMasterIdLst>
-    <p:sldMasterId xmlns:r="http://schemas.openxmlformats.org/officeDocument/2006/relationships" id="2147483648" r:id="Rba1ea0080a194399"/>
+    <p:sldMasterId xmlns:r="http://schemas.openxmlformats.org/officeDocument/2006/relationships" id="2147483648" r:id="R1eea82e0c9b14d34"/>
   </p:sldMasterIdLst>
   <p:notesMasterIdLst>
-    <p:notesMasterId xmlns:r="http://schemas.openxmlformats.org/officeDocument/2006/relationships" r:id="R8f70bfb25fef48b6"/>
+    <p:notesMasterId xmlns:r="http://schemas.openxmlformats.org/officeDocument/2006/relationships" r:id="Ra009e59096034d49"/>
   </p:notesMasterIdLst>
   <p:sldIdLst>
-    <p:sldId xmlns:r="http://schemas.openxmlformats.org/officeDocument/2006/relationships" id="256" r:id="R88c93a5934e84d52"/>
-    <p:sldId xmlns:r="http://schemas.openxmlformats.org/officeDocument/2006/relationships" id="257" r:id="R7f75b5b56d5046a8"/>
-    <p:sldId xmlns:r="http://schemas.openxmlformats.org/officeDocument/2006/relationships" id="258" r:id="Rfbd2c2f28e854b74"/>
-    <p:sldId xmlns:r="http://schemas.openxmlformats.org/officeDocument/2006/relationships" id="259" r:id="R634c87b841034f91"/>
-    <p:sldId xmlns:r="http://schemas.openxmlformats.org/officeDocument/2006/relationships" id="260" r:id="R85fa9c3f41c444ee"/>
-    <p:sldId xmlns:r="http://schemas.openxmlformats.org/officeDocument/2006/relationships" id="261" r:id="Rb2113631aab946b3"/>
+    <p:sldId xmlns:r="http://schemas.openxmlformats.org/officeDocument/2006/relationships" id="256" r:id="Rfef2bec8220c4f71"/>
+    <p:sldId xmlns:r="http://schemas.openxmlformats.org/officeDocument/2006/relationships" id="257" r:id="R8ad2ae6874014b8a"/>
+    <p:sldId xmlns:r="http://schemas.openxmlformats.org/officeDocument/2006/relationships" id="258" r:id="R868746eb9e0e4ba6"/>
+    <p:sldId xmlns:r="http://schemas.openxmlformats.org/officeDocument/2006/relationships" id="259" r:id="Ra21edb021a6c4874"/>
+    <p:sldId xmlns:r="http://schemas.openxmlformats.org/officeDocument/2006/relationships" id="260" r:id="R977fd5df35d94217"/>
+    <p:sldId xmlns:r="http://schemas.openxmlformats.org/officeDocument/2006/relationships" id="261" r:id="Ra80df5e162084513"/>
   </p:sldIdLst>
   <p:sldSz cx="12192000" cy="6858000"/>
   <p:notesSz cx="6858000" cy="9144000"/>
@@ -453,13 +453,20 @@
           <a:p xmlns:a="http://schemas.openxmlformats.org/drawingml/2006/main">
             <a:r>
               <a:t>
+Regional framing: ECOllateral is an environmental impact assessment and regional ecosystem forecasting project. Primary question: development demands/cooling/location and seasonal impacts on area municipal reserves and watershed conditions. The cooling model is one pressure component. No regional impact or ecosystem health score is implemented/validated. Source: docs/project-scope.md and user context supplied October 8.</a:t>
+            </a:r>
+          </a:p>
+          <a:p xmlns:a="http://schemas.openxmlformats.org/drawingml/2006/main">
+            <a:r>
+              <a:t>
 Plain-English talk:
-ECOllateral estimates how much water a proposed data center would use for cooling.
-A researcher or planner enters facility size, cooling type, watershed, and month.
-The system returns water use, calculated physical limits, a prediction range, warnings,
-and permit quotations for the location. Water is measured in million gallons per day.
-The local prototype works, but our water-use targets are made-up test data. We have
-not shown accuracy at real facilities yet.</a:t>
+ECOllateral aims to help planners, researchers, and utilities understand how proposed
+development affects an area's municipal water reserves and watershed conditions across
+seasons. The ecosystem and area are the focus. Our prototype connects environmental
+data, a cooling-water pressure model, physical checks, and local permit quotations.
+Cooling is one component test. The regional supply, demand, return-flow, and ecological
+assessment is still planned. Our model targets are made-up data, so we are not claiming
+validated regional impact forecasts yet.</a:t>
             </a:r>
           </a:p>
         </p:txBody>
@@ -535,13 +542,20 @@
           <a:p xmlns:a="http://schemas.openxmlformats.org/drawingml/2006/main">
             <a:r>
               <a:t>
+This map describes current components. Regional balances, ecological flow needs, cumulative demands/returns, verified boundaries, and regional targets remain planned. Current vectors are sparse TF-IDF, not dense learned embeddings. Groundwater depth is not recharge.</a:t>
+            </a:r>
+          </a:p>
+          <a:p xmlns:a="http://schemas.openxmlformats.org/drawingml/2006/main">
+            <a:r>
+              <a:t>
 Plain-English talk:
-The top path handles numbers. Weather, river flow, drought, season, and facility size
-become six inputs. A tree-based AI model predicts water use. Separate engineering
-rules check the number and warn if it needs adjusting. The bottom path handles permit
-text. We search words, check the location, and return original quotations. Tests showed
-the physical limits and four location cases work. No language model calculates the
-water estimate or decides legal compliance.</a:t>
+The diagram shows current components. Six features describe size, weather, flow,
+drought, and season. The target is cooling water use. Trees learn number relationships;
+rules check physical limits. Permit documents keep original words, sources, and location
+metadata. TF-IDF creates word vectors, FAISS ranks matches, and location checks filter
+results. This connects learned numbers, symbolic rules, and text evidence. Four location
+tests pass; forced wrong predictions clip and warn. Quotations add context, without
+calculating risk or deciding compliance.</a:t>
             </a:r>
           </a:p>
         </p:txBody>
@@ -866,17 +880,25 @@
           <a:p xmlns:a="http://schemas.openxmlformats.org/drawingml/2006/main">
             <a:r>
               <a:t>
+Primary next study: observed regional supply/reserves, demands, returns, ecological baselines and unseen-area tests. Facility holdouts remain a supporting component check. Zero-shot LLM, heatwave validation, EIA/EPA ingestion and historical recharge masking are proposals, not completed benchmarks. Troy supports data/grounding; Scott evaluation/interface/failure evidence; Shaun leads coding.</a:t>
+            </a:r>
+          </a:p>
+          <a:p xmlns:a="http://schemas.openxmlformats.org/drawingml/2006/main">
+            <a:r>
+              <a:t>
 Plain-English talk:
-We will keep the tree models, physical limits, and permit location checks. We will
-improve the missing-data tests and how prediction ranges are set. We reject using
-R-squared as confidence, and we will wait on neural or generative language models
-because we have not compared them and they do not solve the missing-label problem.
-Our next question is whether the system works at a real facility it has never seen
-during drought, with enough values inside its prediction range. Shaun leads code
-and separate calibration. Troy checks environmental locations and drought tests.
-Scott checks real permits and prepares the evidence. These supporting roles are
-assigned; we still need to confirm actual completed contributions. The dossier keeps
-the full methods, results, limits, and remaining course steps.</a:t>
+We will keep the tested models, component rules, and location checks. Next, connect
+development pressures to observed area supply, reserves, other demands, returns, and
+ecological flow needs. We must define regional targets and test unseen areas and seasons
+with separate calibration. One cooling-water number cannot represent ecosystem health.
+We also reject R-squared as confidence and unconstrained language-model risk scoring.
+No zero-shot or generative comparison was run. Shaun leads coding and area integration.
+We defer neural/LLM comparisons until measured regional labels exist.
+Troy supports environmental baselines, drought analysis, and document grounding.
+Scott supports safety and interface evaluation, failure analysis, and regional evidence.
+These supporting duties still need completion confirmation. Our next question is whether
+verified area conditions and development demands can explain seasonal reserve and
+watershed impacts in an area not used to build the model.</a:t>
             </a:r>
           </a:p>
         </p:txBody>
@@ -944,7 +966,7 @@
   </p:cSld>
   <p:clrMap bg1="lt1" tx1="dk1" bg2="lt2" tx2="dk2" accent1="accent1" accent2="accent2" accent3="accent3" accent4="accent4" accent5="accent5" accent6="accent6" hlink="hlink" folHlink="folHlink"/>
   <p:sldLayoutIdLst>
-    <p:sldLayoutId xmlns:r="http://schemas.openxmlformats.org/officeDocument/2006/relationships" id="2147483649" r:id="R261c120faaa24699"/>
+    <p:sldLayoutId xmlns:r="http://schemas.openxmlformats.org/officeDocument/2006/relationships" id="2147483649" r:id="Ref711e882c574985"/>
   </p:sldLayoutIdLst>
   <p:txStyles>
     <p:titleStyle>
@@ -2292,62 +2314,10 @@
       </p:grpSpPr>
       <p:sp>
         <p:nvSpPr>
-          <p:cNvPr id="16" name="">
-            <a:extLst xmlns:a="http://schemas.openxmlformats.org/drawingml/2006/main">
-              <a:ext uri="{FF2B5EF4-FFF2-40B4-BE49-F238E27FC236}">
-                <a16:creationId xmlns:a16="http://schemas.microsoft.com/office/drawing/2014/main" id="{D7D8184C-3F51-4C2B-B461-2FE691418A1A}"/>
-              </a:ext>
-            </a:extLst>
-          </p:cNvPr>
-          <p:cNvSpPr>
-            <a:spLocks xmlns:a="http://schemas.openxmlformats.org/drawingml/2006/main" noGrp="1"/>
-          </p:cNvSpPr>
-          <p:nvPr/>
-        </p:nvSpPr>
-        <p:spPr>
-          <a:xfrm xmlns:a="http://schemas.openxmlformats.org/drawingml/2006/main">
-            <a:off x="809625" y="476250"/>
-            <a:ext cx="7143750" cy="5334000"/>
-          </a:xfrm>
-          <a:prstGeom xmlns:a="http://schemas.openxmlformats.org/drawingml/2006/main" prst="ellipse">
-            <a:avLst/>
-          </a:prstGeom>
-          <a:gradFill xmlns:a="http://schemas.openxmlformats.org/drawingml/2006/main">
-            <a:gsLst>
-              <a:gs pos="0">
-                <a:srgbClr val="9382FF">
-                  <a:alpha val="45000"/>
-                </a:srgbClr>
-              </a:gs>
-              <a:gs pos="35000">
-                <a:srgbClr val="9382FF">
-                  <a:alpha val="18000"/>
-                </a:srgbClr>
-              </a:gs>
-              <a:gs pos="65000">
-                <a:srgbClr val="9382FF">
-                  <a:alpha val="4000"/>
-                </a:srgbClr>
-              </a:gs>
-              <a:gs pos="100000">
-                <a:srgbClr val="9382FF">
-                  <a:alpha val="0"/>
-                </a:srgbClr>
-              </a:gs>
-            </a:gsLst>
-            <a:path path="shape"/>
-          </a:gradFill>
-          <a:ln xmlns:a="http://schemas.openxmlformats.org/drawingml/2006/main" w="0">
-            <a:noFill/>
-          </a:ln>
-        </p:spPr>
-      </p:sp>
-      <p:sp>
-        <p:nvSpPr>
-          <p:cNvPr id="2" name="">
-            <a:extLst xmlns:a="http://schemas.openxmlformats.org/drawingml/2006/main">
-              <a:ext uri="{FF2B5EF4-FFF2-40B4-BE49-F238E27FC236}">
-                <a16:creationId xmlns:a16="http://schemas.microsoft.com/office/drawing/2014/main" id="{78FC9026-0CD5-4FE4-BD9B-B264B42DF7EC}"/>
+          <p:cNvPr id="15" name="">
+            <a:extLst xmlns:a="http://schemas.openxmlformats.org/drawingml/2006/main">
+              <a:ext uri="{FF2B5EF4-FFF2-40B4-BE49-F238E27FC236}">
+                <a16:creationId xmlns:a16="http://schemas.microsoft.com/office/drawing/2014/main" id="{0F94B4D9-60CA-4D67-972E-DF79C41B6200}"/>
               </a:ext>
             </a:extLst>
           </p:cNvPr>
@@ -2401,10 +2371,10 @@
       </p:sp>
       <p:sp>
         <p:nvSpPr>
-          <p:cNvPr id="3" name="">
-            <a:extLst xmlns:a="http://schemas.openxmlformats.org/drawingml/2006/main">
-              <a:ext uri="{FF2B5EF4-FFF2-40B4-BE49-F238E27FC236}">
-                <a16:creationId xmlns:a16="http://schemas.microsoft.com/office/drawing/2014/main" id="{8EB301F6-7BA0-429B-BA40-83071B6D1585}"/>
+          <p:cNvPr id="2" name="">
+            <a:extLst xmlns:a="http://schemas.openxmlformats.org/drawingml/2006/main">
+              <a:ext uri="{FF2B5EF4-FFF2-40B4-BE49-F238E27FC236}">
+                <a16:creationId xmlns:a16="http://schemas.microsoft.com/office/drawing/2014/main" id="{238C3142-C4EE-44E1-A691-83FC62A0F338}"/>
               </a:ext>
             </a:extLst>
           </p:cNvPr>
@@ -2431,10 +2401,10 @@
       </p:sp>
       <p:sp>
         <p:nvSpPr>
-          <p:cNvPr id="4" name="">
-            <a:extLst xmlns:a="http://schemas.openxmlformats.org/drawingml/2006/main">
-              <a:ext uri="{FF2B5EF4-FFF2-40B4-BE49-F238E27FC236}">
-                <a16:creationId xmlns:a16="http://schemas.microsoft.com/office/drawing/2014/main" id="{F273208B-1C1F-45CF-8442-B9E8BF9AE664}"/>
+          <p:cNvPr id="3" name="">
+            <a:extLst xmlns:a="http://schemas.openxmlformats.org/drawingml/2006/main">
+              <a:ext uri="{FF2B5EF4-FFF2-40B4-BE49-F238E27FC236}">
+                <a16:creationId xmlns:a16="http://schemas.microsoft.com/office/drawing/2014/main" id="{FE829EDD-71AB-45A0-A742-E1929E50FE31}"/>
               </a:ext>
             </a:extLst>
           </p:cNvPr>
@@ -2481,17 +2451,40 @@
                 <a:ea typeface="Georgia"/>
                 <a:cs typeface="Georgia"/>
               </a:rPr>
-              <a:t>ESTIMATE THE WATER A DATA CENTER USES FOR COOLING</a:t>
-            </a:r>
-          </a:p>
-        </p:txBody>
-      </p:sp>
-      <p:sp>
-        <p:nvSpPr>
-          <p:cNvPr id="5" name="">
-            <a:extLst xmlns:a="http://schemas.openxmlformats.org/drawingml/2006/main">
-              <a:ext uri="{FF2B5EF4-FFF2-40B4-BE49-F238E27FC236}">
-                <a16:creationId xmlns:a16="http://schemas.microsoft.com/office/drawing/2014/main" id="{E4077FC8-6D55-469E-9B10-22AE16C0CCBD}"/>
+              <a:t>PROBLEM &amp; USERS:</a:t>
+            </a:r>
+          </a:p>
+          <a:p xmlns:a="http://schemas.openxmlformats.org/drawingml/2006/main">
+            <a:pPr>
+              <a:defRPr sz="4350" b="0">
+                <a:solidFill>
+                  <a:srgbClr val="111827"/>
+                </a:solidFill>
+                <a:latin typeface="Georgia"/>
+                <a:ea typeface="Georgia"/>
+                <a:cs typeface="Georgia"/>
+              </a:defRPr>
+            </a:pPr>
+            <a:r>
+              <a:rPr sz="4350" b="0">
+                <a:solidFill>
+                  <a:srgbClr val="111827"/>
+                </a:solidFill>
+                <a:latin typeface="Georgia"/>
+                <a:ea typeface="Georgia"/>
+                <a:cs typeface="Georgia"/>
+              </a:rPr>
+              <a:t>ECOSYSTEMS ACROSS AN AREA</a:t>
+            </a:r>
+          </a:p>
+        </p:txBody>
+      </p:sp>
+      <p:sp>
+        <p:nvSpPr>
+          <p:cNvPr id="4" name="">
+            <a:extLst xmlns:a="http://schemas.openxmlformats.org/drawingml/2006/main">
+              <a:ext uri="{FF2B5EF4-FFF2-40B4-BE49-F238E27FC236}">
+                <a16:creationId xmlns:a16="http://schemas.microsoft.com/office/drawing/2014/main" id="{C28A8E67-DA58-414D-B6D0-C6FE1DCC3A07}"/>
               </a:ext>
             </a:extLst>
           </p:cNvPr>
@@ -2538,17 +2531,17 @@
                 <a:ea typeface="Arial"/>
                 <a:cs typeface="Arial"/>
               </a:rPr>
-              <a:t>October 7, 2026 snapshot | Made-up test data; real-facility accuracy still unverified</a:t>
-            </a:r>
-          </a:p>
-        </p:txBody>
-      </p:sp>
-      <p:sp>
-        <p:nvSpPr>
-          <p:cNvPr id="6" name="">
-            <a:extLst xmlns:a="http://schemas.openxmlformats.org/drawingml/2006/main">
-              <a:ext uri="{FF2B5EF4-FFF2-40B4-BE49-F238E27FC236}">
-                <a16:creationId xmlns:a16="http://schemas.microsoft.com/office/drawing/2014/main" id="{2D8ACA29-BFF3-4E17-9C90-21F40878DF5C}"/>
+              <a:t>October 7 component evidence | Synthetic model targets; regional assessment not yet validated</a:t>
+            </a:r>
+          </a:p>
+        </p:txBody>
+      </p:sp>
+      <p:sp>
+        <p:nvSpPr>
+          <p:cNvPr id="5" name="">
+            <a:extLst xmlns:a="http://schemas.openxmlformats.org/drawingml/2006/main">
+              <a:ext uri="{FF2B5EF4-FFF2-40B4-BE49-F238E27FC236}">
+                <a16:creationId xmlns:a16="http://schemas.microsoft.com/office/drawing/2014/main" id="{654286E4-48BD-40BC-8932-C9EE7918E91B}"/>
               </a:ext>
             </a:extLst>
           </p:cNvPr>
@@ -2602,10 +2595,10 @@
       </p:sp>
       <p:sp>
         <p:nvSpPr>
-          <p:cNvPr id="7" name="">
-            <a:extLst xmlns:a="http://schemas.openxmlformats.org/drawingml/2006/main">
-              <a:ext uri="{FF2B5EF4-FFF2-40B4-BE49-F238E27FC236}">
-                <a16:creationId xmlns:a16="http://schemas.microsoft.com/office/drawing/2014/main" id="{DC6CDA4B-C6D3-4002-B179-2EC76DBF6E66}"/>
+          <p:cNvPr id="6" name="">
+            <a:extLst xmlns:a="http://schemas.openxmlformats.org/drawingml/2006/main">
+              <a:ext uri="{FF2B5EF4-FFF2-40B4-BE49-F238E27FC236}">
+                <a16:creationId xmlns:a16="http://schemas.microsoft.com/office/drawing/2014/main" id="{F7F00FA7-1A1E-4205-834E-CB2B4870C13A}"/>
               </a:ext>
             </a:extLst>
           </p:cNvPr>
@@ -2659,22 +2652,22 @@
       </p:sp>
       <p:sp>
         <p:nvSpPr>
-          <p:cNvPr id="8" name="">
-            <a:extLst xmlns:a="http://schemas.openxmlformats.org/drawingml/2006/main">
-              <a:ext uri="{FF2B5EF4-FFF2-40B4-BE49-F238E27FC236}">
-                <a16:creationId xmlns:a16="http://schemas.microsoft.com/office/drawing/2014/main" id="{730438CD-9A06-4BE1-B207-4968BC17D816}"/>
-              </a:ext>
-            </a:extLst>
-          </p:cNvPr>
-          <p:cNvSpPr>
-            <a:spLocks xmlns:a="http://schemas.openxmlformats.org/drawingml/2006/main" noGrp="1"/>
-          </p:cNvSpPr>
-          <p:nvPr/>
-        </p:nvSpPr>
-        <p:spPr>
-          <a:xfrm xmlns:a="http://schemas.openxmlformats.org/drawingml/2006/main">
-            <a:off x="809625" y="3238500"/>
-            <a:ext cx="10477500" cy="409575"/>
+          <p:cNvPr id="7" name="">
+            <a:extLst xmlns:a="http://schemas.openxmlformats.org/drawingml/2006/main">
+              <a:ext uri="{FF2B5EF4-FFF2-40B4-BE49-F238E27FC236}">
+                <a16:creationId xmlns:a16="http://schemas.microsoft.com/office/drawing/2014/main" id="{6E0221C3-5F00-49B5-9B16-3403E3397EAB}"/>
+              </a:ext>
+            </a:extLst>
+          </p:cNvPr>
+          <p:cNvSpPr>
+            <a:spLocks xmlns:a="http://schemas.openxmlformats.org/drawingml/2006/main" noGrp="1"/>
+          </p:cNvSpPr>
+          <p:nvPr/>
+        </p:nvSpPr>
+        <p:spPr>
+          <a:xfrm xmlns:a="http://schemas.openxmlformats.org/drawingml/2006/main">
+            <a:off x="809625" y="3181350"/>
+            <a:ext cx="10477500" cy="619125"/>
           </a:xfrm>
           <a:prstGeom xmlns:a="http://schemas.openxmlformats.org/drawingml/2006/main" prst="rect">
             <a:avLst/>
@@ -2709,17 +2702,17 @@
                 <a:ea typeface="Arial"/>
                 <a:cs typeface="Arial"/>
               </a:rPr>
-              <a:t>For researchers and planners comparing proposed data centers</a:t>
-            </a:r>
-          </a:p>
-        </p:txBody>
-      </p:sp>
-      <p:sp>
-        <p:nvSpPr>
-          <p:cNvPr id="9" name="">
-            <a:extLst xmlns:a="http://schemas.openxmlformats.org/drawingml/2006/main">
-              <a:ext uri="{FF2B5EF4-FFF2-40B4-BE49-F238E27FC236}">
-                <a16:creationId xmlns:a16="http://schemas.microsoft.com/office/drawing/2014/main" id="{91916771-8510-40B8-A5DB-6A72DCAF8CB3}"/>
+              <a:t>How could development change area water reserves and watershed conditions across seasons?</a:t>
+            </a:r>
+          </a:p>
+        </p:txBody>
+      </p:sp>
+      <p:sp>
+        <p:nvSpPr>
+          <p:cNvPr id="8" name="">
+            <a:extLst xmlns:a="http://schemas.openxmlformats.org/drawingml/2006/main">
+              <a:ext uri="{FF2B5EF4-FFF2-40B4-BE49-F238E27FC236}">
+                <a16:creationId xmlns:a16="http://schemas.microsoft.com/office/drawing/2014/main" id="{F1548F97-FF97-4D98-B43F-BB9A14D3F9E8}"/>
               </a:ext>
             </a:extLst>
           </p:cNvPr>
@@ -2731,7 +2724,7 @@
         <p:spPr>
           <a:xfrm xmlns:a="http://schemas.openxmlformats.org/drawingml/2006/main">
             <a:off x="809625" y="4057650"/>
-            <a:ext cx="3905250" cy="285750"/>
+            <a:ext cx="4857750" cy="285750"/>
           </a:xfrm>
           <a:prstGeom xmlns:a="http://schemas.openxmlformats.org/drawingml/2006/main" prst="rect">
             <a:avLst/>
@@ -2766,17 +2759,17 @@
                 <a:ea typeface="Arial"/>
                 <a:cs typeface="Arial"/>
               </a:rPr>
-              <a:t>I N P U T</a:t>
-            </a:r>
-          </a:p>
-        </p:txBody>
-      </p:sp>
-      <p:sp>
-        <p:nvSpPr>
-          <p:cNvPr id="10" name="">
-            <a:extLst xmlns:a="http://schemas.openxmlformats.org/drawingml/2006/main">
-              <a:ext uri="{FF2B5EF4-FFF2-40B4-BE49-F238E27FC236}">
-                <a16:creationId xmlns:a16="http://schemas.microsoft.com/office/drawing/2014/main" id="{5E36EBD7-678D-4110-839D-C0D5BAA92E46}"/>
+              <a:t>R E G I O N A L  G O A L</a:t>
+            </a:r>
+          </a:p>
+        </p:txBody>
+      </p:sp>
+      <p:sp>
+        <p:nvSpPr>
+          <p:cNvPr id="9" name="">
+            <a:extLst xmlns:a="http://schemas.openxmlformats.org/drawingml/2006/main">
+              <a:ext uri="{FF2B5EF4-FFF2-40B4-BE49-F238E27FC236}">
+                <a16:creationId xmlns:a16="http://schemas.microsoft.com/office/drawing/2014/main" id="{3FFFDAD3-9805-4824-BA84-9E811F04E03E}"/>
               </a:ext>
             </a:extLst>
           </p:cNvPr>
@@ -2803,10 +2796,10 @@
       </p:sp>
       <p:sp>
         <p:nvSpPr>
-          <p:cNvPr id="11" name="">
-            <a:extLst xmlns:a="http://schemas.openxmlformats.org/drawingml/2006/main">
-              <a:ext uri="{FF2B5EF4-FFF2-40B4-BE49-F238E27FC236}">
-                <a16:creationId xmlns:a16="http://schemas.microsoft.com/office/drawing/2014/main" id="{4ECD1693-CE1C-4B64-B8A0-0BDEFD11ED98}"/>
+          <p:cNvPr id="10" name="">
+            <a:extLst xmlns:a="http://schemas.openxmlformats.org/drawingml/2006/main">
+              <a:ext uri="{FF2B5EF4-FFF2-40B4-BE49-F238E27FC236}">
+                <a16:creationId xmlns:a16="http://schemas.microsoft.com/office/drawing/2014/main" id="{A2DC9303-1831-4487-B63C-51AA3084E171}"/>
               </a:ext>
             </a:extLst>
           </p:cNvPr>
@@ -2818,7 +2811,7 @@
         <p:spPr>
           <a:xfrm xmlns:a="http://schemas.openxmlformats.org/drawingml/2006/main">
             <a:off x="809625" y="4600575"/>
-            <a:ext cx="4143375" cy="1095375"/>
+            <a:ext cx="5048250" cy="1095375"/>
           </a:xfrm>
           <a:prstGeom xmlns:a="http://schemas.openxmlformats.org/drawingml/2006/main" prst="rect">
             <a:avLst/>
@@ -2835,81 +2828,81 @@
           <a:lstStyle xmlns:a="http://schemas.openxmlformats.org/drawingml/2006/main"/>
           <a:p xmlns:a="http://schemas.openxmlformats.org/drawingml/2006/main">
             <a:pPr>
-              <a:defRPr sz="2025" b="0">
-                <a:solidFill>
-                  <a:srgbClr val="111827"/>
-                </a:solidFill>
-                <a:latin typeface="Arial"/>
-                <a:ea typeface="Arial"/>
-                <a:cs typeface="Arial"/>
-              </a:defRPr>
-            </a:pPr>
-            <a:r>
-              <a:rPr sz="2025" b="0">
-                <a:solidFill>
-                  <a:srgbClr val="111827"/>
-                </a:solidFill>
-                <a:latin typeface="Arial"/>
-                <a:ea typeface="Arial"/>
-                <a:cs typeface="Arial"/>
-              </a:rPr>
-              <a:t>IT size (megawatts)</a:t>
-            </a:r>
-          </a:p>
-          <a:p xmlns:a="http://schemas.openxmlformats.org/drawingml/2006/main">
-            <a:pPr>
-              <a:defRPr sz="2025" b="0">
-                <a:solidFill>
-                  <a:srgbClr val="111827"/>
-                </a:solidFill>
-                <a:latin typeface="Arial"/>
-                <a:ea typeface="Arial"/>
-                <a:cs typeface="Arial"/>
-              </a:defRPr>
-            </a:pPr>
-            <a:r>
-              <a:rPr sz="2025" b="0">
-                <a:solidFill>
-                  <a:srgbClr val="111827"/>
-                </a:solidFill>
-                <a:latin typeface="Arial"/>
-                <a:ea typeface="Arial"/>
-                <a:cs typeface="Arial"/>
-              </a:rPr>
-              <a:t>Cooling type</a:t>
-            </a:r>
-          </a:p>
-          <a:p xmlns:a="http://schemas.openxmlformats.org/drawingml/2006/main">
-            <a:pPr>
-              <a:defRPr sz="2025" b="0">
-                <a:solidFill>
-                  <a:srgbClr val="111827"/>
-                </a:solidFill>
-                <a:latin typeface="Arial"/>
-                <a:ea typeface="Arial"/>
-                <a:cs typeface="Arial"/>
-              </a:defRPr>
-            </a:pPr>
-            <a:r>
-              <a:rPr sz="2025" b="0">
-                <a:solidFill>
-                  <a:srgbClr val="111827"/>
-                </a:solidFill>
-                <a:latin typeface="Arial"/>
-                <a:ea typeface="Arial"/>
-                <a:cs typeface="Arial"/>
-              </a:rPr>
-              <a:t>Watershed + month</a:t>
-            </a:r>
-          </a:p>
-        </p:txBody>
-      </p:sp>
-      <p:sp>
-        <p:nvSpPr>
-          <p:cNvPr id="12" name="">
-            <a:extLst xmlns:a="http://schemas.openxmlformats.org/drawingml/2006/main">
-              <a:ext uri="{FF2B5EF4-FFF2-40B4-BE49-F238E27FC236}">
-                <a16:creationId xmlns:a16="http://schemas.microsoft.com/office/drawing/2014/main" id="{1516E11D-4E28-46AE-AD54-75AA4DB17E91}"/>
+              <a:defRPr sz="1875" b="0">
+                <a:solidFill>
+                  <a:srgbClr val="111827"/>
+                </a:solidFill>
+                <a:latin typeface="Arial"/>
+                <a:ea typeface="Arial"/>
+                <a:cs typeface="Arial"/>
+              </a:defRPr>
+            </a:pPr>
+            <a:r>
+              <a:rPr sz="1875" b="0">
+                <a:solidFill>
+                  <a:srgbClr val="111827"/>
+                </a:solidFill>
+                <a:latin typeface="Arial"/>
+                <a:ea typeface="Arial"/>
+                <a:cs typeface="Arial"/>
+              </a:rPr>
+              <a:t>Seasonal area conditions</a:t>
+            </a:r>
+          </a:p>
+          <a:p xmlns:a="http://schemas.openxmlformats.org/drawingml/2006/main">
+            <a:pPr>
+              <a:defRPr sz="1875" b="0">
+                <a:solidFill>
+                  <a:srgbClr val="111827"/>
+                </a:solidFill>
+                <a:latin typeface="Arial"/>
+                <a:ea typeface="Arial"/>
+                <a:cs typeface="Arial"/>
+              </a:defRPr>
+            </a:pPr>
+            <a:r>
+              <a:rPr sz="1875" b="0">
+                <a:solidFill>
+                  <a:srgbClr val="111827"/>
+                </a:solidFill>
+                <a:latin typeface="Arial"/>
+                <a:ea typeface="Arial"/>
+                <a:cs typeface="Arial"/>
+              </a:rPr>
+              <a:t>Development demands + returns</a:t>
+            </a:r>
+          </a:p>
+          <a:p xmlns:a="http://schemas.openxmlformats.org/drawingml/2006/main">
+            <a:pPr>
+              <a:defRPr sz="1875" b="0">
+                <a:solidFill>
+                  <a:srgbClr val="111827"/>
+                </a:solidFill>
+                <a:latin typeface="Arial"/>
+                <a:ea typeface="Arial"/>
+                <a:cs typeface="Arial"/>
+              </a:defRPr>
+            </a:pPr>
+            <a:r>
+              <a:rPr sz="1875" b="0">
+                <a:solidFill>
+                  <a:srgbClr val="111827"/>
+                </a:solidFill>
+                <a:latin typeface="Arial"/>
+                <a:ea typeface="Arial"/>
+                <a:cs typeface="Arial"/>
+              </a:rPr>
+              <a:t>Municipal reserves + watershed</a:t>
+            </a:r>
+          </a:p>
+        </p:txBody>
+      </p:sp>
+      <p:sp>
+        <p:nvSpPr>
+          <p:cNvPr id="11" name="">
+            <a:extLst xmlns:a="http://schemas.openxmlformats.org/drawingml/2006/main">
+              <a:ext uri="{FF2B5EF4-FFF2-40B4-BE49-F238E27FC236}">
+                <a16:creationId xmlns:a16="http://schemas.microsoft.com/office/drawing/2014/main" id="{83BE0963-60E1-4517-A280-B3B21ED64F6B}"/>
               </a:ext>
             </a:extLst>
           </p:cNvPr>
@@ -2921,7 +2914,7 @@
         <p:spPr>
           <a:xfrm xmlns:a="http://schemas.openxmlformats.org/drawingml/2006/main">
             <a:off x="6286500" y="4057650"/>
-            <a:ext cx="4619625" cy="285750"/>
+            <a:ext cx="5143500" cy="285750"/>
           </a:xfrm>
           <a:prstGeom xmlns:a="http://schemas.openxmlformats.org/drawingml/2006/main" prst="rect">
             <a:avLst/>
@@ -2956,17 +2949,17 @@
                 <a:ea typeface="Arial"/>
                 <a:cs typeface="Arial"/>
               </a:rPr>
-              <a:t>O U T P U T</a:t>
-            </a:r>
-          </a:p>
-        </p:txBody>
-      </p:sp>
-      <p:sp>
-        <p:nvSpPr>
-          <p:cNvPr id="13" name="">
-            <a:extLst xmlns:a="http://schemas.openxmlformats.org/drawingml/2006/main">
-              <a:ext uri="{FF2B5EF4-FFF2-40B4-BE49-F238E27FC236}">
-                <a16:creationId xmlns:a16="http://schemas.microsoft.com/office/drawing/2014/main" id="{8A7DE5B0-268F-42B8-B479-7144FA61B69E}"/>
+              <a:t>C U R R E N T  P R O T O T Y P E</a:t>
+            </a:r>
+          </a:p>
+        </p:txBody>
+      </p:sp>
+      <p:sp>
+        <p:nvSpPr>
+          <p:cNvPr id="12" name="">
+            <a:extLst xmlns:a="http://schemas.openxmlformats.org/drawingml/2006/main">
+              <a:ext uri="{FF2B5EF4-FFF2-40B4-BE49-F238E27FC236}">
+                <a16:creationId xmlns:a16="http://schemas.microsoft.com/office/drawing/2014/main" id="{62B43B0F-9CF9-4254-A0B9-9C070B89EACC}"/>
               </a:ext>
             </a:extLst>
           </p:cNvPr>
@@ -2993,10 +2986,10 @@
       </p:sp>
       <p:sp>
         <p:nvSpPr>
-          <p:cNvPr id="14" name="">
-            <a:extLst xmlns:a="http://schemas.openxmlformats.org/drawingml/2006/main">
-              <a:ext uri="{FF2B5EF4-FFF2-40B4-BE49-F238E27FC236}">
-                <a16:creationId xmlns:a16="http://schemas.microsoft.com/office/drawing/2014/main" id="{E3D896FD-03C7-4AF2-8F9C-F0DC296D45DC}"/>
+          <p:cNvPr id="13" name="">
+            <a:extLst xmlns:a="http://schemas.openxmlformats.org/drawingml/2006/main">
+              <a:ext uri="{FF2B5EF4-FFF2-40B4-BE49-F238E27FC236}">
+                <a16:creationId xmlns:a16="http://schemas.microsoft.com/office/drawing/2014/main" id="{043670AC-1F12-4779-B934-8F7DAC3CF9D0}"/>
               </a:ext>
             </a:extLst>
           </p:cNvPr>
@@ -3025,81 +3018,81 @@
           <a:lstStyle xmlns:a="http://schemas.openxmlformats.org/drawingml/2006/main"/>
           <a:p xmlns:a="http://schemas.openxmlformats.org/drawingml/2006/main">
             <a:pPr>
-              <a:defRPr sz="2025" b="0">
-                <a:solidFill>
-                  <a:srgbClr val="111827"/>
-                </a:solidFill>
-                <a:latin typeface="Arial"/>
-                <a:ea typeface="Arial"/>
-                <a:cs typeface="Arial"/>
-              </a:defRPr>
-            </a:pPr>
-            <a:r>
-              <a:rPr sz="2025" b="0">
-                <a:solidFill>
-                  <a:srgbClr val="111827"/>
-                </a:solidFill>
-                <a:latin typeface="Arial"/>
-                <a:ea typeface="Arial"/>
-                <a:cs typeface="Arial"/>
-              </a:rPr>
-              <a:t>Water use + physical limits</a:t>
-            </a:r>
-          </a:p>
-          <a:p xmlns:a="http://schemas.openxmlformats.org/drawingml/2006/main">
-            <a:pPr>
-              <a:defRPr sz="2025" b="0">
-                <a:solidFill>
-                  <a:srgbClr val="111827"/>
-                </a:solidFill>
-                <a:latin typeface="Arial"/>
-                <a:ea typeface="Arial"/>
-                <a:cs typeface="Arial"/>
-              </a:defRPr>
-            </a:pPr>
-            <a:r>
-              <a:rPr sz="2025" b="0">
-                <a:solidFill>
-                  <a:srgbClr val="111827"/>
-                </a:solidFill>
-                <a:latin typeface="Arial"/>
-                <a:ea typeface="Arial"/>
-                <a:cs typeface="Arial"/>
-              </a:rPr>
-              <a:t>Prediction range + warnings</a:t>
-            </a:r>
-          </a:p>
-          <a:p xmlns:a="http://schemas.openxmlformats.org/drawingml/2006/main">
-            <a:pPr>
-              <a:defRPr sz="2025" b="0">
-                <a:solidFill>
-                  <a:srgbClr val="111827"/>
-                </a:solidFill>
-                <a:latin typeface="Arial"/>
-                <a:ea typeface="Arial"/>
-                <a:cs typeface="Arial"/>
-              </a:defRPr>
-            </a:pPr>
-            <a:r>
-              <a:rPr sz="2025" b="0">
-                <a:solidFill>
-                  <a:srgbClr val="111827"/>
-                </a:solidFill>
-                <a:latin typeface="Arial"/>
-                <a:ea typeface="Arial"/>
-                <a:cs typeface="Arial"/>
-              </a:rPr>
-              <a:t>Permit quotes for the location</a:t>
-            </a:r>
-          </a:p>
-        </p:txBody>
-      </p:sp>
-      <p:sp>
-        <p:nvSpPr>
-          <p:cNvPr id="15" name="">
-            <a:extLst xmlns:a="http://schemas.openxmlformats.org/drawingml/2006/main">
-              <a:ext uri="{FF2B5EF4-FFF2-40B4-BE49-F238E27FC236}">
-                <a16:creationId xmlns:a16="http://schemas.microsoft.com/office/drawing/2014/main" id="{A58ABBB3-8D98-4E4F-B236-0F6F7E3C1C3B}"/>
+              <a:defRPr sz="1875" b="0">
+                <a:solidFill>
+                  <a:srgbClr val="111827"/>
+                </a:solidFill>
+                <a:latin typeface="Arial"/>
+                <a:ea typeface="Arial"/>
+                <a:cs typeface="Arial"/>
+              </a:defRPr>
+            </a:pPr>
+            <a:r>
+              <a:rPr sz="1875" b="0">
+                <a:solidFill>
+                  <a:srgbClr val="111827"/>
+                </a:solidFill>
+                <a:latin typeface="Arial"/>
+                <a:ea typeface="Arial"/>
+                <a:cs typeface="Arial"/>
+              </a:rPr>
+              <a:t>Environmental data + cooling model</a:t>
+            </a:r>
+          </a:p>
+          <a:p xmlns:a="http://schemas.openxmlformats.org/drawingml/2006/main">
+            <a:pPr>
+              <a:defRPr sz="1875" b="0">
+                <a:solidFill>
+                  <a:srgbClr val="111827"/>
+                </a:solidFill>
+                <a:latin typeface="Arial"/>
+                <a:ea typeface="Arial"/>
+                <a:cs typeface="Arial"/>
+              </a:defRPr>
+            </a:pPr>
+            <a:r>
+              <a:rPr sz="1875" b="0">
+                <a:solidFill>
+                  <a:srgbClr val="111827"/>
+                </a:solidFill>
+                <a:latin typeface="Arial"/>
+                <a:ea typeface="Arial"/>
+                <a:cs typeface="Arial"/>
+              </a:rPr>
+              <a:t>Physical checks + permit quotes</a:t>
+            </a:r>
+          </a:p>
+          <a:p xmlns:a="http://schemas.openxmlformats.org/drawingml/2006/main">
+            <a:pPr>
+              <a:defRPr sz="1875" b="0">
+                <a:solidFill>
+                  <a:srgbClr val="111827"/>
+                </a:solidFill>
+                <a:latin typeface="Arial"/>
+                <a:ea typeface="Arial"/>
+                <a:cs typeface="Arial"/>
+              </a:defRPr>
+            </a:pPr>
+            <a:r>
+              <a:rPr sz="1875" b="0">
+                <a:solidFill>
+                  <a:srgbClr val="111827"/>
+                </a:solidFill>
+                <a:latin typeface="Arial"/>
+                <a:ea typeface="Arial"/>
+                <a:cs typeface="Arial"/>
+              </a:rPr>
+              <a:t>Regional assessment still planned</a:t>
+            </a:r>
+          </a:p>
+        </p:txBody>
+      </p:sp>
+      <p:sp>
+        <p:nvSpPr>
+          <p:cNvPr id="14" name="">
+            <a:extLst xmlns:a="http://schemas.openxmlformats.org/drawingml/2006/main">
+              <a:ext uri="{FF2B5EF4-FFF2-40B4-BE49-F238E27FC236}">
+                <a16:creationId xmlns:a16="http://schemas.microsoft.com/office/drawing/2014/main" id="{92210842-3957-4ECD-9A0A-D4D9D5AF80F7}"/>
               </a:ext>
             </a:extLst>
           </p:cNvPr>
@@ -3111,7 +3104,7 @@
         <p:spPr>
           <a:xfrm xmlns:a="http://schemas.openxmlformats.org/drawingml/2006/main">
             <a:off x="809625" y="5867400"/>
-            <a:ext cx="7620000" cy="257175"/>
+            <a:ext cx="10572750" cy="257175"/>
           </a:xfrm>
           <a:prstGeom xmlns:a="http://schemas.openxmlformats.org/drawingml/2006/main" prst="rect">
             <a:avLst/>
@@ -3146,7 +3139,7 @@
                 <a:ea typeface="Arial"/>
                 <a:cs typeface="Arial"/>
               </a:rPr>
-              <a:t>Working local prototype</a:t>
+              <a:t>Cooling is one case study. Users: municipal planners, researchers, utilities.</a:t>
             </a:r>
           </a:p>
         </p:txBody>
@@ -3154,7 +3147,7 @@
     </p:spTree>
     <p:extLst>
       <p:ext uri="{BB962C8B-B14F-4D97-AF65-F5344CB8AC3E}">
-        <p14:creationId xmlns:p14="http://schemas.microsoft.com/office/powerpoint/2010/main" val="1317099166"/>
+        <p14:creationId xmlns:p14="http://schemas.microsoft.com/office/powerpoint/2010/main" val="1544669755"/>
       </p:ext>
     </p:extLst>
   </p:cSld>
@@ -3182,62 +3175,10 @@
       </p:grpSpPr>
       <p:sp>
         <p:nvSpPr>
-          <p:cNvPr id="59" name="">
-            <a:extLst xmlns:a="http://schemas.openxmlformats.org/drawingml/2006/main">
-              <a:ext uri="{FF2B5EF4-FFF2-40B4-BE49-F238E27FC236}">
-                <a16:creationId xmlns:a16="http://schemas.microsoft.com/office/drawing/2014/main" id="{DE317F57-5633-4178-9CE3-EA24A042338F}"/>
-              </a:ext>
-            </a:extLst>
-          </p:cNvPr>
-          <p:cNvSpPr>
-            <a:spLocks xmlns:a="http://schemas.openxmlformats.org/drawingml/2006/main" noGrp="1"/>
-          </p:cNvSpPr>
-          <p:nvPr/>
-        </p:nvSpPr>
-        <p:spPr>
-          <a:xfrm xmlns:a="http://schemas.openxmlformats.org/drawingml/2006/main">
-            <a:off x="6286500" y="-619125"/>
-            <a:ext cx="4953000" cy="2857500"/>
-          </a:xfrm>
-          <a:prstGeom xmlns:a="http://schemas.openxmlformats.org/drawingml/2006/main" prst="ellipse">
-            <a:avLst/>
-          </a:prstGeom>
-          <a:gradFill xmlns:a="http://schemas.openxmlformats.org/drawingml/2006/main">
-            <a:gsLst>
-              <a:gs pos="0">
-                <a:srgbClr val="9382FF">
-                  <a:alpha val="45000"/>
-                </a:srgbClr>
-              </a:gs>
-              <a:gs pos="35000">
-                <a:srgbClr val="9382FF">
-                  <a:alpha val="18000"/>
-                </a:srgbClr>
-              </a:gs>
-              <a:gs pos="65000">
-                <a:srgbClr val="9382FF">
-                  <a:alpha val="4000"/>
-                </a:srgbClr>
-              </a:gs>
-              <a:gs pos="100000">
-                <a:srgbClr val="9382FF">
-                  <a:alpha val="0"/>
-                </a:srgbClr>
-              </a:gs>
-            </a:gsLst>
-            <a:path path="shape"/>
-          </a:gradFill>
-          <a:ln xmlns:a="http://schemas.openxmlformats.org/drawingml/2006/main" w="0">
-            <a:noFill/>
-          </a:ln>
-        </p:spPr>
-      </p:sp>
-      <p:sp>
-        <p:nvSpPr>
-          <p:cNvPr id="2" name="">
-            <a:extLst xmlns:a="http://schemas.openxmlformats.org/drawingml/2006/main">
-              <a:ext uri="{FF2B5EF4-FFF2-40B4-BE49-F238E27FC236}">
-                <a16:creationId xmlns:a16="http://schemas.microsoft.com/office/drawing/2014/main" id="{252BA05A-68E0-40CE-89F3-36111D6EE38C}"/>
+          <p:cNvPr id="58" name="">
+            <a:extLst xmlns:a="http://schemas.openxmlformats.org/drawingml/2006/main">
+              <a:ext uri="{FF2B5EF4-FFF2-40B4-BE49-F238E27FC236}">
+                <a16:creationId xmlns:a16="http://schemas.microsoft.com/office/drawing/2014/main" id="{B9B97266-7375-4BCF-A36B-96A490AC5CF1}"/>
               </a:ext>
             </a:extLst>
           </p:cNvPr>
@@ -3291,10 +3232,10 @@
       </p:sp>
       <p:sp>
         <p:nvSpPr>
-          <p:cNvPr id="3" name="">
-            <a:extLst xmlns:a="http://schemas.openxmlformats.org/drawingml/2006/main">
-              <a:ext uri="{FF2B5EF4-FFF2-40B4-BE49-F238E27FC236}">
-                <a16:creationId xmlns:a16="http://schemas.microsoft.com/office/drawing/2014/main" id="{F04A91C2-A8B1-4C47-A5DC-8A67344B1E03}"/>
+          <p:cNvPr id="2" name="">
+            <a:extLst xmlns:a="http://schemas.openxmlformats.org/drawingml/2006/main">
+              <a:ext uri="{FF2B5EF4-FFF2-40B4-BE49-F238E27FC236}">
+                <a16:creationId xmlns:a16="http://schemas.microsoft.com/office/drawing/2014/main" id="{7210FD32-CCA7-403C-9F7E-0D846F3EF82A}"/>
               </a:ext>
             </a:extLst>
           </p:cNvPr>
@@ -3321,10 +3262,10 @@
       </p:sp>
       <p:sp>
         <p:nvSpPr>
-          <p:cNvPr id="4" name="">
-            <a:extLst xmlns:a="http://schemas.openxmlformats.org/drawingml/2006/main">
-              <a:ext uri="{FF2B5EF4-FFF2-40B4-BE49-F238E27FC236}">
-                <a16:creationId xmlns:a16="http://schemas.microsoft.com/office/drawing/2014/main" id="{330C627C-70A6-47B8-82EA-362EAC2A8CBC}"/>
+          <p:cNvPr id="3" name="">
+            <a:extLst xmlns:a="http://schemas.openxmlformats.org/drawingml/2006/main">
+              <a:ext uri="{FF2B5EF4-FFF2-40B4-BE49-F238E27FC236}">
+                <a16:creationId xmlns:a16="http://schemas.microsoft.com/office/drawing/2014/main" id="{590809D9-C3FC-4940-8316-66782F601CD9}"/>
               </a:ext>
             </a:extLst>
           </p:cNvPr>
@@ -3371,17 +3312,17 @@
                 <a:ea typeface="Georgia"/>
                 <a:cs typeface="Georgia"/>
               </a:rPr>
-              <a:t>TWO PATHS: PREDICT WATER USE AND FIND PERMIT QUOTES</a:t>
-            </a:r>
-          </a:p>
-        </p:txBody>
-      </p:sp>
-      <p:sp>
-        <p:nvSpPr>
-          <p:cNvPr id="5" name="">
-            <a:extLst xmlns:a="http://schemas.openxmlformats.org/drawingml/2006/main">
-              <a:ext uri="{FF2B5EF4-FFF2-40B4-BE49-F238E27FC236}">
-                <a16:creationId xmlns:a16="http://schemas.microsoft.com/office/drawing/2014/main" id="{C2DF4676-306C-4119-BF61-194F56A6996D}"/>
+              <a:t>SEMANTIC MAP: CURRENT SYSTEM</a:t>
+            </a:r>
+          </a:p>
+        </p:txBody>
+      </p:sp>
+      <p:sp>
+        <p:nvSpPr>
+          <p:cNvPr id="4" name="">
+            <a:extLst xmlns:a="http://schemas.openxmlformats.org/drawingml/2006/main">
+              <a:ext uri="{FF2B5EF4-FFF2-40B4-BE49-F238E27FC236}">
+                <a16:creationId xmlns:a16="http://schemas.microsoft.com/office/drawing/2014/main" id="{601CA5A5-27EC-4F8F-8249-B96AF0AA4A3F}"/>
               </a:ext>
             </a:extLst>
           </p:cNvPr>
@@ -3428,17 +3369,17 @@
                 <a:ea typeface="Arial"/>
                 <a:cs typeface="Arial"/>
               </a:rPr>
-              <a:t>E3/E4: constraint-failure-cases.json; retrieval-cases.json | Diagram shows current prototype</a:t>
-            </a:r>
-          </a:p>
-        </p:txBody>
-      </p:sp>
-      <p:sp>
-        <p:nvSpPr>
-          <p:cNvPr id="6" name="">
-            <a:extLst xmlns:a="http://schemas.openxmlformats.org/drawingml/2006/main">
-              <a:ext uri="{FF2B5EF4-FFF2-40B4-BE49-F238E27FC236}">
-                <a16:creationId xmlns:a16="http://schemas.microsoft.com/office/drawing/2014/main" id="{259A6269-636A-4591-BE76-61961788E464}"/>
+              <a:t>Evidence: E3/E4: constraint-failure-cases.json; retrieval-cases.json | Diagram shows current prototype</a:t>
+            </a:r>
+          </a:p>
+        </p:txBody>
+      </p:sp>
+      <p:sp>
+        <p:nvSpPr>
+          <p:cNvPr id="5" name="">
+            <a:extLst xmlns:a="http://schemas.openxmlformats.org/drawingml/2006/main">
+              <a:ext uri="{FF2B5EF4-FFF2-40B4-BE49-F238E27FC236}">
+                <a16:creationId xmlns:a16="http://schemas.microsoft.com/office/drawing/2014/main" id="{840AE70F-F351-498C-9CF8-43C671C118A8}"/>
               </a:ext>
             </a:extLst>
           </p:cNvPr>
@@ -3492,10 +3433,10 @@
       </p:sp>
       <p:sp>
         <p:nvSpPr>
-          <p:cNvPr id="7" name="">
-            <a:extLst xmlns:a="http://schemas.openxmlformats.org/drawingml/2006/main">
-              <a:ext uri="{FF2B5EF4-FFF2-40B4-BE49-F238E27FC236}">
-                <a16:creationId xmlns:a16="http://schemas.microsoft.com/office/drawing/2014/main" id="{C6147B96-7F50-4CA4-A054-D8D101836B5B}"/>
+          <p:cNvPr id="6" name="">
+            <a:extLst xmlns:a="http://schemas.openxmlformats.org/drawingml/2006/main">
+              <a:ext uri="{FF2B5EF4-FFF2-40B4-BE49-F238E27FC236}">
+                <a16:creationId xmlns:a16="http://schemas.microsoft.com/office/drawing/2014/main" id="{691374C7-0F8E-46DE-B74D-C4DCAC53C858}"/>
               </a:ext>
             </a:extLst>
           </p:cNvPr>
@@ -3542,17 +3483,17 @@
                 <a:ea typeface="Arial"/>
                 <a:cs typeface="Arial"/>
               </a:rPr>
-              <a:t>Enter IT size, cooling type, watershed code (HUC8), and month; coordinates optional</a:t>
-            </a:r>
-          </a:p>
-        </p:txBody>
-      </p:sp>
-      <p:sp>
-        <p:nvSpPr>
-          <p:cNvPr id="8" name="">
-            <a:extLst xmlns:a="http://schemas.openxmlformats.org/drawingml/2006/main">
-              <a:ext uri="{FF2B5EF4-FFF2-40B4-BE49-F238E27FC236}">
-                <a16:creationId xmlns:a16="http://schemas.microsoft.com/office/drawing/2014/main" id="{BEAD9024-4869-4A01-8CCB-A70B89C6D174}"/>
+              <a:t>Current API example: IT size, cooling type, watershed (HUC8), month; coordinates optional</a:t>
+            </a:r>
+          </a:p>
+        </p:txBody>
+      </p:sp>
+      <p:sp>
+        <p:nvSpPr>
+          <p:cNvPr id="7" name="">
+            <a:extLst xmlns:a="http://schemas.openxmlformats.org/drawingml/2006/main">
+              <a:ext uri="{FF2B5EF4-FFF2-40B4-BE49-F238E27FC236}">
+                <a16:creationId xmlns:a16="http://schemas.microsoft.com/office/drawing/2014/main" id="{8CA5B2CB-39B4-406B-BBA1-33CF1F173A62}"/>
               </a:ext>
             </a:extLst>
           </p:cNvPr>
@@ -3577,10 +3518,10 @@
       </p:sp>
       <p:sp>
         <p:nvSpPr>
-          <p:cNvPr id="9" name="">
-            <a:extLst xmlns:a="http://schemas.openxmlformats.org/drawingml/2006/main">
-              <a:ext uri="{FF2B5EF4-FFF2-40B4-BE49-F238E27FC236}">
-                <a16:creationId xmlns:a16="http://schemas.microsoft.com/office/drawing/2014/main" id="{472A38F5-015F-4D3E-8025-BAAD84C5581B}"/>
+          <p:cNvPr id="8" name="">
+            <a:extLst xmlns:a="http://schemas.openxmlformats.org/drawingml/2006/main">
+              <a:ext uri="{FF2B5EF4-FFF2-40B4-BE49-F238E27FC236}">
+                <a16:creationId xmlns:a16="http://schemas.microsoft.com/office/drawing/2014/main" id="{CE9CF199-FC74-43C6-9FAF-39E8638FDB78}"/>
               </a:ext>
             </a:extLst>
           </p:cNvPr>
@@ -3634,10 +3575,10 @@
       </p:sp>
       <p:sp>
         <p:nvSpPr>
-          <p:cNvPr id="10" name="">
-            <a:extLst xmlns:a="http://schemas.openxmlformats.org/drawingml/2006/main">
-              <a:ext uri="{FF2B5EF4-FFF2-40B4-BE49-F238E27FC236}">
-                <a16:creationId xmlns:a16="http://schemas.microsoft.com/office/drawing/2014/main" id="{B4C75C6D-BAA0-42BE-9C9A-889D26A92697}"/>
+          <p:cNvPr id="9" name="">
+            <a:extLst xmlns:a="http://schemas.openxmlformats.org/drawingml/2006/main">
+              <a:ext uri="{FF2B5EF4-FFF2-40B4-BE49-F238E27FC236}">
+                <a16:creationId xmlns:a16="http://schemas.microsoft.com/office/drawing/2014/main" id="{ABD280D5-6F5B-4EC6-8551-AC22112D2F6E}"/>
               </a:ext>
             </a:extLst>
           </p:cNvPr>
@@ -3664,10 +3605,10 @@
       </p:sp>
       <p:sp>
         <p:nvSpPr>
-          <p:cNvPr id="11" name="">
-            <a:extLst xmlns:a="http://schemas.openxmlformats.org/drawingml/2006/main">
-              <a:ext uri="{FF2B5EF4-FFF2-40B4-BE49-F238E27FC236}">
-                <a16:creationId xmlns:a16="http://schemas.microsoft.com/office/drawing/2014/main" id="{16E49B3D-EAA8-4470-B702-0692C7AD63C7}"/>
+          <p:cNvPr id="10" name="">
+            <a:extLst xmlns:a="http://schemas.openxmlformats.org/drawingml/2006/main">
+              <a:ext uri="{FF2B5EF4-FFF2-40B4-BE49-F238E27FC236}">
+                <a16:creationId xmlns:a16="http://schemas.microsoft.com/office/drawing/2014/main" id="{04EAB915-AB61-4C18-9EE7-471B5F48D755}"/>
               </a:ext>
             </a:extLst>
           </p:cNvPr>
@@ -3744,10 +3685,10 @@
       </p:sp>
       <p:sp>
         <p:nvSpPr>
-          <p:cNvPr id="12" name="">
-            <a:extLst xmlns:a="http://schemas.openxmlformats.org/drawingml/2006/main">
-              <a:ext uri="{FF2B5EF4-FFF2-40B4-BE49-F238E27FC236}">
-                <a16:creationId xmlns:a16="http://schemas.microsoft.com/office/drawing/2014/main" id="{E077B6F3-21BD-4834-98A5-27B92BB08A24}"/>
+          <p:cNvPr id="11" name="">
+            <a:extLst xmlns:a="http://schemas.openxmlformats.org/drawingml/2006/main">
+              <a:ext uri="{FF2B5EF4-FFF2-40B4-BE49-F238E27FC236}">
+                <a16:creationId xmlns:a16="http://schemas.microsoft.com/office/drawing/2014/main" id="{FAD2A5FC-7F47-4589-9214-421333BB981C}"/>
               </a:ext>
             </a:extLst>
           </p:cNvPr>
@@ -3772,10 +3713,10 @@
       </p:sp>
       <p:sp>
         <p:nvSpPr>
-          <p:cNvPr id="13" name="">
-            <a:extLst xmlns:a="http://schemas.openxmlformats.org/drawingml/2006/main">
-              <a:ext uri="{FF2B5EF4-FFF2-40B4-BE49-F238E27FC236}">
-                <a16:creationId xmlns:a16="http://schemas.microsoft.com/office/drawing/2014/main" id="{4DA3F611-08E6-4087-8C38-B23F18B352D6}"/>
+          <p:cNvPr id="12" name="">
+            <a:extLst xmlns:a="http://schemas.openxmlformats.org/drawingml/2006/main">
+              <a:ext uri="{FF2B5EF4-FFF2-40B4-BE49-F238E27FC236}">
+                <a16:creationId xmlns:a16="http://schemas.microsoft.com/office/drawing/2014/main" id="{F0840932-B375-4C72-9E10-C4C899C880BB}"/>
               </a:ext>
             </a:extLst>
           </p:cNvPr>
@@ -3829,10 +3770,10 @@
       </p:sp>
       <p:sp>
         <p:nvSpPr>
-          <p:cNvPr id="14" name="">
-            <a:extLst xmlns:a="http://schemas.openxmlformats.org/drawingml/2006/main">
-              <a:ext uri="{FF2B5EF4-FFF2-40B4-BE49-F238E27FC236}">
-                <a16:creationId xmlns:a16="http://schemas.microsoft.com/office/drawing/2014/main" id="{31648790-132B-4D6A-B855-CB6BC43E54FC}"/>
+          <p:cNvPr id="13" name="">
+            <a:extLst xmlns:a="http://schemas.openxmlformats.org/drawingml/2006/main">
+              <a:ext uri="{FF2B5EF4-FFF2-40B4-BE49-F238E27FC236}">
+                <a16:creationId xmlns:a16="http://schemas.microsoft.com/office/drawing/2014/main" id="{FBB6C2AD-1B94-42A6-B3EF-73AB453A1305}"/>
               </a:ext>
             </a:extLst>
           </p:cNvPr>
@@ -3859,10 +3800,10 @@
       </p:sp>
       <p:sp>
         <p:nvSpPr>
-          <p:cNvPr id="15" name="">
-            <a:extLst xmlns:a="http://schemas.openxmlformats.org/drawingml/2006/main">
-              <a:ext uri="{FF2B5EF4-FFF2-40B4-BE49-F238E27FC236}">
-                <a16:creationId xmlns:a16="http://schemas.microsoft.com/office/drawing/2014/main" id="{B4476C09-ACFF-4F5E-A815-99173FF969AB}"/>
+          <p:cNvPr id="14" name="">
+            <a:extLst xmlns:a="http://schemas.openxmlformats.org/drawingml/2006/main">
+              <a:ext uri="{FF2B5EF4-FFF2-40B4-BE49-F238E27FC236}">
+                <a16:creationId xmlns:a16="http://schemas.microsoft.com/office/drawing/2014/main" id="{F09980AC-31F8-4A2C-B3BC-52B4E971B58C}"/>
               </a:ext>
             </a:extLst>
           </p:cNvPr>
@@ -3939,10 +3880,10 @@
       </p:sp>
       <p:sp>
         <p:nvSpPr>
-          <p:cNvPr id="16" name="">
-            <a:extLst xmlns:a="http://schemas.openxmlformats.org/drawingml/2006/main">
-              <a:ext uri="{FF2B5EF4-FFF2-40B4-BE49-F238E27FC236}">
-                <a16:creationId xmlns:a16="http://schemas.microsoft.com/office/drawing/2014/main" id="{118DF898-18AD-4157-A39A-E8A69779B23D}"/>
+          <p:cNvPr id="15" name="">
+            <a:extLst xmlns:a="http://schemas.openxmlformats.org/drawingml/2006/main">
+              <a:ext uri="{FF2B5EF4-FFF2-40B4-BE49-F238E27FC236}">
+                <a16:creationId xmlns:a16="http://schemas.microsoft.com/office/drawing/2014/main" id="{21EB9669-E970-43F1-B3FD-943004D10C4A}"/>
               </a:ext>
             </a:extLst>
           </p:cNvPr>
@@ -3967,10 +3908,10 @@
       </p:sp>
       <p:sp>
         <p:nvSpPr>
-          <p:cNvPr id="17" name="">
-            <a:extLst xmlns:a="http://schemas.openxmlformats.org/drawingml/2006/main">
-              <a:ext uri="{FF2B5EF4-FFF2-40B4-BE49-F238E27FC236}">
-                <a16:creationId xmlns:a16="http://schemas.microsoft.com/office/drawing/2014/main" id="{2FD819D7-5ED4-48BF-B654-EF9AFAE4015A}"/>
+          <p:cNvPr id="16" name="">
+            <a:extLst xmlns:a="http://schemas.openxmlformats.org/drawingml/2006/main">
+              <a:ext uri="{FF2B5EF4-FFF2-40B4-BE49-F238E27FC236}">
+                <a16:creationId xmlns:a16="http://schemas.microsoft.com/office/drawing/2014/main" id="{DC6701F1-20C6-4E26-8574-0BAD53DC74ED}"/>
               </a:ext>
             </a:extLst>
           </p:cNvPr>
@@ -4024,10 +3965,10 @@
       </p:sp>
       <p:sp>
         <p:nvSpPr>
-          <p:cNvPr id="18" name="">
-            <a:extLst xmlns:a="http://schemas.openxmlformats.org/drawingml/2006/main">
-              <a:ext uri="{FF2B5EF4-FFF2-40B4-BE49-F238E27FC236}">
-                <a16:creationId xmlns:a16="http://schemas.microsoft.com/office/drawing/2014/main" id="{0ED48795-A5FA-482F-8CBF-3B1408A208EF}"/>
+          <p:cNvPr id="17" name="">
+            <a:extLst xmlns:a="http://schemas.openxmlformats.org/drawingml/2006/main">
+              <a:ext uri="{FF2B5EF4-FFF2-40B4-BE49-F238E27FC236}">
+                <a16:creationId xmlns:a16="http://schemas.microsoft.com/office/drawing/2014/main" id="{6CE0162A-BDFE-4AD9-A5FA-A6D74541BC69}"/>
               </a:ext>
             </a:extLst>
           </p:cNvPr>
@@ -4054,10 +3995,10 @@
       </p:sp>
       <p:sp>
         <p:nvSpPr>
-          <p:cNvPr id="19" name="">
-            <a:extLst xmlns:a="http://schemas.openxmlformats.org/drawingml/2006/main">
-              <a:ext uri="{FF2B5EF4-FFF2-40B4-BE49-F238E27FC236}">
-                <a16:creationId xmlns:a16="http://schemas.microsoft.com/office/drawing/2014/main" id="{0956AD1E-83AC-462D-A35E-0B40CD68A094}"/>
+          <p:cNvPr id="18" name="">
+            <a:extLst xmlns:a="http://schemas.openxmlformats.org/drawingml/2006/main">
+              <a:ext uri="{FF2B5EF4-FFF2-40B4-BE49-F238E27FC236}">
+                <a16:creationId xmlns:a16="http://schemas.microsoft.com/office/drawing/2014/main" id="{ECCBDDC4-F684-44D1-91DF-72E7B764393E}"/>
               </a:ext>
             </a:extLst>
           </p:cNvPr>
@@ -4127,17 +4068,17 @@
                 <a:ea typeface="Arial"/>
                 <a:cs typeface="Arial"/>
               </a:rPr>
-              <a:t>predict a number</a:t>
-            </a:r>
-          </a:p>
-        </p:txBody>
-      </p:sp>
-      <p:sp>
-        <p:nvSpPr>
-          <p:cNvPr id="20" name="">
-            <a:extLst xmlns:a="http://schemas.openxmlformats.org/drawingml/2006/main">
-              <a:ext uri="{FF2B5EF4-FFF2-40B4-BE49-F238E27FC236}">
-                <a16:creationId xmlns:a16="http://schemas.microsoft.com/office/drawing/2014/main" id="{0D22C5AA-BDF7-4BDA-A2DF-2292303F6C88}"/>
+              <a:t>cooling-use target</a:t>
+            </a:r>
+          </a:p>
+        </p:txBody>
+      </p:sp>
+      <p:sp>
+        <p:nvSpPr>
+          <p:cNvPr id="19" name="">
+            <a:extLst xmlns:a="http://schemas.openxmlformats.org/drawingml/2006/main">
+              <a:ext uri="{FF2B5EF4-FFF2-40B4-BE49-F238E27FC236}">
+                <a16:creationId xmlns:a16="http://schemas.microsoft.com/office/drawing/2014/main" id="{5BE5EBAC-3BFB-4443-AAC5-6103D71884E0}"/>
               </a:ext>
             </a:extLst>
           </p:cNvPr>
@@ -4162,10 +4103,10 @@
       </p:sp>
       <p:sp>
         <p:nvSpPr>
-          <p:cNvPr id="21" name="">
-            <a:extLst xmlns:a="http://schemas.openxmlformats.org/drawingml/2006/main">
-              <a:ext uri="{FF2B5EF4-FFF2-40B4-BE49-F238E27FC236}">
-                <a16:creationId xmlns:a16="http://schemas.microsoft.com/office/drawing/2014/main" id="{51197DE6-CC50-4648-8C71-F964DD0C81FF}"/>
+          <p:cNvPr id="20" name="">
+            <a:extLst xmlns:a="http://schemas.openxmlformats.org/drawingml/2006/main">
+              <a:ext uri="{FF2B5EF4-FFF2-40B4-BE49-F238E27FC236}">
+                <a16:creationId xmlns:a16="http://schemas.microsoft.com/office/drawing/2014/main" id="{34AD6466-7840-4C50-8E33-17681C23F758}"/>
               </a:ext>
             </a:extLst>
           </p:cNvPr>
@@ -4219,10 +4160,10 @@
       </p:sp>
       <p:sp>
         <p:nvSpPr>
-          <p:cNvPr id="22" name="">
-            <a:extLst xmlns:a="http://schemas.openxmlformats.org/drawingml/2006/main">
-              <a:ext uri="{FF2B5EF4-FFF2-40B4-BE49-F238E27FC236}">
-                <a16:creationId xmlns:a16="http://schemas.microsoft.com/office/drawing/2014/main" id="{0AB62FD9-20F0-41C9-87EC-F86D91EA2CF0}"/>
+          <p:cNvPr id="21" name="">
+            <a:extLst xmlns:a="http://schemas.openxmlformats.org/drawingml/2006/main">
+              <a:ext uri="{FF2B5EF4-FFF2-40B4-BE49-F238E27FC236}">
+                <a16:creationId xmlns:a16="http://schemas.microsoft.com/office/drawing/2014/main" id="{1AE90DE5-6987-48A7-92CA-4219F3728E2D}"/>
               </a:ext>
             </a:extLst>
           </p:cNvPr>
@@ -4249,10 +4190,10 @@
       </p:sp>
       <p:sp>
         <p:nvSpPr>
-          <p:cNvPr id="23" name="">
-            <a:extLst xmlns:a="http://schemas.openxmlformats.org/drawingml/2006/main">
-              <a:ext uri="{FF2B5EF4-FFF2-40B4-BE49-F238E27FC236}">
-                <a16:creationId xmlns:a16="http://schemas.microsoft.com/office/drawing/2014/main" id="{820D0BDE-122D-4678-9304-F57BBB7FADE9}"/>
+          <p:cNvPr id="22" name="">
+            <a:extLst xmlns:a="http://schemas.openxmlformats.org/drawingml/2006/main">
+              <a:ext uri="{FF2B5EF4-FFF2-40B4-BE49-F238E27FC236}">
+                <a16:creationId xmlns:a16="http://schemas.microsoft.com/office/drawing/2014/main" id="{EF2EA4EC-754F-42C5-A6DB-A9D497331614}"/>
               </a:ext>
             </a:extLst>
           </p:cNvPr>
@@ -4299,7 +4240,7 @@
                 <a:ea typeface="Arial"/>
                 <a:cs typeface="Arial"/>
               </a:rPr>
-              <a:t>size + weather</a:t>
+              <a:t>PUE + heat rules</a:t>
             </a:r>
           </a:p>
           <a:p xmlns:a="http://schemas.openxmlformats.org/drawingml/2006/main">
@@ -4329,10 +4270,10 @@
       </p:sp>
       <p:sp>
         <p:nvSpPr>
-          <p:cNvPr id="24" name="">
-            <a:extLst xmlns:a="http://schemas.openxmlformats.org/drawingml/2006/main">
-              <a:ext uri="{FF2B5EF4-FFF2-40B4-BE49-F238E27FC236}">
-                <a16:creationId xmlns:a16="http://schemas.microsoft.com/office/drawing/2014/main" id="{AACA931D-0941-4202-A1D6-C75BDB49E91E}"/>
+          <p:cNvPr id="23" name="">
+            <a:extLst xmlns:a="http://schemas.openxmlformats.org/drawingml/2006/main">
+              <a:ext uri="{FF2B5EF4-FFF2-40B4-BE49-F238E27FC236}">
+                <a16:creationId xmlns:a16="http://schemas.microsoft.com/office/drawing/2014/main" id="{6006F569-E32F-43AB-B9DF-CEA4BED73369}"/>
               </a:ext>
             </a:extLst>
           </p:cNvPr>
@@ -4357,10 +4298,10 @@
       </p:sp>
       <p:sp>
         <p:nvSpPr>
-          <p:cNvPr id="25" name="">
-            <a:extLst xmlns:a="http://schemas.openxmlformats.org/drawingml/2006/main">
-              <a:ext uri="{FF2B5EF4-FFF2-40B4-BE49-F238E27FC236}">
-                <a16:creationId xmlns:a16="http://schemas.microsoft.com/office/drawing/2014/main" id="{A453B239-213D-47AD-B487-723E2AEFDA93}"/>
+          <p:cNvPr id="24" name="">
+            <a:extLst xmlns:a="http://schemas.openxmlformats.org/drawingml/2006/main">
+              <a:ext uri="{FF2B5EF4-FFF2-40B4-BE49-F238E27FC236}">
+                <a16:creationId xmlns:a16="http://schemas.microsoft.com/office/drawing/2014/main" id="{8A78DA04-107E-4E21-83FD-E456365CAECB}"/>
               </a:ext>
             </a:extLst>
           </p:cNvPr>
@@ -4414,10 +4355,10 @@
       </p:sp>
       <p:sp>
         <p:nvSpPr>
-          <p:cNvPr id="26" name="">
-            <a:extLst xmlns:a="http://schemas.openxmlformats.org/drawingml/2006/main">
-              <a:ext uri="{FF2B5EF4-FFF2-40B4-BE49-F238E27FC236}">
-                <a16:creationId xmlns:a16="http://schemas.microsoft.com/office/drawing/2014/main" id="{409663D7-73CA-426A-B1C5-F5D4E9FA5A90}"/>
+          <p:cNvPr id="25" name="">
+            <a:extLst xmlns:a="http://schemas.openxmlformats.org/drawingml/2006/main">
+              <a:ext uri="{FF2B5EF4-FFF2-40B4-BE49-F238E27FC236}">
+                <a16:creationId xmlns:a16="http://schemas.microsoft.com/office/drawing/2014/main" id="{A88062E9-8C3D-4A0D-AAAF-D5B603C006D3}"/>
               </a:ext>
             </a:extLst>
           </p:cNvPr>
@@ -4444,10 +4385,10 @@
       </p:sp>
       <p:sp>
         <p:nvSpPr>
-          <p:cNvPr id="27" name="">
-            <a:extLst xmlns:a="http://schemas.openxmlformats.org/drawingml/2006/main">
-              <a:ext uri="{FF2B5EF4-FFF2-40B4-BE49-F238E27FC236}">
-                <a16:creationId xmlns:a16="http://schemas.microsoft.com/office/drawing/2014/main" id="{3B64F938-0F2A-4BA9-A55E-12530E8D772C}"/>
+          <p:cNvPr id="26" name="">
+            <a:extLst xmlns:a="http://schemas.openxmlformats.org/drawingml/2006/main">
+              <a:ext uri="{FF2B5EF4-FFF2-40B4-BE49-F238E27FC236}">
+                <a16:creationId xmlns:a16="http://schemas.microsoft.com/office/drawing/2014/main" id="{BA5CD508-9640-4C4F-8F6D-CD3B319CB58A}"/>
               </a:ext>
             </a:extLst>
           </p:cNvPr>
@@ -4524,10 +4465,10 @@
       </p:sp>
       <p:sp>
         <p:nvSpPr>
-          <p:cNvPr id="28" name="">
-            <a:extLst xmlns:a="http://schemas.openxmlformats.org/drawingml/2006/main">
-              <a:ext uri="{FF2B5EF4-FFF2-40B4-BE49-F238E27FC236}">
-                <a16:creationId xmlns:a16="http://schemas.microsoft.com/office/drawing/2014/main" id="{5AE214D5-A36D-4E39-A634-7850999E4B04}"/>
+          <p:cNvPr id="27" name="">
+            <a:extLst xmlns:a="http://schemas.openxmlformats.org/drawingml/2006/main">
+              <a:ext uri="{FF2B5EF4-FFF2-40B4-BE49-F238E27FC236}">
+                <a16:creationId xmlns:a16="http://schemas.microsoft.com/office/drawing/2014/main" id="{CE0A5FDA-62C0-40C1-BD6B-2E58E58470EC}"/>
               </a:ext>
             </a:extLst>
           </p:cNvPr>
@@ -4552,10 +4493,10 @@
       </p:sp>
       <p:sp>
         <p:nvSpPr>
-          <p:cNvPr id="29" name="">
-            <a:extLst xmlns:a="http://schemas.openxmlformats.org/drawingml/2006/main">
-              <a:ext uri="{FF2B5EF4-FFF2-40B4-BE49-F238E27FC236}">
-                <a16:creationId xmlns:a16="http://schemas.microsoft.com/office/drawing/2014/main" id="{1DDF208D-A6B9-4417-A95F-9DD423E69BE4}"/>
+          <p:cNvPr id="28" name="">
+            <a:extLst xmlns:a="http://schemas.openxmlformats.org/drawingml/2006/main">
+              <a:ext uri="{FF2B5EF4-FFF2-40B4-BE49-F238E27FC236}">
+                <a16:creationId xmlns:a16="http://schemas.microsoft.com/office/drawing/2014/main" id="{B5961B65-4EC4-4486-A750-61DE09D64857}"/>
               </a:ext>
             </a:extLst>
           </p:cNvPr>
@@ -4609,10 +4550,10 @@
       </p:sp>
       <p:sp>
         <p:nvSpPr>
-          <p:cNvPr id="30" name="">
-            <a:extLst xmlns:a="http://schemas.openxmlformats.org/drawingml/2006/main">
-              <a:ext uri="{FF2B5EF4-FFF2-40B4-BE49-F238E27FC236}">
-                <a16:creationId xmlns:a16="http://schemas.microsoft.com/office/drawing/2014/main" id="{23728934-7C03-46D5-8AE6-9DA5C0F81853}"/>
+          <p:cNvPr id="29" name="">
+            <a:extLst xmlns:a="http://schemas.openxmlformats.org/drawingml/2006/main">
+              <a:ext uri="{FF2B5EF4-FFF2-40B4-BE49-F238E27FC236}">
+                <a16:creationId xmlns:a16="http://schemas.microsoft.com/office/drawing/2014/main" id="{2AB9DF73-ACD8-4B2D-B7B9-D7FAC1C546F7}"/>
               </a:ext>
             </a:extLst>
           </p:cNvPr>
@@ -4639,10 +4580,10 @@
       </p:sp>
       <p:sp>
         <p:nvSpPr>
-          <p:cNvPr id="31" name="">
-            <a:extLst xmlns:a="http://schemas.openxmlformats.org/drawingml/2006/main">
-              <a:ext uri="{FF2B5EF4-FFF2-40B4-BE49-F238E27FC236}">
-                <a16:creationId xmlns:a16="http://schemas.microsoft.com/office/drawing/2014/main" id="{707B09AF-FA90-4CD0-9E65-D718D93450C4}"/>
+          <p:cNvPr id="30" name="">
+            <a:extLst xmlns:a="http://schemas.openxmlformats.org/drawingml/2006/main">
+              <a:ext uri="{FF2B5EF4-FFF2-40B4-BE49-F238E27FC236}">
+                <a16:creationId xmlns:a16="http://schemas.microsoft.com/office/drawing/2014/main" id="{C6B9F415-3D48-4560-AD4E-AB0EBF20A26A}"/>
               </a:ext>
             </a:extLst>
           </p:cNvPr>
@@ -4719,10 +4660,10 @@
       </p:sp>
       <p:sp>
         <p:nvSpPr>
-          <p:cNvPr id="32" name="">
-            <a:extLst xmlns:a="http://schemas.openxmlformats.org/drawingml/2006/main">
-              <a:ext uri="{FF2B5EF4-FFF2-40B4-BE49-F238E27FC236}">
-                <a16:creationId xmlns:a16="http://schemas.microsoft.com/office/drawing/2014/main" id="{197DE22B-F2C5-46E5-AD9A-C2F26AF25EE2}"/>
+          <p:cNvPr id="31" name="">
+            <a:extLst xmlns:a="http://schemas.openxmlformats.org/drawingml/2006/main">
+              <a:ext uri="{FF2B5EF4-FFF2-40B4-BE49-F238E27FC236}">
+                <a16:creationId xmlns:a16="http://schemas.microsoft.com/office/drawing/2014/main" id="{A828F906-DA08-476C-9B60-724C2B37489A}"/>
               </a:ext>
             </a:extLst>
           </p:cNvPr>
@@ -4747,10 +4688,10 @@
       </p:sp>
       <p:sp>
         <p:nvSpPr>
-          <p:cNvPr id="33" name="">
-            <a:extLst xmlns:a="http://schemas.openxmlformats.org/drawingml/2006/main">
-              <a:ext uri="{FF2B5EF4-FFF2-40B4-BE49-F238E27FC236}">
-                <a16:creationId xmlns:a16="http://schemas.microsoft.com/office/drawing/2014/main" id="{CF37178E-297F-4E2D-85B3-5623D0E91452}"/>
+          <p:cNvPr id="32" name="">
+            <a:extLst xmlns:a="http://schemas.openxmlformats.org/drawingml/2006/main">
+              <a:ext uri="{FF2B5EF4-FFF2-40B4-BE49-F238E27FC236}">
+                <a16:creationId xmlns:a16="http://schemas.microsoft.com/office/drawing/2014/main" id="{5FC9EA8F-3D65-491A-AE2E-F626B94F6DB5}"/>
               </a:ext>
             </a:extLst>
           </p:cNvPr>
@@ -4804,10 +4745,10 @@
       </p:sp>
       <p:sp>
         <p:nvSpPr>
-          <p:cNvPr id="34" name="">
-            <a:extLst xmlns:a="http://schemas.openxmlformats.org/drawingml/2006/main">
-              <a:ext uri="{FF2B5EF4-FFF2-40B4-BE49-F238E27FC236}">
-                <a16:creationId xmlns:a16="http://schemas.microsoft.com/office/drawing/2014/main" id="{A470F2AF-FAD8-4D42-835E-E6BCC5FDAE60}"/>
+          <p:cNvPr id="33" name="">
+            <a:extLst xmlns:a="http://schemas.openxmlformats.org/drawingml/2006/main">
+              <a:ext uri="{FF2B5EF4-FFF2-40B4-BE49-F238E27FC236}">
+                <a16:creationId xmlns:a16="http://schemas.microsoft.com/office/drawing/2014/main" id="{ADF2F911-61FB-4A2D-A814-17B089533138}"/>
               </a:ext>
             </a:extLst>
           </p:cNvPr>
@@ -4834,10 +4775,10 @@
       </p:sp>
       <p:sp>
         <p:nvSpPr>
-          <p:cNvPr id="35" name="">
-            <a:extLst xmlns:a="http://schemas.openxmlformats.org/drawingml/2006/main">
-              <a:ext uri="{FF2B5EF4-FFF2-40B4-BE49-F238E27FC236}">
-                <a16:creationId xmlns:a16="http://schemas.microsoft.com/office/drawing/2014/main" id="{CAC3F9F7-6FFE-40A3-B30E-397FD1B53877}"/>
+          <p:cNvPr id="34" name="">
+            <a:extLst xmlns:a="http://schemas.openxmlformats.org/drawingml/2006/main">
+              <a:ext uri="{FF2B5EF4-FFF2-40B4-BE49-F238E27FC236}">
+                <a16:creationId xmlns:a16="http://schemas.microsoft.com/office/drawing/2014/main" id="{5D811CE7-57B9-47A9-A583-8928811490CB}"/>
               </a:ext>
             </a:extLst>
           </p:cNvPr>
@@ -4907,17 +4848,17 @@
                 <a:ea typeface="Arial"/>
                 <a:cs typeface="Arial"/>
               </a:rPr>
-              <a:t>section IDs</a:t>
-            </a:r>
-          </a:p>
-        </p:txBody>
-      </p:sp>
-      <p:sp>
-        <p:nvSpPr>
-          <p:cNvPr id="36" name="">
-            <a:extLst xmlns:a="http://schemas.openxmlformats.org/drawingml/2006/main">
-              <a:ext uri="{FF2B5EF4-FFF2-40B4-BE49-F238E27FC236}">
-                <a16:creationId xmlns:a16="http://schemas.microsoft.com/office/drawing/2014/main" id="{94FB339D-062C-4E45-AC01-A809AE6ABE40}"/>
+              <a:t>source/section IDs</a:t>
+            </a:r>
+          </a:p>
+        </p:txBody>
+      </p:sp>
+      <p:sp>
+        <p:nvSpPr>
+          <p:cNvPr id="35" name="">
+            <a:extLst xmlns:a="http://schemas.openxmlformats.org/drawingml/2006/main">
+              <a:ext uri="{FF2B5EF4-FFF2-40B4-BE49-F238E27FC236}">
+                <a16:creationId xmlns:a16="http://schemas.microsoft.com/office/drawing/2014/main" id="{57A0067F-85D8-4248-A30F-0C72DC322F71}"/>
               </a:ext>
             </a:extLst>
           </p:cNvPr>
@@ -4942,10 +4883,10 @@
       </p:sp>
       <p:sp>
         <p:nvSpPr>
-          <p:cNvPr id="37" name="">
-            <a:extLst xmlns:a="http://schemas.openxmlformats.org/drawingml/2006/main">
-              <a:ext uri="{FF2B5EF4-FFF2-40B4-BE49-F238E27FC236}">
-                <a16:creationId xmlns:a16="http://schemas.microsoft.com/office/drawing/2014/main" id="{BD863F8C-97B1-4921-A8DB-4203D27C7F85}"/>
+          <p:cNvPr id="36" name="">
+            <a:extLst xmlns:a="http://schemas.openxmlformats.org/drawingml/2006/main">
+              <a:ext uri="{FF2B5EF4-FFF2-40B4-BE49-F238E27FC236}">
+                <a16:creationId xmlns:a16="http://schemas.microsoft.com/office/drawing/2014/main" id="{373F6D18-410D-4D94-9E25-688C889939FE}"/>
               </a:ext>
             </a:extLst>
           </p:cNvPr>
@@ -4999,10 +4940,10 @@
       </p:sp>
       <p:sp>
         <p:nvSpPr>
-          <p:cNvPr id="38" name="">
-            <a:extLst xmlns:a="http://schemas.openxmlformats.org/drawingml/2006/main">
-              <a:ext uri="{FF2B5EF4-FFF2-40B4-BE49-F238E27FC236}">
-                <a16:creationId xmlns:a16="http://schemas.microsoft.com/office/drawing/2014/main" id="{1A39FABF-A077-47C3-B120-F7BD96AE57C4}"/>
+          <p:cNvPr id="37" name="">
+            <a:extLst xmlns:a="http://schemas.openxmlformats.org/drawingml/2006/main">
+              <a:ext uri="{FF2B5EF4-FFF2-40B4-BE49-F238E27FC236}">
+                <a16:creationId xmlns:a16="http://schemas.microsoft.com/office/drawing/2014/main" id="{0CAEAA74-FA05-4FAB-89B0-9DADF296A209}"/>
               </a:ext>
             </a:extLst>
           </p:cNvPr>
@@ -5029,10 +4970,10 @@
       </p:sp>
       <p:sp>
         <p:nvSpPr>
-          <p:cNvPr id="39" name="">
-            <a:extLst xmlns:a="http://schemas.openxmlformats.org/drawingml/2006/main">
-              <a:ext uri="{FF2B5EF4-FFF2-40B4-BE49-F238E27FC236}">
-                <a16:creationId xmlns:a16="http://schemas.microsoft.com/office/drawing/2014/main" id="{DAFB39ED-F928-48BA-BE5D-1E404A43E009}"/>
+          <p:cNvPr id="38" name="">
+            <a:extLst xmlns:a="http://schemas.openxmlformats.org/drawingml/2006/main">
+              <a:ext uri="{FF2B5EF4-FFF2-40B4-BE49-F238E27FC236}">
+                <a16:creationId xmlns:a16="http://schemas.microsoft.com/office/drawing/2014/main" id="{4EF4DFEC-551E-43BB-BB52-E02CDBDB3A16}"/>
               </a:ext>
             </a:extLst>
           </p:cNvPr>
@@ -5102,17 +5043,17 @@
                 <a:ea typeface="Arial"/>
                 <a:cs typeface="Arial"/>
               </a:rPr>
-              <a:t>rank word matches</a:t>
-            </a:r>
-          </a:p>
-        </p:txBody>
-      </p:sp>
-      <p:sp>
-        <p:nvSpPr>
-          <p:cNvPr id="40" name="">
-            <a:extLst xmlns:a="http://schemas.openxmlformats.org/drawingml/2006/main">
-              <a:ext uri="{FF2B5EF4-FFF2-40B4-BE49-F238E27FC236}">
-                <a16:creationId xmlns:a16="http://schemas.microsoft.com/office/drawing/2014/main" id="{7B1B8A9A-E80D-4751-BD77-8267A046151A}"/>
+              <a:t>word-pair vectors</a:t>
+            </a:r>
+          </a:p>
+        </p:txBody>
+      </p:sp>
+      <p:sp>
+        <p:nvSpPr>
+          <p:cNvPr id="39" name="">
+            <a:extLst xmlns:a="http://schemas.openxmlformats.org/drawingml/2006/main">
+              <a:ext uri="{FF2B5EF4-FFF2-40B4-BE49-F238E27FC236}">
+                <a16:creationId xmlns:a16="http://schemas.microsoft.com/office/drawing/2014/main" id="{1B137963-80DA-4348-8881-EB3514C2CAE1}"/>
               </a:ext>
             </a:extLst>
           </p:cNvPr>
@@ -5137,10 +5078,10 @@
       </p:sp>
       <p:sp>
         <p:nvSpPr>
-          <p:cNvPr id="41" name="">
-            <a:extLst xmlns:a="http://schemas.openxmlformats.org/drawingml/2006/main">
-              <a:ext uri="{FF2B5EF4-FFF2-40B4-BE49-F238E27FC236}">
-                <a16:creationId xmlns:a16="http://schemas.microsoft.com/office/drawing/2014/main" id="{E887B316-963A-4F27-A2A6-6F57ED153ACE}"/>
+          <p:cNvPr id="40" name="">
+            <a:extLst xmlns:a="http://schemas.openxmlformats.org/drawingml/2006/main">
+              <a:ext uri="{FF2B5EF4-FFF2-40B4-BE49-F238E27FC236}">
+                <a16:creationId xmlns:a16="http://schemas.microsoft.com/office/drawing/2014/main" id="{C0B82702-58BA-42C1-8C40-DBA91F0D2E29}"/>
               </a:ext>
             </a:extLst>
           </p:cNvPr>
@@ -5194,10 +5135,10 @@
       </p:sp>
       <p:sp>
         <p:nvSpPr>
-          <p:cNvPr id="42" name="">
-            <a:extLst xmlns:a="http://schemas.openxmlformats.org/drawingml/2006/main">
-              <a:ext uri="{FF2B5EF4-FFF2-40B4-BE49-F238E27FC236}">
-                <a16:creationId xmlns:a16="http://schemas.microsoft.com/office/drawing/2014/main" id="{911731AF-706E-4899-AE1B-EFB228DC2335}"/>
+          <p:cNvPr id="41" name="">
+            <a:extLst xmlns:a="http://schemas.openxmlformats.org/drawingml/2006/main">
+              <a:ext uri="{FF2B5EF4-FFF2-40B4-BE49-F238E27FC236}">
+                <a16:creationId xmlns:a16="http://schemas.microsoft.com/office/drawing/2014/main" id="{FF6313BF-F6F0-4EF0-99DD-1B9B71CBA759}"/>
               </a:ext>
             </a:extLst>
           </p:cNvPr>
@@ -5224,10 +5165,10 @@
       </p:sp>
       <p:sp>
         <p:nvSpPr>
-          <p:cNvPr id="43" name="">
-            <a:extLst xmlns:a="http://schemas.openxmlformats.org/drawingml/2006/main">
-              <a:ext uri="{FF2B5EF4-FFF2-40B4-BE49-F238E27FC236}">
-                <a16:creationId xmlns:a16="http://schemas.microsoft.com/office/drawing/2014/main" id="{C6A101A9-CEFE-4164-A3F6-3E3AB612583B}"/>
+          <p:cNvPr id="42" name="">
+            <a:extLst xmlns:a="http://schemas.openxmlformats.org/drawingml/2006/main">
+              <a:ext uri="{FF2B5EF4-FFF2-40B4-BE49-F238E27FC236}">
+                <a16:creationId xmlns:a16="http://schemas.microsoft.com/office/drawing/2014/main" id="{7AEA86F7-D441-403A-B76F-ED7BB1C74EE9}"/>
               </a:ext>
             </a:extLst>
           </p:cNvPr>
@@ -5304,10 +5245,10 @@
       </p:sp>
       <p:sp>
         <p:nvSpPr>
-          <p:cNvPr id="44" name="">
-            <a:extLst xmlns:a="http://schemas.openxmlformats.org/drawingml/2006/main">
-              <a:ext uri="{FF2B5EF4-FFF2-40B4-BE49-F238E27FC236}">
-                <a16:creationId xmlns:a16="http://schemas.microsoft.com/office/drawing/2014/main" id="{C438BD16-B94B-48FC-AF41-6AD63F3E4C97}"/>
+          <p:cNvPr id="43" name="">
+            <a:extLst xmlns:a="http://schemas.openxmlformats.org/drawingml/2006/main">
+              <a:ext uri="{FF2B5EF4-FFF2-40B4-BE49-F238E27FC236}">
+                <a16:creationId xmlns:a16="http://schemas.microsoft.com/office/drawing/2014/main" id="{9AD8C8E1-9A99-4B05-B302-0B3BBB9A2A1C}"/>
               </a:ext>
             </a:extLst>
           </p:cNvPr>
@@ -5332,10 +5273,10 @@
       </p:sp>
       <p:sp>
         <p:nvSpPr>
-          <p:cNvPr id="45" name="">
-            <a:extLst xmlns:a="http://schemas.openxmlformats.org/drawingml/2006/main">
-              <a:ext uri="{FF2B5EF4-FFF2-40B4-BE49-F238E27FC236}">
-                <a16:creationId xmlns:a16="http://schemas.microsoft.com/office/drawing/2014/main" id="{75B3317B-8C96-4AD1-930D-323A8EE45C36}"/>
+          <p:cNvPr id="44" name="">
+            <a:extLst xmlns:a="http://schemas.openxmlformats.org/drawingml/2006/main">
+              <a:ext uri="{FF2B5EF4-FFF2-40B4-BE49-F238E27FC236}">
+                <a16:creationId xmlns:a16="http://schemas.microsoft.com/office/drawing/2014/main" id="{50D2E758-38E8-4B4B-855E-C8DC5C6D94EC}"/>
               </a:ext>
             </a:extLst>
           </p:cNvPr>
@@ -5389,10 +5330,10 @@
       </p:sp>
       <p:sp>
         <p:nvSpPr>
-          <p:cNvPr id="46" name="">
-            <a:extLst xmlns:a="http://schemas.openxmlformats.org/drawingml/2006/main">
-              <a:ext uri="{FF2B5EF4-FFF2-40B4-BE49-F238E27FC236}">
-                <a16:creationId xmlns:a16="http://schemas.microsoft.com/office/drawing/2014/main" id="{A1FB310C-6AD0-4F2A-A0FC-709548B79553}"/>
+          <p:cNvPr id="45" name="">
+            <a:extLst xmlns:a="http://schemas.openxmlformats.org/drawingml/2006/main">
+              <a:ext uri="{FF2B5EF4-FFF2-40B4-BE49-F238E27FC236}">
+                <a16:creationId xmlns:a16="http://schemas.microsoft.com/office/drawing/2014/main" id="{F6ECA1B1-CF94-4A3D-AC0B-8E512351F89A}"/>
               </a:ext>
             </a:extLst>
           </p:cNvPr>
@@ -5419,10 +5360,10 @@
       </p:sp>
       <p:sp>
         <p:nvSpPr>
-          <p:cNvPr id="47" name="">
-            <a:extLst xmlns:a="http://schemas.openxmlformats.org/drawingml/2006/main">
-              <a:ext uri="{FF2B5EF4-FFF2-40B4-BE49-F238E27FC236}">
-                <a16:creationId xmlns:a16="http://schemas.microsoft.com/office/drawing/2014/main" id="{B7B5A8D9-A0F3-4BEA-8054-04FA91A1FED2}"/>
+          <p:cNvPr id="46" name="">
+            <a:extLst xmlns:a="http://schemas.openxmlformats.org/drawingml/2006/main">
+              <a:ext uri="{FF2B5EF4-FFF2-40B4-BE49-F238E27FC236}">
+                <a16:creationId xmlns:a16="http://schemas.microsoft.com/office/drawing/2014/main" id="{3DC9FE79-39AF-4231-AB1E-6D9A0B3C8080}"/>
               </a:ext>
             </a:extLst>
           </p:cNvPr>
@@ -5499,10 +5440,10 @@
       </p:sp>
       <p:cxnSp>
         <p:nvCxnSpPr>
-          <p:cNvPr id="106" name=""/>
+          <p:cNvPr id="104" name=""/>
           <p:cNvCxnSpPr>
-            <a:stCxn xmlns:a="http://schemas.openxmlformats.org/drawingml/2006/main" id="8" idx="3"/>
-            <a:endCxn xmlns:a="http://schemas.openxmlformats.org/drawingml/2006/main" id="12" idx="1"/>
+            <a:stCxn xmlns:a="http://schemas.openxmlformats.org/drawingml/2006/main" id="7" idx="3"/>
+            <a:endCxn xmlns:a="http://schemas.openxmlformats.org/drawingml/2006/main" id="11" idx="1"/>
           </p:cNvCxnSpPr>
           <p:nvPr/>
         </p:nvCxnSpPr>
@@ -5524,10 +5465,10 @@
       </p:cxnSp>
       <p:cxnSp>
         <p:nvCxnSpPr>
-          <p:cNvPr id="107" name=""/>
+          <p:cNvPr id="105" name=""/>
           <p:cNvCxnSpPr>
-            <a:stCxn xmlns:a="http://schemas.openxmlformats.org/drawingml/2006/main" id="12" idx="3"/>
-            <a:endCxn xmlns:a="http://schemas.openxmlformats.org/drawingml/2006/main" id="16" idx="1"/>
+            <a:stCxn xmlns:a="http://schemas.openxmlformats.org/drawingml/2006/main" id="11" idx="3"/>
+            <a:endCxn xmlns:a="http://schemas.openxmlformats.org/drawingml/2006/main" id="15" idx="1"/>
           </p:cNvCxnSpPr>
           <p:nvPr/>
         </p:nvCxnSpPr>
@@ -5549,10 +5490,10 @@
       </p:cxnSp>
       <p:cxnSp>
         <p:nvCxnSpPr>
-          <p:cNvPr id="108" name=""/>
+          <p:cNvPr id="106" name=""/>
           <p:cNvCxnSpPr>
-            <a:stCxn xmlns:a="http://schemas.openxmlformats.org/drawingml/2006/main" id="16" idx="3"/>
-            <a:endCxn xmlns:a="http://schemas.openxmlformats.org/drawingml/2006/main" id="20" idx="1"/>
+            <a:stCxn xmlns:a="http://schemas.openxmlformats.org/drawingml/2006/main" id="15" idx="3"/>
+            <a:endCxn xmlns:a="http://schemas.openxmlformats.org/drawingml/2006/main" id="19" idx="1"/>
           </p:cNvCxnSpPr>
           <p:nvPr/>
         </p:nvCxnSpPr>
@@ -5574,10 +5515,10 @@
       </p:cxnSp>
       <p:cxnSp>
         <p:nvCxnSpPr>
-          <p:cNvPr id="109" name=""/>
+          <p:cNvPr id="107" name=""/>
           <p:cNvCxnSpPr>
-            <a:stCxn xmlns:a="http://schemas.openxmlformats.org/drawingml/2006/main" id="20" idx="3"/>
-            <a:endCxn xmlns:a="http://schemas.openxmlformats.org/drawingml/2006/main" id="24" idx="1"/>
+            <a:stCxn xmlns:a="http://schemas.openxmlformats.org/drawingml/2006/main" id="19" idx="3"/>
+            <a:endCxn xmlns:a="http://schemas.openxmlformats.org/drawingml/2006/main" id="23" idx="1"/>
           </p:cNvCxnSpPr>
           <p:nvPr/>
         </p:nvCxnSpPr>
@@ -5599,10 +5540,10 @@
       </p:cxnSp>
       <p:cxnSp>
         <p:nvCxnSpPr>
-          <p:cNvPr id="110" name=""/>
+          <p:cNvPr id="108" name=""/>
           <p:cNvCxnSpPr>
-            <a:stCxn xmlns:a="http://schemas.openxmlformats.org/drawingml/2006/main" id="28" idx="3"/>
-            <a:endCxn xmlns:a="http://schemas.openxmlformats.org/drawingml/2006/main" id="32" idx="1"/>
+            <a:stCxn xmlns:a="http://schemas.openxmlformats.org/drawingml/2006/main" id="27" idx="3"/>
+            <a:endCxn xmlns:a="http://schemas.openxmlformats.org/drawingml/2006/main" id="31" idx="1"/>
           </p:cNvCxnSpPr>
           <p:nvPr/>
         </p:nvCxnSpPr>
@@ -5624,10 +5565,10 @@
       </p:cxnSp>
       <p:cxnSp>
         <p:nvCxnSpPr>
-          <p:cNvPr id="111" name=""/>
+          <p:cNvPr id="109" name=""/>
           <p:cNvCxnSpPr>
-            <a:stCxn xmlns:a="http://schemas.openxmlformats.org/drawingml/2006/main" id="32" idx="3"/>
-            <a:endCxn xmlns:a="http://schemas.openxmlformats.org/drawingml/2006/main" id="36" idx="1"/>
+            <a:stCxn xmlns:a="http://schemas.openxmlformats.org/drawingml/2006/main" id="31" idx="3"/>
+            <a:endCxn xmlns:a="http://schemas.openxmlformats.org/drawingml/2006/main" id="35" idx="1"/>
           </p:cNvCxnSpPr>
           <p:nvPr/>
         </p:nvCxnSpPr>
@@ -5649,10 +5590,10 @@
       </p:cxnSp>
       <p:cxnSp>
         <p:nvCxnSpPr>
-          <p:cNvPr id="112" name=""/>
+          <p:cNvPr id="110" name=""/>
           <p:cNvCxnSpPr>
-            <a:stCxn xmlns:a="http://schemas.openxmlformats.org/drawingml/2006/main" id="36" idx="3"/>
-            <a:endCxn xmlns:a="http://schemas.openxmlformats.org/drawingml/2006/main" id="40" idx="1"/>
+            <a:stCxn xmlns:a="http://schemas.openxmlformats.org/drawingml/2006/main" id="35" idx="3"/>
+            <a:endCxn xmlns:a="http://schemas.openxmlformats.org/drawingml/2006/main" id="39" idx="1"/>
           </p:cNvCxnSpPr>
           <p:nvPr/>
         </p:nvCxnSpPr>
@@ -5674,10 +5615,10 @@
       </p:cxnSp>
       <p:cxnSp>
         <p:nvCxnSpPr>
-          <p:cNvPr id="113" name=""/>
+          <p:cNvPr id="111" name=""/>
           <p:cNvCxnSpPr>
-            <a:stCxn xmlns:a="http://schemas.openxmlformats.org/drawingml/2006/main" id="40" idx="3"/>
-            <a:endCxn xmlns:a="http://schemas.openxmlformats.org/drawingml/2006/main" id="44" idx="1"/>
+            <a:stCxn xmlns:a="http://schemas.openxmlformats.org/drawingml/2006/main" id="39" idx="3"/>
+            <a:endCxn xmlns:a="http://schemas.openxmlformats.org/drawingml/2006/main" id="43" idx="1"/>
           </p:cNvCxnSpPr>
           <p:nvPr/>
         </p:nvCxnSpPr>
@@ -5699,10 +5640,10 @@
       </p:cxnSp>
       <p:cxnSp>
         <p:nvCxnSpPr>
-          <p:cNvPr id="114" name=""/>
+          <p:cNvPr id="112" name=""/>
           <p:cNvCxnSpPr>
-            <a:stCxn xmlns:a="http://schemas.openxmlformats.org/drawingml/2006/main" id="44" idx="0"/>
-            <a:endCxn xmlns:a="http://schemas.openxmlformats.org/drawingml/2006/main" id="24" idx="2"/>
+            <a:stCxn xmlns:a="http://schemas.openxmlformats.org/drawingml/2006/main" id="43" idx="0"/>
+            <a:endCxn xmlns:a="http://schemas.openxmlformats.org/drawingml/2006/main" id="23" idx="2"/>
           </p:cNvCxnSpPr>
           <p:nvPr/>
         </p:nvCxnSpPr>
@@ -5724,10 +5665,10 @@
       </p:cxnSp>
       <p:sp>
         <p:nvSpPr>
-          <p:cNvPr id="57" name="">
-            <a:extLst xmlns:a="http://schemas.openxmlformats.org/drawingml/2006/main">
-              <a:ext uri="{FF2B5EF4-FFF2-40B4-BE49-F238E27FC236}">
-                <a16:creationId xmlns:a16="http://schemas.microsoft.com/office/drawing/2014/main" id="{999C38DA-7318-4B6A-9730-59F79DCF826A}"/>
+          <p:cNvPr id="56" name="">
+            <a:extLst xmlns:a="http://schemas.openxmlformats.org/drawingml/2006/main">
+              <a:ext uri="{FF2B5EF4-FFF2-40B4-BE49-F238E27FC236}">
+                <a16:creationId xmlns:a16="http://schemas.microsoft.com/office/drawing/2014/main" id="{A75DD0ED-24A4-4BAC-9291-95E268B30F20}"/>
               </a:ext>
             </a:extLst>
           </p:cNvPr>
@@ -5774,17 +5715,17 @@
                 <a:ea typeface="Arial"/>
                 <a:cs typeface="Arial"/>
               </a:rPr>
-              <a:t>Before use: train on made-up water use; choose, set ranges, and test by date.</a:t>
-            </a:r>
-          </a:p>
-        </p:txBody>
-      </p:sp>
-      <p:sp>
-        <p:nvSpPr>
-          <p:cNvPr id="58" name="">
-            <a:extLst xmlns:a="http://schemas.openxmlformats.org/drawingml/2006/main">
-              <a:ext uri="{FF2B5EF4-FFF2-40B4-BE49-F238E27FC236}">
-                <a16:creationId xmlns:a16="http://schemas.microsoft.com/office/drawing/2014/main" id="{AAAFF707-8106-4982-A197-E100FE1477D6}"/>
+              <a:t>Rules check learned numbers. Place metadata filters word vectors. Quotes add context.</a:t>
+            </a:r>
+          </a:p>
+        </p:txBody>
+      </p:sp>
+      <p:sp>
+        <p:nvSpPr>
+          <p:cNvPr id="57" name="">
+            <a:extLst xmlns:a="http://schemas.openxmlformats.org/drawingml/2006/main">
+              <a:ext uri="{FF2B5EF4-FFF2-40B4-BE49-F238E27FC236}">
+                <a16:creationId xmlns:a16="http://schemas.microsoft.com/office/drawing/2014/main" id="{E389FED3-FD65-4C32-81C8-9FBCC9FF43C3}"/>
               </a:ext>
             </a:extLst>
           </p:cNvPr>
@@ -5831,7 +5772,7 @@
                 <a:ea typeface="Arial"/>
                 <a:cs typeface="Arial"/>
               </a:rPr>
-              <a:t>Forced wrong numbers trigger warnings. Four permit-location tests pass.</a:t>
+              <a:t>E3: 40 MW fault test clips to [0, 0.446484] MGD. E4: four location checks pass.</a:t>
             </a:r>
           </a:p>
         </p:txBody>
@@ -5839,7 +5780,7 @@
     </p:spTree>
     <p:extLst>
       <p:ext uri="{BB962C8B-B14F-4D97-AF65-F5344CB8AC3E}">
-        <p14:creationId xmlns:p14="http://schemas.microsoft.com/office/powerpoint/2010/main" val="1544836962"/>
+        <p14:creationId xmlns:p14="http://schemas.microsoft.com/office/powerpoint/2010/main" val="916598804"/>
       </p:ext>
     </p:extLst>
   </p:cSld>
@@ -5867,62 +5808,10 @@
       </p:grpSpPr>
       <p:sp>
         <p:nvSpPr>
-          <p:cNvPr id="13" name="">
-            <a:extLst xmlns:a="http://schemas.openxmlformats.org/drawingml/2006/main">
-              <a:ext uri="{FF2B5EF4-FFF2-40B4-BE49-F238E27FC236}">
-                <a16:creationId xmlns:a16="http://schemas.microsoft.com/office/drawing/2014/main" id="{717CFC43-8CED-4965-96D1-564A0DE33C71}"/>
-              </a:ext>
-            </a:extLst>
-          </p:cNvPr>
-          <p:cNvSpPr>
-            <a:spLocks xmlns:a="http://schemas.openxmlformats.org/drawingml/2006/main" noGrp="1"/>
-          </p:cNvSpPr>
-          <p:nvPr/>
-        </p:nvSpPr>
-        <p:spPr>
-          <a:xfrm xmlns:a="http://schemas.openxmlformats.org/drawingml/2006/main">
-            <a:off x="6286500" y="-619125"/>
-            <a:ext cx="4953000" cy="2857500"/>
-          </a:xfrm>
-          <a:prstGeom xmlns:a="http://schemas.openxmlformats.org/drawingml/2006/main" prst="ellipse">
-            <a:avLst/>
-          </a:prstGeom>
-          <a:gradFill xmlns:a="http://schemas.openxmlformats.org/drawingml/2006/main">
-            <a:gsLst>
-              <a:gs pos="0">
-                <a:srgbClr val="9382FF">
-                  <a:alpha val="45000"/>
-                </a:srgbClr>
-              </a:gs>
-              <a:gs pos="35000">
-                <a:srgbClr val="9382FF">
-                  <a:alpha val="18000"/>
-                </a:srgbClr>
-              </a:gs>
-              <a:gs pos="65000">
-                <a:srgbClr val="9382FF">
-                  <a:alpha val="4000"/>
-                </a:srgbClr>
-              </a:gs>
-              <a:gs pos="100000">
-                <a:srgbClr val="9382FF">
-                  <a:alpha val="0"/>
-                </a:srgbClr>
-              </a:gs>
-            </a:gsLst>
-            <a:path path="shape"/>
-          </a:gradFill>
-          <a:ln xmlns:a="http://schemas.openxmlformats.org/drawingml/2006/main" w="0">
-            <a:noFill/>
-          </a:ln>
-        </p:spPr>
-      </p:sp>
-      <p:sp>
-        <p:nvSpPr>
-          <p:cNvPr id="2" name="">
-            <a:extLst xmlns:a="http://schemas.openxmlformats.org/drawingml/2006/main">
-              <a:ext uri="{FF2B5EF4-FFF2-40B4-BE49-F238E27FC236}">
-                <a16:creationId xmlns:a16="http://schemas.microsoft.com/office/drawing/2014/main" id="{2F0C8D5C-3850-4C75-827B-03DB6DD2E82F}"/>
+          <p:cNvPr id="12" name="">
+            <a:extLst xmlns:a="http://schemas.openxmlformats.org/drawingml/2006/main">
+              <a:ext uri="{FF2B5EF4-FFF2-40B4-BE49-F238E27FC236}">
+                <a16:creationId xmlns:a16="http://schemas.microsoft.com/office/drawing/2014/main" id="{73804E18-203D-4907-8B61-EEA3E1E5C63F}"/>
               </a:ext>
             </a:extLst>
           </p:cNvPr>
@@ -5976,10 +5865,10 @@
       </p:sp>
       <p:sp>
         <p:nvSpPr>
-          <p:cNvPr id="3" name="">
-            <a:extLst xmlns:a="http://schemas.openxmlformats.org/drawingml/2006/main">
-              <a:ext uri="{FF2B5EF4-FFF2-40B4-BE49-F238E27FC236}">
-                <a16:creationId xmlns:a16="http://schemas.microsoft.com/office/drawing/2014/main" id="{7B0D386B-DE2E-4F75-A5B8-7342CAC99B65}"/>
+          <p:cNvPr id="2" name="">
+            <a:extLst xmlns:a="http://schemas.openxmlformats.org/drawingml/2006/main">
+              <a:ext uri="{FF2B5EF4-FFF2-40B4-BE49-F238E27FC236}">
+                <a16:creationId xmlns:a16="http://schemas.microsoft.com/office/drawing/2014/main" id="{D0F001D5-2028-4CFD-A466-55695CE5FDE1}"/>
               </a:ext>
             </a:extLst>
           </p:cNvPr>
@@ -6006,10 +5895,10 @@
       </p:sp>
       <p:sp>
         <p:nvSpPr>
-          <p:cNvPr id="4" name="">
-            <a:extLst xmlns:a="http://schemas.openxmlformats.org/drawingml/2006/main">
-              <a:ext uri="{FF2B5EF4-FFF2-40B4-BE49-F238E27FC236}">
-                <a16:creationId xmlns:a16="http://schemas.microsoft.com/office/drawing/2014/main" id="{E6EA473E-5EBC-43F2-87F2-E9087F467D79}"/>
+          <p:cNvPr id="3" name="">
+            <a:extLst xmlns:a="http://schemas.openxmlformats.org/drawingml/2006/main">
+              <a:ext uri="{FF2B5EF4-FFF2-40B4-BE49-F238E27FC236}">
+                <a16:creationId xmlns:a16="http://schemas.microsoft.com/office/drawing/2014/main" id="{757A3279-5A7B-48E9-9269-3669B6A2913F}"/>
               </a:ext>
             </a:extLst>
           </p:cNvPr>
@@ -6056,17 +5945,17 @@
                 <a:ea typeface="Georgia"/>
                 <a:cs typeface="Georgia"/>
               </a:rPr>
-              <a:t>XGBOOST MADE SMALLER ERRORS ON OUR TEST DATA</a:t>
-            </a:r>
-          </a:p>
-        </p:txBody>
-      </p:sp>
-      <p:sp>
-        <p:nvSpPr>
-          <p:cNvPr id="5" name="">
-            <a:extLst xmlns:a="http://schemas.openxmlformats.org/drawingml/2006/main">
-              <a:ext uri="{FF2B5EF4-FFF2-40B4-BE49-F238E27FC236}">
-                <a16:creationId xmlns:a16="http://schemas.microsoft.com/office/drawing/2014/main" id="{4E6BFC30-6E40-46A4-A4A1-9FD934286BCD}"/>
+              <a:t>EXPERIMENT E1: MODEL COMPARISON</a:t>
+            </a:r>
+          </a:p>
+        </p:txBody>
+      </p:sp>
+      <p:sp>
+        <p:nvSpPr>
+          <p:cNvPr id="4" name="">
+            <a:extLst xmlns:a="http://schemas.openxmlformats.org/drawingml/2006/main">
+              <a:ext uri="{FF2B5EF4-FFF2-40B4-BE49-F238E27FC236}">
+                <a16:creationId xmlns:a16="http://schemas.microsoft.com/office/drawing/2014/main" id="{0EF51438-34E2-454D-8A4B-40DDF8A418C8}"/>
               </a:ext>
             </a:extLst>
           </p:cNvPr>
@@ -6113,17 +6002,17 @@
                 <a:ea typeface="Arial"/>
                 <a:cs typeface="Arial"/>
               </a:rPr>
-              <a:t>E1: regression-comparison.csv | 333 test rows per evaporative type | MGD = million US gallons/day</a:t>
-            </a:r>
-          </a:p>
-        </p:txBody>
-      </p:sp>
-      <p:sp>
-        <p:nvSpPr>
-          <p:cNvPr id="6" name="">
-            <a:extLst xmlns:a="http://schemas.openxmlformats.org/drawingml/2006/main">
-              <a:ext uri="{FF2B5EF4-FFF2-40B4-BE49-F238E27FC236}">
-                <a16:creationId xmlns:a16="http://schemas.microsoft.com/office/drawing/2014/main" id="{5A37930E-B94B-49F6-98FE-ACA741E0410A}"/>
+              <a:t>Evidence: E1: regression-comparison.csv | 333 test rows per evaporative type | MGD = million US gallons/day</a:t>
+            </a:r>
+          </a:p>
+        </p:txBody>
+      </p:sp>
+      <p:sp>
+        <p:nvSpPr>
+          <p:cNvPr id="5" name="">
+            <a:extLst xmlns:a="http://schemas.openxmlformats.org/drawingml/2006/main">
+              <a:ext uri="{FF2B5EF4-FFF2-40B4-BE49-F238E27FC236}">
+                <a16:creationId xmlns:a16="http://schemas.microsoft.com/office/drawing/2014/main" id="{25CDE85C-0166-4F93-915B-E654AF6EB0BD}"/>
               </a:ext>
             </a:extLst>
           </p:cNvPr>
@@ -6177,7 +6066,7 @@
       </p:sp>
       <p:graphicFrame>
         <p:nvGraphicFramePr>
-          <p:cNvPr id="19" name="Chart"/>
+          <p:cNvPr id="17" name="Chart"/>
           <p:cNvGraphicFramePr/>
           <p:nvPr/>
         </p:nvGraphicFramePr>
@@ -6187,16 +6076,16 @@
         </p:xfrm>
         <a:graphic xmlns:a="http://schemas.openxmlformats.org/drawingml/2006/main">
           <a:graphicData uri="http://schemas.openxmlformats.org/drawingml/2006/chart">
-            <c:chart xmlns:r="http://schemas.openxmlformats.org/officeDocument/2006/relationships" xmlns:c="http://schemas.openxmlformats.org/drawingml/2006/chart" r:id="R4a0fc1cb8dbb4b96"/>
+            <c:chart xmlns:r="http://schemas.openxmlformats.org/officeDocument/2006/relationships" xmlns:c="http://schemas.openxmlformats.org/drawingml/2006/chart" r:id="Rf2c84cedf87e4bd8"/>
           </a:graphicData>
         </a:graphic>
       </p:graphicFrame>
       <p:sp>
         <p:nvSpPr>
-          <p:cNvPr id="8" name="">
-            <a:extLst xmlns:a="http://schemas.openxmlformats.org/drawingml/2006/main">
-              <a:ext uri="{FF2B5EF4-FFF2-40B4-BE49-F238E27FC236}">
-                <a16:creationId xmlns:a16="http://schemas.microsoft.com/office/drawing/2014/main" id="{AA18D834-1615-4093-89FE-EBF4E93AC793}"/>
+          <p:cNvPr id="7" name="">
+            <a:extLst xmlns:a="http://schemas.openxmlformats.org/drawingml/2006/main">
+              <a:ext uri="{FF2B5EF4-FFF2-40B4-BE49-F238E27FC236}">
+                <a16:creationId xmlns:a16="http://schemas.microsoft.com/office/drawing/2014/main" id="{DDAF2DD1-4513-4332-BB76-E4683B966356}"/>
               </a:ext>
             </a:extLst>
           </p:cNvPr>
@@ -6243,17 +6132,17 @@
                 <a:ea typeface="Arial"/>
                 <a:cs typeface="Arial"/>
               </a:rPr>
-              <a:t>KEEP XGBOOST</a:t>
-            </a:r>
-          </a:p>
-        </p:txBody>
-      </p:sp>
-      <p:sp>
-        <p:nvSpPr>
-          <p:cNvPr id="9" name="">
-            <a:extLst xmlns:a="http://schemas.openxmlformats.org/drawingml/2006/main">
-              <a:ext uri="{FF2B5EF4-FFF2-40B4-BE49-F238E27FC236}">
-                <a16:creationId xmlns:a16="http://schemas.microsoft.com/office/drawing/2014/main" id="{6E599470-EB8C-433B-A4EF-1B3534374BFF}"/>
+              <a:t>KEEP AS A COMPONENT</a:t>
+            </a:r>
+          </a:p>
+        </p:txBody>
+      </p:sp>
+      <p:sp>
+        <p:nvSpPr>
+          <p:cNvPr id="8" name="">
+            <a:extLst xmlns:a="http://schemas.openxmlformats.org/drawingml/2006/main">
+              <a:ext uri="{FF2B5EF4-FFF2-40B4-BE49-F238E27FC236}">
+                <a16:creationId xmlns:a16="http://schemas.microsoft.com/office/drawing/2014/main" id="{B60CA3BF-6465-4DD2-BA4C-ECCECF8CEBF7}"/>
               </a:ext>
             </a:extLst>
           </p:cNvPr>
@@ -6280,10 +6169,10 @@
       </p:sp>
       <p:sp>
         <p:nvSpPr>
-          <p:cNvPr id="10" name="">
-            <a:extLst xmlns:a="http://schemas.openxmlformats.org/drawingml/2006/main">
-              <a:ext uri="{FF2B5EF4-FFF2-40B4-BE49-F238E27FC236}">
-                <a16:creationId xmlns:a16="http://schemas.microsoft.com/office/drawing/2014/main" id="{AE533E41-A92F-42F9-9A6C-5E140570C906}"/>
+          <p:cNvPr id="9" name="">
+            <a:extLst xmlns:a="http://schemas.openxmlformats.org/drawingml/2006/main">
+              <a:ext uri="{FF2B5EF4-FFF2-40B4-BE49-F238E27FC236}">
+                <a16:creationId xmlns:a16="http://schemas.microsoft.com/office/drawing/2014/main" id="{5C6E093A-7CDF-447B-93EF-26D18FF977F9}"/>
               </a:ext>
             </a:extLst>
           </p:cNvPr>
@@ -6383,10 +6272,10 @@
       </p:sp>
       <p:sp>
         <p:nvSpPr>
-          <p:cNvPr id="11" name="">
-            <a:extLst xmlns:a="http://schemas.openxmlformats.org/drawingml/2006/main">
-              <a:ext uri="{FF2B5EF4-FFF2-40B4-BE49-F238E27FC236}">
-                <a16:creationId xmlns:a16="http://schemas.microsoft.com/office/drawing/2014/main" id="{71C52290-505F-4615-8157-4B04CD593170}"/>
+          <p:cNvPr id="10" name="">
+            <a:extLst xmlns:a="http://schemas.openxmlformats.org/drawingml/2006/main">
+              <a:ext uri="{FF2B5EF4-FFF2-40B4-BE49-F238E27FC236}">
+                <a16:creationId xmlns:a16="http://schemas.microsoft.com/office/drawing/2014/main" id="{2CB236CE-F923-43C9-B04C-0AEA1F4A19A0}"/>
               </a:ext>
             </a:extLst>
           </p:cNvPr>
@@ -6433,7 +6322,7 @@
                 <a:ea typeface="Arial"/>
                 <a:cs typeface="Arial"/>
               </a:rPr>
-              <a:t>Next: measured water</a:t>
+              <a:t>Next: measured demand</a:t>
             </a:r>
           </a:p>
           <a:p xmlns:a="http://schemas.openxmlformats.org/drawingml/2006/main">
@@ -6456,17 +6345,17 @@
                 <a:ea typeface="Arial"/>
                 <a:cs typeface="Arial"/>
               </a:rPr>
-              <a:t>use at real facilities.</a:t>
-            </a:r>
-          </a:p>
-        </p:txBody>
-      </p:sp>
-      <p:sp>
-        <p:nvSpPr>
-          <p:cNvPr id="12" name="">
-            <a:extLst xmlns:a="http://schemas.openxmlformats.org/drawingml/2006/main">
-              <a:ext uri="{FF2B5EF4-FFF2-40B4-BE49-F238E27FC236}">
-                <a16:creationId xmlns:a16="http://schemas.microsoft.com/office/drawing/2014/main" id="{221865B4-FAE3-4CCD-8741-798D63F1FAE5}"/>
+              <a:t>and regional outcome data.</a:t>
+            </a:r>
+          </a:p>
+        </p:txBody>
+      </p:sp>
+      <p:sp>
+        <p:nvSpPr>
+          <p:cNvPr id="11" name="">
+            <a:extLst xmlns:a="http://schemas.openxmlformats.org/drawingml/2006/main">
+              <a:ext uri="{FF2B5EF4-FFF2-40B4-BE49-F238E27FC236}">
+                <a16:creationId xmlns:a16="http://schemas.microsoft.com/office/drawing/2014/main" id="{92DD3AF4-2876-4849-B282-E558F6EC7CA3}"/>
               </a:ext>
             </a:extLst>
           </p:cNvPr>
@@ -6544,7 +6433,7 @@
     </p:spTree>
     <p:extLst>
       <p:ext uri="{BB962C8B-B14F-4D97-AF65-F5344CB8AC3E}">
-        <p14:creationId xmlns:p14="http://schemas.microsoft.com/office/powerpoint/2010/main" val="15707172"/>
+        <p14:creationId xmlns:p14="http://schemas.microsoft.com/office/powerpoint/2010/main" val="1891366707"/>
       </p:ext>
     </p:extLst>
   </p:cSld>
@@ -6572,62 +6461,10 @@
       </p:grpSpPr>
       <p:sp>
         <p:nvSpPr>
-          <p:cNvPr id="15" name="">
-            <a:extLst xmlns:a="http://schemas.openxmlformats.org/drawingml/2006/main">
-              <a:ext uri="{FF2B5EF4-FFF2-40B4-BE49-F238E27FC236}">
-                <a16:creationId xmlns:a16="http://schemas.microsoft.com/office/drawing/2014/main" id="{1DC8FFAD-1C26-492E-B510-4555F272508A}"/>
-              </a:ext>
-            </a:extLst>
-          </p:cNvPr>
-          <p:cNvSpPr>
-            <a:spLocks xmlns:a="http://schemas.openxmlformats.org/drawingml/2006/main" noGrp="1"/>
-          </p:cNvSpPr>
-          <p:nvPr/>
-        </p:nvSpPr>
-        <p:spPr>
-          <a:xfrm xmlns:a="http://schemas.openxmlformats.org/drawingml/2006/main">
-            <a:off x="6286500" y="-619125"/>
-            <a:ext cx="4953000" cy="2857500"/>
-          </a:xfrm>
-          <a:prstGeom xmlns:a="http://schemas.openxmlformats.org/drawingml/2006/main" prst="ellipse">
-            <a:avLst/>
-          </a:prstGeom>
-          <a:gradFill xmlns:a="http://schemas.openxmlformats.org/drawingml/2006/main">
-            <a:gsLst>
-              <a:gs pos="0">
-                <a:srgbClr val="9382FF">
-                  <a:alpha val="45000"/>
-                </a:srgbClr>
-              </a:gs>
-              <a:gs pos="35000">
-                <a:srgbClr val="9382FF">
-                  <a:alpha val="18000"/>
-                </a:srgbClr>
-              </a:gs>
-              <a:gs pos="65000">
-                <a:srgbClr val="9382FF">
-                  <a:alpha val="4000"/>
-                </a:srgbClr>
-              </a:gs>
-              <a:gs pos="100000">
-                <a:srgbClr val="9382FF">
-                  <a:alpha val="0"/>
-                </a:srgbClr>
-              </a:gs>
-            </a:gsLst>
-            <a:path path="shape"/>
-          </a:gradFill>
-          <a:ln xmlns:a="http://schemas.openxmlformats.org/drawingml/2006/main" w="0">
-            <a:noFill/>
-          </a:ln>
-        </p:spPr>
-      </p:sp>
-      <p:sp>
-        <p:nvSpPr>
-          <p:cNvPr id="2" name="">
-            <a:extLst xmlns:a="http://schemas.openxmlformats.org/drawingml/2006/main">
-              <a:ext uri="{FF2B5EF4-FFF2-40B4-BE49-F238E27FC236}">
-                <a16:creationId xmlns:a16="http://schemas.microsoft.com/office/drawing/2014/main" id="{7B37859D-CB81-442C-A47C-4528AA81F6F0}"/>
+          <p:cNvPr id="14" name="">
+            <a:extLst xmlns:a="http://schemas.openxmlformats.org/drawingml/2006/main">
+              <a:ext uri="{FF2B5EF4-FFF2-40B4-BE49-F238E27FC236}">
+                <a16:creationId xmlns:a16="http://schemas.microsoft.com/office/drawing/2014/main" id="{3D0FEC48-A94A-48BB-9A28-D08F1DFAC4F7}"/>
               </a:ext>
             </a:extLst>
           </p:cNvPr>
@@ -6681,10 +6518,10 @@
       </p:sp>
       <p:sp>
         <p:nvSpPr>
-          <p:cNvPr id="3" name="">
-            <a:extLst xmlns:a="http://schemas.openxmlformats.org/drawingml/2006/main">
-              <a:ext uri="{FF2B5EF4-FFF2-40B4-BE49-F238E27FC236}">
-                <a16:creationId xmlns:a16="http://schemas.microsoft.com/office/drawing/2014/main" id="{2543A666-F0C4-4E3B-A0A7-68C68D5F0F82}"/>
+          <p:cNvPr id="2" name="">
+            <a:extLst xmlns:a="http://schemas.openxmlformats.org/drawingml/2006/main">
+              <a:ext uri="{FF2B5EF4-FFF2-40B4-BE49-F238E27FC236}">
+                <a16:creationId xmlns:a16="http://schemas.microsoft.com/office/drawing/2014/main" id="{7E767BAA-3A30-48C0-8E46-868864CA7442}"/>
               </a:ext>
             </a:extLst>
           </p:cNvPr>
@@ -6711,10 +6548,10 @@
       </p:sp>
       <p:sp>
         <p:nvSpPr>
-          <p:cNvPr id="4" name="">
-            <a:extLst xmlns:a="http://schemas.openxmlformats.org/drawingml/2006/main">
-              <a:ext uri="{FF2B5EF4-FFF2-40B4-BE49-F238E27FC236}">
-                <a16:creationId xmlns:a16="http://schemas.microsoft.com/office/drawing/2014/main" id="{C0392D66-5A9B-4C4F-B4ED-4D05945C6099}"/>
+          <p:cNvPr id="3" name="">
+            <a:extLst xmlns:a="http://schemas.openxmlformats.org/drawingml/2006/main">
+              <a:ext uri="{FF2B5EF4-FFF2-40B4-BE49-F238E27FC236}">
+                <a16:creationId xmlns:a16="http://schemas.microsoft.com/office/drawing/2014/main" id="{630376FB-8DB2-4E4A-B91B-564BDC4D12C0}"/>
               </a:ext>
             </a:extLst>
           </p:cNvPr>
@@ -6761,17 +6598,17 @@
                 <a:ea typeface="Georgia"/>
                 <a:cs typeface="Georgia"/>
               </a:rPr>
-              <a:t>SIMILAR NEARBY STATIONS MADE GAPS EASIER TO FILL</a:t>
-            </a:r>
-          </a:p>
-        </p:txBody>
-      </p:sp>
-      <p:sp>
-        <p:nvSpPr>
-          <p:cNvPr id="5" name="">
-            <a:extLst xmlns:a="http://schemas.openxmlformats.org/drawingml/2006/main">
-              <a:ext uri="{FF2B5EF4-FFF2-40B4-BE49-F238E27FC236}">
-                <a16:creationId xmlns:a16="http://schemas.microsoft.com/office/drawing/2014/main" id="{19D3E0FC-9864-4015-B238-5DA571CA2078}"/>
+              <a:t>EXPERIMENT E2: GAPS &amp; BIASED NEIGHBORS</a:t>
+            </a:r>
+          </a:p>
+        </p:txBody>
+      </p:sp>
+      <p:sp>
+        <p:nvSpPr>
+          <p:cNvPr id="4" name="">
+            <a:extLst xmlns:a="http://schemas.openxmlformats.org/drawingml/2006/main">
+              <a:ext uri="{FF2B5EF4-FFF2-40B4-BE49-F238E27FC236}">
+                <a16:creationId xmlns:a16="http://schemas.microsoft.com/office/drawing/2014/main" id="{90B7BBD2-FF6D-4998-86FB-26DDFAD8C664}"/>
               </a:ext>
             </a:extLst>
           </p:cNvPr>
@@ -6818,17 +6655,17 @@
                 <a:ea typeface="Arial"/>
                 <a:cs typeface="Arial"/>
               </a:rPr>
-              <a:t>E2: missingness-summary.csv; biased-donor-diagnostic.csv | Main test uses trained AI and made-up river data</a:t>
-            </a:r>
-          </a:p>
-        </p:txBody>
-      </p:sp>
-      <p:sp>
-        <p:nvSpPr>
-          <p:cNvPr id="6" name="">
-            <a:extLst xmlns:a="http://schemas.openxmlformats.org/drawingml/2006/main">
-              <a:ext uri="{FF2B5EF4-FFF2-40B4-BE49-F238E27FC236}">
-                <a16:creationId xmlns:a16="http://schemas.microsoft.com/office/drawing/2014/main" id="{17ECD2FC-5C3C-4BB6-927D-F17BB2A452CA}"/>
+              <a:t>Evidence: E2: missingness-summary.csv; biased-donor-diagnostic.csv | Main test uses trained AI and made-up river data</a:t>
+            </a:r>
+          </a:p>
+        </p:txBody>
+      </p:sp>
+      <p:sp>
+        <p:nvSpPr>
+          <p:cNvPr id="5" name="">
+            <a:extLst xmlns:a="http://schemas.openxmlformats.org/drawingml/2006/main">
+              <a:ext uri="{FF2B5EF4-FFF2-40B4-BE49-F238E27FC236}">
+                <a16:creationId xmlns:a16="http://schemas.microsoft.com/office/drawing/2014/main" id="{EC0D65D0-4941-4884-8EF3-85B69EF3570F}"/>
               </a:ext>
             </a:extLst>
           </p:cNvPr>
@@ -6882,7 +6719,7 @@
       </p:sp>
       <p:graphicFrame>
         <p:nvGraphicFramePr>
-          <p:cNvPr id="21" name="Chart"/>
+          <p:cNvPr id="19" name="Chart"/>
           <p:cNvGraphicFramePr/>
           <p:nvPr/>
         </p:nvGraphicFramePr>
@@ -6892,16 +6729,16 @@
         </p:xfrm>
         <a:graphic xmlns:a="http://schemas.openxmlformats.org/drawingml/2006/main">
           <a:graphicData uri="http://schemas.openxmlformats.org/drawingml/2006/chart">
-            <c:chart xmlns:r="http://schemas.openxmlformats.org/officeDocument/2006/relationships" xmlns:c="http://schemas.openxmlformats.org/drawingml/2006/chart" r:id="R1ce7c6edd7c147cf"/>
+            <c:chart xmlns:r="http://schemas.openxmlformats.org/officeDocument/2006/relationships" xmlns:c="http://schemas.openxmlformats.org/drawingml/2006/chart" r:id="Rf9339be411ae4be1"/>
           </a:graphicData>
         </a:graphic>
       </p:graphicFrame>
       <p:sp>
         <p:nvSpPr>
-          <p:cNvPr id="8" name="">
-            <a:extLst xmlns:a="http://schemas.openxmlformats.org/drawingml/2006/main">
-              <a:ext uri="{FF2B5EF4-FFF2-40B4-BE49-F238E27FC236}">
-                <a16:creationId xmlns:a16="http://schemas.microsoft.com/office/drawing/2014/main" id="{9A9F0A3F-4ECD-498D-812E-8554F8DBF0B1}"/>
+          <p:cNvPr id="7" name="">
+            <a:extLst xmlns:a="http://schemas.openxmlformats.org/drawingml/2006/main">
+              <a:ext uri="{FF2B5EF4-FFF2-40B4-BE49-F238E27FC236}">
+                <a16:creationId xmlns:a16="http://schemas.microsoft.com/office/drawing/2014/main" id="{3AC591CC-A76F-438F-9A15-C927EDDA8389}"/>
               </a:ext>
             </a:extLst>
           </p:cNvPr>
@@ -6955,10 +6792,10 @@
       </p:sp>
       <p:sp>
         <p:nvSpPr>
-          <p:cNvPr id="9" name="">
-            <a:extLst xmlns:a="http://schemas.openxmlformats.org/drawingml/2006/main">
-              <a:ext uri="{FF2B5EF4-FFF2-40B4-BE49-F238E27FC236}">
-                <a16:creationId xmlns:a16="http://schemas.microsoft.com/office/drawing/2014/main" id="{D006C042-243A-43AB-9F59-F1F46CAD5155}"/>
+          <p:cNvPr id="8" name="">
+            <a:extLst xmlns:a="http://schemas.openxmlformats.org/drawingml/2006/main">
+              <a:ext uri="{FF2B5EF4-FFF2-40B4-BE49-F238E27FC236}">
+                <a16:creationId xmlns:a16="http://schemas.microsoft.com/office/drawing/2014/main" id="{DD79EF7F-587A-4E78-A718-C07060B23C00}"/>
               </a:ext>
             </a:extLst>
           </p:cNvPr>
@@ -6985,10 +6822,10 @@
       </p:sp>
       <p:sp>
         <p:nvSpPr>
-          <p:cNvPr id="10" name="">
-            <a:extLst xmlns:a="http://schemas.openxmlformats.org/drawingml/2006/main">
-              <a:ext uri="{FF2B5EF4-FFF2-40B4-BE49-F238E27FC236}">
-                <a16:creationId xmlns:a16="http://schemas.microsoft.com/office/drawing/2014/main" id="{1D42175D-3F21-4C91-BC9E-077543E12458}"/>
+          <p:cNvPr id="9" name="">
+            <a:extLst xmlns:a="http://schemas.openxmlformats.org/drawingml/2006/main">
+              <a:ext uri="{FF2B5EF4-FFF2-40B4-BE49-F238E27FC236}">
+                <a16:creationId xmlns:a16="http://schemas.microsoft.com/office/drawing/2014/main" id="{9750F6DF-D5C8-4596-971C-FDE32CF6A320}"/>
               </a:ext>
             </a:extLst>
           </p:cNvPr>
@@ -7042,10 +6879,10 @@
       </p:sp>
       <p:sp>
         <p:nvSpPr>
-          <p:cNvPr id="11" name="">
-            <a:extLst xmlns:a="http://schemas.openxmlformats.org/drawingml/2006/main">
-              <a:ext uri="{FF2B5EF4-FFF2-40B4-BE49-F238E27FC236}">
-                <a16:creationId xmlns:a16="http://schemas.microsoft.com/office/drawing/2014/main" id="{9226F6BB-7C52-476D-97E4-C02313BFAE33}"/>
+          <p:cNvPr id="10" name="">
+            <a:extLst xmlns:a="http://schemas.openxmlformats.org/drawingml/2006/main">
+              <a:ext uri="{FF2B5EF4-FFF2-40B4-BE49-F238E27FC236}">
+                <a16:creationId xmlns:a16="http://schemas.microsoft.com/office/drawing/2014/main" id="{0B77CE7A-158D-425E-849C-011DD70446EE}"/>
               </a:ext>
             </a:extLst>
           </p:cNvPr>
@@ -7122,10 +6959,10 @@
       </p:sp>
       <p:sp>
         <p:nvSpPr>
-          <p:cNvPr id="12" name="">
-            <a:extLst xmlns:a="http://schemas.openxmlformats.org/drawingml/2006/main">
-              <a:ext uri="{FF2B5EF4-FFF2-40B4-BE49-F238E27FC236}">
-                <a16:creationId xmlns:a16="http://schemas.microsoft.com/office/drawing/2014/main" id="{922B318C-2AB2-4568-8747-593B86B2B00F}"/>
+          <p:cNvPr id="11" name="">
+            <a:extLst xmlns:a="http://schemas.openxmlformats.org/drawingml/2006/main">
+              <a:ext uri="{FF2B5EF4-FFF2-40B4-BE49-F238E27FC236}">
+                <a16:creationId xmlns:a16="http://schemas.microsoft.com/office/drawing/2014/main" id="{D0B3EE25-CD15-4A33-AFBB-0622FAF68FB0}"/>
               </a:ext>
             </a:extLst>
           </p:cNvPr>
@@ -7152,10 +6989,10 @@
       </p:sp>
       <p:sp>
         <p:nvSpPr>
-          <p:cNvPr id="13" name="">
-            <a:extLst xmlns:a="http://schemas.openxmlformats.org/drawingml/2006/main">
-              <a:ext uri="{FF2B5EF4-FFF2-40B4-BE49-F238E27FC236}">
-                <a16:creationId xmlns:a16="http://schemas.microsoft.com/office/drawing/2014/main" id="{EFDF873C-0B25-4D67-A802-03B3742537BC}"/>
+          <p:cNvPr id="12" name="">
+            <a:extLst xmlns:a="http://schemas.openxmlformats.org/drawingml/2006/main">
+              <a:ext uri="{FF2B5EF4-FFF2-40B4-BE49-F238E27FC236}">
+                <a16:creationId xmlns:a16="http://schemas.microsoft.com/office/drawing/2014/main" id="{14CD58FC-FBAD-4FE9-982B-57CAB0E6A892}"/>
               </a:ext>
             </a:extLst>
           </p:cNvPr>
@@ -7202,7 +7039,7 @@
                 <a:ea typeface="Arial"/>
                 <a:cs typeface="Arial"/>
               </a:rPr>
-              <a:t>Biased-neighbor test:</a:t>
+              <a:t>FAILURE: biased neighbors</a:t>
             </a:r>
           </a:p>
           <a:p xmlns:a="http://schemas.openxmlformats.org/drawingml/2006/main">
@@ -7232,10 +7069,10 @@
       </p:sp>
       <p:sp>
         <p:nvSpPr>
-          <p:cNvPr id="14" name="">
-            <a:extLst xmlns:a="http://schemas.openxmlformats.org/drawingml/2006/main">
-              <a:ext uri="{FF2B5EF4-FFF2-40B4-BE49-F238E27FC236}">
-                <a16:creationId xmlns:a16="http://schemas.microsoft.com/office/drawing/2014/main" id="{303FD4D8-5906-45AB-8F15-A4D1116CEE2B}"/>
+          <p:cNvPr id="13" name="">
+            <a:extLst xmlns:a="http://schemas.openxmlformats.org/drawingml/2006/main">
+              <a:ext uri="{FF2B5EF4-FFF2-40B4-BE49-F238E27FC236}">
+                <a16:creationId xmlns:a16="http://schemas.microsoft.com/office/drawing/2014/main" id="{8E91A626-6F99-49BE-8AA7-9EBFB81F4BDD}"/>
               </a:ext>
             </a:extLst>
           </p:cNvPr>
@@ -7290,7 +7127,7 @@
     </p:spTree>
     <p:extLst>
       <p:ext uri="{BB962C8B-B14F-4D97-AF65-F5344CB8AC3E}">
-        <p14:creationId xmlns:p14="http://schemas.microsoft.com/office/powerpoint/2010/main" val="1428171539"/>
+        <p14:creationId xmlns:p14="http://schemas.microsoft.com/office/powerpoint/2010/main" val="1501487678"/>
       </p:ext>
     </p:extLst>
   </p:cSld>
@@ -7318,62 +7155,10 @@
       </p:grpSpPr>
       <p:sp>
         <p:nvSpPr>
-          <p:cNvPr id="15" name="">
-            <a:extLst xmlns:a="http://schemas.openxmlformats.org/drawingml/2006/main">
-              <a:ext uri="{FF2B5EF4-FFF2-40B4-BE49-F238E27FC236}">
-                <a16:creationId xmlns:a16="http://schemas.microsoft.com/office/drawing/2014/main" id="{77D521AD-F4C8-4D70-8BFE-EB0EA80D57A9}"/>
-              </a:ext>
-            </a:extLst>
-          </p:cNvPr>
-          <p:cNvSpPr>
-            <a:spLocks xmlns:a="http://schemas.openxmlformats.org/drawingml/2006/main" noGrp="1"/>
-          </p:cNvSpPr>
-          <p:nvPr/>
-        </p:nvSpPr>
-        <p:spPr>
-          <a:xfrm xmlns:a="http://schemas.openxmlformats.org/drawingml/2006/main">
-            <a:off x="6286500" y="-619125"/>
-            <a:ext cx="4953000" cy="2857500"/>
-          </a:xfrm>
-          <a:prstGeom xmlns:a="http://schemas.openxmlformats.org/drawingml/2006/main" prst="ellipse">
-            <a:avLst/>
-          </a:prstGeom>
-          <a:gradFill xmlns:a="http://schemas.openxmlformats.org/drawingml/2006/main">
-            <a:gsLst>
-              <a:gs pos="0">
-                <a:srgbClr val="9382FF">
-                  <a:alpha val="45000"/>
-                </a:srgbClr>
-              </a:gs>
-              <a:gs pos="35000">
-                <a:srgbClr val="9382FF">
-                  <a:alpha val="18000"/>
-                </a:srgbClr>
-              </a:gs>
-              <a:gs pos="65000">
-                <a:srgbClr val="9382FF">
-                  <a:alpha val="4000"/>
-                </a:srgbClr>
-              </a:gs>
-              <a:gs pos="100000">
-                <a:srgbClr val="9382FF">
-                  <a:alpha val="0"/>
-                </a:srgbClr>
-              </a:gs>
-            </a:gsLst>
-            <a:path path="shape"/>
-          </a:gradFill>
-          <a:ln xmlns:a="http://schemas.openxmlformats.org/drawingml/2006/main" w="0">
-            <a:noFill/>
-          </a:ln>
-        </p:spPr>
-      </p:sp>
-      <p:sp>
-        <p:nvSpPr>
-          <p:cNvPr id="2" name="">
-            <a:extLst xmlns:a="http://schemas.openxmlformats.org/drawingml/2006/main">
-              <a:ext uri="{FF2B5EF4-FFF2-40B4-BE49-F238E27FC236}">
-                <a16:creationId xmlns:a16="http://schemas.microsoft.com/office/drawing/2014/main" id="{55188893-62A5-4EA9-BC65-8B12FBC18746}"/>
+          <p:cNvPr id="14" name="">
+            <a:extLst xmlns:a="http://schemas.openxmlformats.org/drawingml/2006/main">
+              <a:ext uri="{FF2B5EF4-FFF2-40B4-BE49-F238E27FC236}">
+                <a16:creationId xmlns:a16="http://schemas.microsoft.com/office/drawing/2014/main" id="{4683A881-EEF2-46C7-A480-747D5AEF8538}"/>
               </a:ext>
             </a:extLst>
           </p:cNvPr>
@@ -7427,10 +7212,10 @@
       </p:sp>
       <p:sp>
         <p:nvSpPr>
-          <p:cNvPr id="3" name="">
-            <a:extLst xmlns:a="http://schemas.openxmlformats.org/drawingml/2006/main">
-              <a:ext uri="{FF2B5EF4-FFF2-40B4-BE49-F238E27FC236}">
-                <a16:creationId xmlns:a16="http://schemas.microsoft.com/office/drawing/2014/main" id="{2C3F91FB-4895-494B-B707-FD7848B00ED6}"/>
+          <p:cNvPr id="2" name="">
+            <a:extLst xmlns:a="http://schemas.openxmlformats.org/drawingml/2006/main">
+              <a:ext uri="{FF2B5EF4-FFF2-40B4-BE49-F238E27FC236}">
+                <a16:creationId xmlns:a16="http://schemas.microsoft.com/office/drawing/2014/main" id="{62FC00F8-74CC-47F9-AFEE-3823CD35916D}"/>
               </a:ext>
             </a:extLst>
           </p:cNvPr>
@@ -7457,10 +7242,10 @@
       </p:sp>
       <p:sp>
         <p:nvSpPr>
-          <p:cNvPr id="4" name="">
-            <a:extLst xmlns:a="http://schemas.openxmlformats.org/drawingml/2006/main">
-              <a:ext uri="{FF2B5EF4-FFF2-40B4-BE49-F238E27FC236}">
-                <a16:creationId xmlns:a16="http://schemas.microsoft.com/office/drawing/2014/main" id="{FBF7F8C2-D53A-4D7B-84EA-24EA23C73E78}"/>
+          <p:cNvPr id="3" name="">
+            <a:extLst xmlns:a="http://schemas.openxmlformats.org/drawingml/2006/main">
+              <a:ext uri="{FF2B5EF4-FFF2-40B4-BE49-F238E27FC236}">
+                <a16:creationId xmlns:a16="http://schemas.microsoft.com/office/drawing/2014/main" id="{8EE063EB-1385-4ED7-A96B-235C831BEBCC}"/>
               </a:ext>
             </a:extLst>
           </p:cNvPr>
@@ -7507,17 +7292,17 @@
                 <a:ea typeface="Georgia"/>
                 <a:cs typeface="Georgia"/>
               </a:rPr>
-              <a:t>THE PREDICTION RANGES MISSED OUR 90% GOAL</a:t>
-            </a:r>
-          </a:p>
-        </p:txBody>
-      </p:sp>
-      <p:sp>
-        <p:nvSpPr>
-          <p:cNvPr id="5" name="">
-            <a:extLst xmlns:a="http://schemas.openxmlformats.org/drawingml/2006/main">
-              <a:ext uri="{FF2B5EF4-FFF2-40B4-BE49-F238E27FC236}">
-                <a16:creationId xmlns:a16="http://schemas.microsoft.com/office/drawing/2014/main" id="{CA02A12D-D066-41FB-AEC9-BAA0D9939565}"/>
+              <a:t>EXPERIMENT E5: RANGE RELIABILITY</a:t>
+            </a:r>
+          </a:p>
+        </p:txBody>
+      </p:sp>
+      <p:sp>
+        <p:nvSpPr>
+          <p:cNvPr id="4" name="">
+            <a:extLst xmlns:a="http://schemas.openxmlformats.org/drawingml/2006/main">
+              <a:ext uri="{FF2B5EF4-FFF2-40B4-BE49-F238E27FC236}">
+                <a16:creationId xmlns:a16="http://schemas.microsoft.com/office/drawing/2014/main" id="{FBA1ADA8-7FB9-41B0-BC84-6D1875E4710E}"/>
               </a:ext>
             </a:extLst>
           </p:cNvPr>
@@ -7564,17 +7349,17 @@
                 <a:ea typeface="Arial"/>
                 <a:cs typeface="Arial"/>
               </a:rPr>
-              <a:t>E5: interval-coverage.csv; benchmark.json | Made-up test values; 333 per model</a:t>
-            </a:r>
-          </a:p>
-        </p:txBody>
-      </p:sp>
-      <p:sp>
-        <p:nvSpPr>
-          <p:cNvPr id="6" name="">
-            <a:extLst xmlns:a="http://schemas.openxmlformats.org/drawingml/2006/main">
-              <a:ext uri="{FF2B5EF4-FFF2-40B4-BE49-F238E27FC236}">
-                <a16:creationId xmlns:a16="http://schemas.microsoft.com/office/drawing/2014/main" id="{3EC6D07B-BA85-4176-AA0D-35D53212FA4B}"/>
+              <a:t>Evidence: E5: interval-coverage.csv; benchmark.json | Made-up test values; 333 per model</a:t>
+            </a:r>
+          </a:p>
+        </p:txBody>
+      </p:sp>
+      <p:sp>
+        <p:nvSpPr>
+          <p:cNvPr id="5" name="">
+            <a:extLst xmlns:a="http://schemas.openxmlformats.org/drawingml/2006/main">
+              <a:ext uri="{FF2B5EF4-FFF2-40B4-BE49-F238E27FC236}">
+                <a16:creationId xmlns:a16="http://schemas.microsoft.com/office/drawing/2014/main" id="{DC717C26-850F-4671-89A3-8965AA1E32BF}"/>
               </a:ext>
             </a:extLst>
           </p:cNvPr>
@@ -7628,7 +7413,7 @@
       </p:sp>
       <p:graphicFrame>
         <p:nvGraphicFramePr>
-          <p:cNvPr id="21" name="Chart"/>
+          <p:cNvPr id="19" name="Chart"/>
           <p:cNvGraphicFramePr/>
           <p:nvPr/>
         </p:nvGraphicFramePr>
@@ -7638,16 +7423,16 @@
         </p:xfrm>
         <a:graphic xmlns:a="http://schemas.openxmlformats.org/drawingml/2006/main">
           <a:graphicData uri="http://schemas.openxmlformats.org/drawingml/2006/chart">
-            <c:chart xmlns:r="http://schemas.openxmlformats.org/officeDocument/2006/relationships" xmlns:c="http://schemas.openxmlformats.org/drawingml/2006/chart" r:id="Rde7c8e65c9824a65"/>
+            <c:chart xmlns:r="http://schemas.openxmlformats.org/officeDocument/2006/relationships" xmlns:c="http://schemas.openxmlformats.org/drawingml/2006/chart" r:id="Rdcdc181d0ac6455f"/>
           </a:graphicData>
         </a:graphic>
       </p:graphicFrame>
       <p:sp>
         <p:nvSpPr>
-          <p:cNvPr id="8" name="">
-            <a:extLst xmlns:a="http://schemas.openxmlformats.org/drawingml/2006/main">
-              <a:ext uri="{FF2B5EF4-FFF2-40B4-BE49-F238E27FC236}">
-                <a16:creationId xmlns:a16="http://schemas.microsoft.com/office/drawing/2014/main" id="{BB72E7A2-FDA2-4394-8991-5A81A8DCF654}"/>
+          <p:cNvPr id="7" name="">
+            <a:extLst xmlns:a="http://schemas.openxmlformats.org/drawingml/2006/main">
+              <a:ext uri="{FF2B5EF4-FFF2-40B4-BE49-F238E27FC236}">
+                <a16:creationId xmlns:a16="http://schemas.microsoft.com/office/drawing/2014/main" id="{49AE5CAC-993C-4627-A287-C1F2AD40C7B5}"/>
               </a:ext>
             </a:extLst>
           </p:cNvPr>
@@ -7701,10 +7486,10 @@
       </p:sp>
       <p:sp>
         <p:nvSpPr>
-          <p:cNvPr id="9" name="">
-            <a:extLst xmlns:a="http://schemas.openxmlformats.org/drawingml/2006/main">
-              <a:ext uri="{FF2B5EF4-FFF2-40B4-BE49-F238E27FC236}">
-                <a16:creationId xmlns:a16="http://schemas.microsoft.com/office/drawing/2014/main" id="{F81F5F7A-665D-43FE-8FE0-D6A4200C90EA}"/>
+          <p:cNvPr id="8" name="">
+            <a:extLst xmlns:a="http://schemas.openxmlformats.org/drawingml/2006/main">
+              <a:ext uri="{FF2B5EF4-FFF2-40B4-BE49-F238E27FC236}">
+                <a16:creationId xmlns:a16="http://schemas.microsoft.com/office/drawing/2014/main" id="{6BEA2A38-B653-4AD7-9729-4B454EDC52FC}"/>
               </a:ext>
             </a:extLst>
           </p:cNvPr>
@@ -7731,10 +7516,10 @@
       </p:sp>
       <p:sp>
         <p:nvSpPr>
-          <p:cNvPr id="10" name="">
-            <a:extLst xmlns:a="http://schemas.openxmlformats.org/drawingml/2006/main">
-              <a:ext uri="{FF2B5EF4-FFF2-40B4-BE49-F238E27FC236}">
-                <a16:creationId xmlns:a16="http://schemas.microsoft.com/office/drawing/2014/main" id="{903D6D8A-45AF-4A1A-821B-AA9FA85EBF4B}"/>
+          <p:cNvPr id="9" name="">
+            <a:extLst xmlns:a="http://schemas.openxmlformats.org/drawingml/2006/main">
+              <a:ext uri="{FF2B5EF4-FFF2-40B4-BE49-F238E27FC236}">
+                <a16:creationId xmlns:a16="http://schemas.microsoft.com/office/drawing/2014/main" id="{444666B0-3898-4086-9EAA-492D5557B982}"/>
               </a:ext>
             </a:extLst>
           </p:cNvPr>
@@ -7781,17 +7566,17 @@
                 <a:ea typeface="Arial"/>
                 <a:cs typeface="Arial"/>
               </a:rPr>
-              <a:t>Tower / direct evaporative coverage</a:t>
-            </a:r>
-          </a:p>
-        </p:txBody>
-      </p:sp>
-      <p:sp>
-        <p:nvSpPr>
-          <p:cNvPr id="11" name="">
-            <a:extLst xmlns:a="http://schemas.openxmlformats.org/drawingml/2006/main">
-              <a:ext uri="{FF2B5EF4-FFF2-40B4-BE49-F238E27FC236}">
-                <a16:creationId xmlns:a16="http://schemas.microsoft.com/office/drawing/2014/main" id="{F11D69C6-CBB2-4715-9278-9E02F734A0BC}"/>
+              <a:t>RELIABILITY ISSUE: below the 90% goal</a:t>
+            </a:r>
+          </a:p>
+        </p:txBody>
+      </p:sp>
+      <p:sp>
+        <p:nvSpPr>
+          <p:cNvPr id="10" name="">
+            <a:extLst xmlns:a="http://schemas.openxmlformats.org/drawingml/2006/main">
+              <a:ext uri="{FF2B5EF4-FFF2-40B4-BE49-F238E27FC236}">
+                <a16:creationId xmlns:a16="http://schemas.microsoft.com/office/drawing/2014/main" id="{0D0808BF-0FD8-4A08-9D41-FDA5C2BA1514}"/>
               </a:ext>
             </a:extLst>
           </p:cNvPr>
@@ -7868,10 +7653,10 @@
       </p:sp>
       <p:sp>
         <p:nvSpPr>
-          <p:cNvPr id="12" name="">
-            <a:extLst xmlns:a="http://schemas.openxmlformats.org/drawingml/2006/main">
-              <a:ext uri="{FF2B5EF4-FFF2-40B4-BE49-F238E27FC236}">
-                <a16:creationId xmlns:a16="http://schemas.microsoft.com/office/drawing/2014/main" id="{7475E6C9-DCE1-4122-8194-38FAB39C973E}"/>
+          <p:cNvPr id="11" name="">
+            <a:extLst xmlns:a="http://schemas.openxmlformats.org/drawingml/2006/main">
+              <a:ext uri="{FF2B5EF4-FFF2-40B4-BE49-F238E27FC236}">
+                <a16:creationId xmlns:a16="http://schemas.microsoft.com/office/drawing/2014/main" id="{C3004477-6BB4-435D-A561-717015FD45EA}"/>
               </a:ext>
             </a:extLst>
           </p:cNvPr>
@@ -7898,10 +7683,10 @@
       </p:sp>
       <p:sp>
         <p:nvSpPr>
-          <p:cNvPr id="13" name="">
-            <a:extLst xmlns:a="http://schemas.openxmlformats.org/drawingml/2006/main">
-              <a:ext uri="{FF2B5EF4-FFF2-40B4-BE49-F238E27FC236}">
-                <a16:creationId xmlns:a16="http://schemas.microsoft.com/office/drawing/2014/main" id="{B1D2AEBD-DD89-4728-92B0-4A8E538C11D2}"/>
+          <p:cNvPr id="12" name="">
+            <a:extLst xmlns:a="http://schemas.openxmlformats.org/drawingml/2006/main">
+              <a:ext uri="{FF2B5EF4-FFF2-40B4-BE49-F238E27FC236}">
+                <a16:creationId xmlns:a16="http://schemas.microsoft.com/office/drawing/2014/main" id="{9201E195-5392-433A-8456-DFA064C7C529}"/>
               </a:ext>
             </a:extLst>
           </p:cNvPr>
@@ -7955,10 +7740,10 @@
       </p:sp>
       <p:sp>
         <p:nvSpPr>
-          <p:cNvPr id="14" name="">
-            <a:extLst xmlns:a="http://schemas.openxmlformats.org/drawingml/2006/main">
-              <a:ext uri="{FF2B5EF4-FFF2-40B4-BE49-F238E27FC236}">
-                <a16:creationId xmlns:a16="http://schemas.microsoft.com/office/drawing/2014/main" id="{A7EE73B8-354B-4892-9930-8E3176D5774C}"/>
+          <p:cNvPr id="13" name="">
+            <a:extLst xmlns:a="http://schemas.openxmlformats.org/drawingml/2006/main">
+              <a:ext uri="{FF2B5EF4-FFF2-40B4-BE49-F238E27FC236}">
+                <a16:creationId xmlns:a16="http://schemas.microsoft.com/office/drawing/2014/main" id="{1499A5B9-E44B-4507-8473-D6C4CCBE9A59}"/>
               </a:ext>
             </a:extLst>
           </p:cNvPr>
@@ -8013,7 +7798,7 @@
     </p:spTree>
     <p:extLst>
       <p:ext uri="{BB962C8B-B14F-4D97-AF65-F5344CB8AC3E}">
-        <p14:creationId xmlns:p14="http://schemas.microsoft.com/office/powerpoint/2010/main" val="1808393083"/>
+        <p14:creationId xmlns:p14="http://schemas.microsoft.com/office/powerpoint/2010/main" val="375864447"/>
       </p:ext>
     </p:extLst>
   </p:cSld>
@@ -8041,62 +7826,10 @@
       </p:grpSpPr>
       <p:sp>
         <p:nvSpPr>
-          <p:cNvPr id="21" name="">
-            <a:extLst xmlns:a="http://schemas.openxmlformats.org/drawingml/2006/main">
-              <a:ext uri="{FF2B5EF4-FFF2-40B4-BE49-F238E27FC236}">
-                <a16:creationId xmlns:a16="http://schemas.microsoft.com/office/drawing/2014/main" id="{5ABD2304-EAAF-4990-9890-1360170C3165}"/>
-              </a:ext>
-            </a:extLst>
-          </p:cNvPr>
-          <p:cNvSpPr>
-            <a:spLocks xmlns:a="http://schemas.openxmlformats.org/drawingml/2006/main" noGrp="1"/>
-          </p:cNvSpPr>
-          <p:nvPr/>
-        </p:nvSpPr>
-        <p:spPr>
-          <a:xfrm xmlns:a="http://schemas.openxmlformats.org/drawingml/2006/main">
-            <a:off x="6286500" y="-619125"/>
-            <a:ext cx="4953000" cy="2857500"/>
-          </a:xfrm>
-          <a:prstGeom xmlns:a="http://schemas.openxmlformats.org/drawingml/2006/main" prst="ellipse">
-            <a:avLst/>
-          </a:prstGeom>
-          <a:gradFill xmlns:a="http://schemas.openxmlformats.org/drawingml/2006/main">
-            <a:gsLst>
-              <a:gs pos="0">
-                <a:srgbClr val="9382FF">
-                  <a:alpha val="45000"/>
-                </a:srgbClr>
-              </a:gs>
-              <a:gs pos="35000">
-                <a:srgbClr val="9382FF">
-                  <a:alpha val="18000"/>
-                </a:srgbClr>
-              </a:gs>
-              <a:gs pos="65000">
-                <a:srgbClr val="9382FF">
-                  <a:alpha val="4000"/>
-                </a:srgbClr>
-              </a:gs>
-              <a:gs pos="100000">
-                <a:srgbClr val="9382FF">
-                  <a:alpha val="0"/>
-                </a:srgbClr>
-              </a:gs>
-            </a:gsLst>
-            <a:path path="shape"/>
-          </a:gradFill>
-          <a:ln xmlns:a="http://schemas.openxmlformats.org/drawingml/2006/main" w="0">
-            <a:noFill/>
-          </a:ln>
-        </p:spPr>
-      </p:sp>
-      <p:sp>
-        <p:nvSpPr>
-          <p:cNvPr id="2" name="">
-            <a:extLst xmlns:a="http://schemas.openxmlformats.org/drawingml/2006/main">
-              <a:ext uri="{FF2B5EF4-FFF2-40B4-BE49-F238E27FC236}">
-                <a16:creationId xmlns:a16="http://schemas.microsoft.com/office/drawing/2014/main" id="{75D611AA-E3F5-4ACA-94AE-A7EEBE433418}"/>
+          <p:cNvPr id="20" name="">
+            <a:extLst xmlns:a="http://schemas.openxmlformats.org/drawingml/2006/main">
+              <a:ext uri="{FF2B5EF4-FFF2-40B4-BE49-F238E27FC236}">
+                <a16:creationId xmlns:a16="http://schemas.microsoft.com/office/drawing/2014/main" id="{EDE9A87B-EA44-411C-BCC5-C0964E03A63D}"/>
               </a:ext>
             </a:extLst>
           </p:cNvPr>
@@ -8150,10 +7883,10 @@
       </p:sp>
       <p:sp>
         <p:nvSpPr>
-          <p:cNvPr id="3" name="">
-            <a:extLst xmlns:a="http://schemas.openxmlformats.org/drawingml/2006/main">
-              <a:ext uri="{FF2B5EF4-FFF2-40B4-BE49-F238E27FC236}">
-                <a16:creationId xmlns:a16="http://schemas.microsoft.com/office/drawing/2014/main" id="{6F28421F-0D97-4E59-94AF-5D84E89DC6E2}"/>
+          <p:cNvPr id="2" name="">
+            <a:extLst xmlns:a="http://schemas.openxmlformats.org/drawingml/2006/main">
+              <a:ext uri="{FF2B5EF4-FFF2-40B4-BE49-F238E27FC236}">
+                <a16:creationId xmlns:a16="http://schemas.microsoft.com/office/drawing/2014/main" id="{DE1E3C6F-8780-4A30-AA55-46609677E719}"/>
               </a:ext>
             </a:extLst>
           </p:cNvPr>
@@ -8180,10 +7913,10 @@
       </p:sp>
       <p:sp>
         <p:nvSpPr>
-          <p:cNvPr id="4" name="">
-            <a:extLst xmlns:a="http://schemas.openxmlformats.org/drawingml/2006/main">
-              <a:ext uri="{FF2B5EF4-FFF2-40B4-BE49-F238E27FC236}">
-                <a16:creationId xmlns:a16="http://schemas.microsoft.com/office/drawing/2014/main" id="{6A9892A3-ABE5-4BE7-8ED9-C506715978A2}"/>
+          <p:cNvPr id="3" name="">
+            <a:extLst xmlns:a="http://schemas.openxmlformats.org/drawingml/2006/main">
+              <a:ext uri="{FF2B5EF4-FFF2-40B4-BE49-F238E27FC236}">
+                <a16:creationId xmlns:a16="http://schemas.microsoft.com/office/drawing/2014/main" id="{F09BEE68-B9BF-45E6-95FF-4F4B062F9A36}"/>
               </a:ext>
             </a:extLst>
           </p:cNvPr>
@@ -8230,17 +7963,17 @@
                 <a:ea typeface="Georgia"/>
                 <a:cs typeface="Georgia"/>
               </a:rPr>
-              <a:t>NEXT: TEST REAL WATER USE AT A NEW FACILITY</a:t>
-            </a:r>
-          </a:p>
-        </p:txBody>
-      </p:sp>
-      <p:sp>
-        <p:nvSpPr>
-          <p:cNvPr id="5" name="">
-            <a:extLst xmlns:a="http://schemas.openxmlformats.org/drawingml/2006/main">
-              <a:ext uri="{FF2B5EF4-FFF2-40B4-BE49-F238E27FC236}">
-                <a16:creationId xmlns:a16="http://schemas.microsoft.com/office/drawing/2014/main" id="{A08B959E-B459-4307-8BD3-D68517969075}"/>
+              <a:t>DECISIONS &amp; NEXT QUESTION</a:t>
+            </a:r>
+          </a:p>
+        </p:txBody>
+      </p:sp>
+      <p:sp>
+        <p:nvSpPr>
+          <p:cNvPr id="4" name="">
+            <a:extLst xmlns:a="http://schemas.openxmlformats.org/drawingml/2006/main">
+              <a:ext uri="{FF2B5EF4-FFF2-40B4-BE49-F238E27FC236}">
+                <a16:creationId xmlns:a16="http://schemas.microsoft.com/office/drawing/2014/main" id="{97E85B10-9781-4620-B673-88DE7F0FF99E}"/>
               </a:ext>
             </a:extLst>
           </p:cNvPr>
@@ -8294,10 +8027,10 @@
       </p:sp>
       <p:sp>
         <p:nvSpPr>
-          <p:cNvPr id="6" name="">
-            <a:extLst xmlns:a="http://schemas.openxmlformats.org/drawingml/2006/main">
-              <a:ext uri="{FF2B5EF4-FFF2-40B4-BE49-F238E27FC236}">
-                <a16:creationId xmlns:a16="http://schemas.microsoft.com/office/drawing/2014/main" id="{AF77D493-68D9-4A5F-AE5D-F27FA2D70C4B}"/>
+          <p:cNvPr id="5" name="">
+            <a:extLst xmlns:a="http://schemas.openxmlformats.org/drawingml/2006/main">
+              <a:ext uri="{FF2B5EF4-FFF2-40B4-BE49-F238E27FC236}">
+                <a16:creationId xmlns:a16="http://schemas.microsoft.com/office/drawing/2014/main" id="{C550670B-C8B3-48C4-A01F-F379B8317196}"/>
               </a:ext>
             </a:extLst>
           </p:cNvPr>
@@ -8351,22 +8084,22 @@
       </p:sp>
       <p:sp>
         <p:nvSpPr>
-          <p:cNvPr id="7" name="">
-            <a:extLst xmlns:a="http://schemas.openxmlformats.org/drawingml/2006/main">
-              <a:ext uri="{FF2B5EF4-FFF2-40B4-BE49-F238E27FC236}">
-                <a16:creationId xmlns:a16="http://schemas.microsoft.com/office/drawing/2014/main" id="{B8C5E1D4-DC2B-41B8-915D-7BAE661D0F1F}"/>
-              </a:ext>
-            </a:extLst>
-          </p:cNvPr>
-          <p:cNvSpPr>
-            <a:spLocks xmlns:a="http://schemas.openxmlformats.org/drawingml/2006/main" noGrp="1"/>
-          </p:cNvSpPr>
-          <p:nvPr/>
-        </p:nvSpPr>
-        <p:spPr>
-          <a:xfrm xmlns:a="http://schemas.openxmlformats.org/drawingml/2006/main">
-            <a:off x="762000" y="2266950"/>
-            <a:ext cx="5762625" cy="266700"/>
+          <p:cNvPr id="6" name="">
+            <a:extLst xmlns:a="http://schemas.openxmlformats.org/drawingml/2006/main">
+              <a:ext uri="{FF2B5EF4-FFF2-40B4-BE49-F238E27FC236}">
+                <a16:creationId xmlns:a16="http://schemas.microsoft.com/office/drawing/2014/main" id="{051BFF05-F28F-4002-BD67-868365E21181}"/>
+              </a:ext>
+            </a:extLst>
+          </p:cNvPr>
+          <p:cNvSpPr>
+            <a:spLocks xmlns:a="http://schemas.openxmlformats.org/drawingml/2006/main" noGrp="1"/>
+          </p:cNvSpPr>
+          <p:nvPr/>
+        </p:nvSpPr>
+        <p:spPr>
+          <a:xfrm xmlns:a="http://schemas.openxmlformats.org/drawingml/2006/main">
+            <a:off x="762000" y="2228850"/>
+            <a:ext cx="5762625" cy="219075"/>
           </a:xfrm>
           <a:prstGeom xmlns:a="http://schemas.openxmlformats.org/drawingml/2006/main" prst="rect">
             <a:avLst/>
@@ -8383,17 +8116,17 @@
           <a:lstStyle xmlns:a="http://schemas.openxmlformats.org/drawingml/2006/main"/>
           <a:p xmlns:a="http://schemas.openxmlformats.org/drawingml/2006/main">
             <a:pPr>
-              <a:defRPr sz="1425" b="0">
-                <a:solidFill>
-                  <a:srgbClr val="6B7280"/>
-                </a:solidFill>
-                <a:latin typeface="Arial"/>
-                <a:ea typeface="Arial"/>
-                <a:cs typeface="Arial"/>
-              </a:defRPr>
-            </a:pPr>
-            <a:r>
-              <a:rPr sz="1425" b="0">
+              <a:defRPr sz="1275" b="0">
+                <a:solidFill>
+                  <a:srgbClr val="6B7280"/>
+                </a:solidFill>
+                <a:latin typeface="Arial"/>
+                <a:ea typeface="Arial"/>
+                <a:cs typeface="Arial"/>
+              </a:defRPr>
+            </a:pPr>
+            <a:r>
+              <a:rPr sz="1275" b="0">
                 <a:solidFill>
                   <a:srgbClr val="6B7280"/>
                 </a:solidFill>
@@ -8408,21 +8141,21 @@
       </p:sp>
       <p:sp>
         <p:nvSpPr>
-          <p:cNvPr id="8" name="">
-            <a:extLst xmlns:a="http://schemas.openxmlformats.org/drawingml/2006/main">
-              <a:ext uri="{FF2B5EF4-FFF2-40B4-BE49-F238E27FC236}">
-                <a16:creationId xmlns:a16="http://schemas.microsoft.com/office/drawing/2014/main" id="{C4E47810-A04F-4BC5-B2EB-D107E42650F9}"/>
-              </a:ext>
-            </a:extLst>
-          </p:cNvPr>
-          <p:cNvSpPr>
-            <a:spLocks xmlns:a="http://schemas.openxmlformats.org/drawingml/2006/main" noGrp="1"/>
-          </p:cNvSpPr>
-          <p:nvPr/>
-        </p:nvSpPr>
-        <p:spPr>
-          <a:xfrm xmlns:a="http://schemas.openxmlformats.org/drawingml/2006/main">
-            <a:off x="762000" y="2590800"/>
+          <p:cNvPr id="7" name="">
+            <a:extLst xmlns:a="http://schemas.openxmlformats.org/drawingml/2006/main">
+              <a:ext uri="{FF2B5EF4-FFF2-40B4-BE49-F238E27FC236}">
+                <a16:creationId xmlns:a16="http://schemas.microsoft.com/office/drawing/2014/main" id="{4C574903-43DC-45ED-8429-8D9AB6E38F4C}"/>
+              </a:ext>
+            </a:extLst>
+          </p:cNvPr>
+          <p:cNvSpPr>
+            <a:spLocks xmlns:a="http://schemas.openxmlformats.org/drawingml/2006/main" noGrp="1"/>
+          </p:cNvSpPr>
+          <p:nvPr/>
+        </p:nvSpPr>
+        <p:spPr>
+          <a:xfrm xmlns:a="http://schemas.openxmlformats.org/drawingml/2006/main">
+            <a:off x="762000" y="2476500"/>
             <a:ext cx="5810250" cy="9525"/>
           </a:xfrm>
           <a:prstGeom xmlns:a="http://schemas.openxmlformats.org/drawingml/2006/main" prst="rect">
@@ -8438,22 +8171,22 @@
       </p:sp>
       <p:sp>
         <p:nvSpPr>
-          <p:cNvPr id="9" name="">
-            <a:extLst xmlns:a="http://schemas.openxmlformats.org/drawingml/2006/main">
-              <a:ext uri="{FF2B5EF4-FFF2-40B4-BE49-F238E27FC236}">
-                <a16:creationId xmlns:a16="http://schemas.microsoft.com/office/drawing/2014/main" id="{14C4586B-DE7A-469F-A2F9-6105C7D53B4F}"/>
-              </a:ext>
-            </a:extLst>
-          </p:cNvPr>
-          <p:cNvSpPr>
-            <a:spLocks xmlns:a="http://schemas.openxmlformats.org/drawingml/2006/main" noGrp="1"/>
-          </p:cNvSpPr>
-          <p:nvPr/>
-        </p:nvSpPr>
-        <p:spPr>
-          <a:xfrm xmlns:a="http://schemas.openxmlformats.org/drawingml/2006/main">
-            <a:off x="762000" y="2724150"/>
-            <a:ext cx="5905500" cy="523875"/>
+          <p:cNvPr id="8" name="">
+            <a:extLst xmlns:a="http://schemas.openxmlformats.org/drawingml/2006/main">
+              <a:ext uri="{FF2B5EF4-FFF2-40B4-BE49-F238E27FC236}">
+                <a16:creationId xmlns:a16="http://schemas.microsoft.com/office/drawing/2014/main" id="{E8B13783-7F88-496E-BDE4-090F3A24A4B9}"/>
+              </a:ext>
+            </a:extLst>
+          </p:cNvPr>
+          <p:cNvSpPr>
+            <a:spLocks xmlns:a="http://schemas.openxmlformats.org/drawingml/2006/main" noGrp="1"/>
+          </p:cNvSpPr>
+          <p:nvPr/>
+        </p:nvSpPr>
+        <p:spPr>
+          <a:xfrm xmlns:a="http://schemas.openxmlformats.org/drawingml/2006/main">
+            <a:off x="762000" y="2600325"/>
+            <a:ext cx="5905500" cy="504825"/>
           </a:xfrm>
           <a:prstGeom xmlns:a="http://schemas.openxmlformats.org/drawingml/2006/main" prst="rect">
             <a:avLst/>
@@ -8470,47 +8203,70 @@
           <a:lstStyle xmlns:a="http://schemas.openxmlformats.org/drawingml/2006/main"/>
           <a:p xmlns:a="http://schemas.openxmlformats.org/drawingml/2006/main">
             <a:pPr>
-              <a:defRPr sz="1950" b="0">
-                <a:solidFill>
-                  <a:srgbClr val="111827"/>
-                </a:solidFill>
-                <a:latin typeface="Arial"/>
-                <a:ea typeface="Arial"/>
-                <a:cs typeface="Arial"/>
-              </a:defRPr>
-            </a:pPr>
-            <a:r>
-              <a:rPr sz="1950" b="0">
-                <a:solidFill>
-                  <a:srgbClr val="111827"/>
-                </a:solidFill>
-                <a:latin typeface="Arial"/>
-                <a:ea typeface="Arial"/>
-                <a:cs typeface="Arial"/>
-              </a:rPr>
-              <a:t>Tree models, physical limits, permit-location checks</a:t>
-            </a:r>
-          </a:p>
-        </p:txBody>
-      </p:sp>
-      <p:sp>
-        <p:nvSpPr>
-          <p:cNvPr id="10" name="">
-            <a:extLst xmlns:a="http://schemas.openxmlformats.org/drawingml/2006/main">
-              <a:ext uri="{FF2B5EF4-FFF2-40B4-BE49-F238E27FC236}">
-                <a16:creationId xmlns:a16="http://schemas.microsoft.com/office/drawing/2014/main" id="{8FB9F9B6-09C0-4D5B-85AD-FD692204463E}"/>
-              </a:ext>
-            </a:extLst>
-          </p:cNvPr>
-          <p:cNvSpPr>
-            <a:spLocks xmlns:a="http://schemas.openxmlformats.org/drawingml/2006/main" noGrp="1"/>
-          </p:cNvSpPr>
-          <p:nvPr/>
-        </p:nvSpPr>
-        <p:spPr>
-          <a:xfrm xmlns:a="http://schemas.openxmlformats.org/drawingml/2006/main">
-            <a:off x="762000" y="3381375"/>
-            <a:ext cx="5762625" cy="266700"/>
+              <a:defRPr sz="1650" b="0">
+                <a:solidFill>
+                  <a:srgbClr val="111827"/>
+                </a:solidFill>
+                <a:latin typeface="Arial"/>
+                <a:ea typeface="Arial"/>
+                <a:cs typeface="Arial"/>
+              </a:defRPr>
+            </a:pPr>
+            <a:r>
+              <a:rPr sz="1650" b="0">
+                <a:solidFill>
+                  <a:srgbClr val="111827"/>
+                </a:solidFill>
+                <a:latin typeface="Arial"/>
+                <a:ea typeface="Arial"/>
+                <a:cs typeface="Arial"/>
+              </a:rPr>
+              <a:t>E1: lower XGBoost error. E3/E4: safeguards pass.</a:t>
+            </a:r>
+          </a:p>
+          <a:p xmlns:a="http://schemas.openxmlformats.org/drawingml/2006/main">
+            <a:pPr>
+              <a:defRPr sz="1650" b="0">
+                <a:solidFill>
+                  <a:srgbClr val="111827"/>
+                </a:solidFill>
+                <a:latin typeface="Arial"/>
+                <a:ea typeface="Arial"/>
+                <a:cs typeface="Arial"/>
+              </a:defRPr>
+            </a:pPr>
+            <a:r>
+              <a:rPr sz="1650" b="0">
+                <a:solidFill>
+                  <a:srgbClr val="111827"/>
+                </a:solidFill>
+                <a:latin typeface="Arial"/>
+                <a:ea typeface="Arial"/>
+                <a:cs typeface="Arial"/>
+              </a:rPr>
+              <a:t>Keep models, rules, and location checks.</a:t>
+            </a:r>
+          </a:p>
+        </p:txBody>
+      </p:sp>
+      <p:sp>
+        <p:nvSpPr>
+          <p:cNvPr id="9" name="">
+            <a:extLst xmlns:a="http://schemas.openxmlformats.org/drawingml/2006/main">
+              <a:ext uri="{FF2B5EF4-FFF2-40B4-BE49-F238E27FC236}">
+                <a16:creationId xmlns:a16="http://schemas.microsoft.com/office/drawing/2014/main" id="{DFDE77A8-3D7D-49C6-938A-76630EBBAAAD}"/>
+              </a:ext>
+            </a:extLst>
+          </p:cNvPr>
+          <p:cNvSpPr>
+            <a:spLocks xmlns:a="http://schemas.openxmlformats.org/drawingml/2006/main" noGrp="1"/>
+          </p:cNvSpPr>
+          <p:nvPr/>
+        </p:nvSpPr>
+        <p:spPr>
+          <a:xfrm xmlns:a="http://schemas.openxmlformats.org/drawingml/2006/main">
+            <a:off x="762000" y="3171825"/>
+            <a:ext cx="5762625" cy="219075"/>
           </a:xfrm>
           <a:prstGeom xmlns:a="http://schemas.openxmlformats.org/drawingml/2006/main" prst="rect">
             <a:avLst/>
@@ -8527,46 +8283,46 @@
           <a:lstStyle xmlns:a="http://schemas.openxmlformats.org/drawingml/2006/main"/>
           <a:p xmlns:a="http://schemas.openxmlformats.org/drawingml/2006/main">
             <a:pPr>
-              <a:defRPr sz="1425" b="0">
-                <a:solidFill>
-                  <a:srgbClr val="6B7280"/>
-                </a:solidFill>
-                <a:latin typeface="Arial"/>
-                <a:ea typeface="Arial"/>
-                <a:cs typeface="Arial"/>
-              </a:defRPr>
-            </a:pPr>
-            <a:r>
-              <a:rPr sz="1425" b="0">
-                <a:solidFill>
-                  <a:srgbClr val="6B7280"/>
-                </a:solidFill>
-                <a:latin typeface="Arial"/>
-                <a:ea typeface="Arial"/>
-                <a:cs typeface="Arial"/>
-              </a:rPr>
-              <a:t>IMPROVE (MODIFY)</a:t>
-            </a:r>
-          </a:p>
-        </p:txBody>
-      </p:sp>
-      <p:sp>
-        <p:nvSpPr>
-          <p:cNvPr id="11" name="">
-            <a:extLst xmlns:a="http://schemas.openxmlformats.org/drawingml/2006/main">
-              <a:ext uri="{FF2B5EF4-FFF2-40B4-BE49-F238E27FC236}">
-                <a16:creationId xmlns:a16="http://schemas.microsoft.com/office/drawing/2014/main" id="{AF25B049-865E-451A-ACCC-FD5E42A99F4D}"/>
-              </a:ext>
-            </a:extLst>
-          </p:cNvPr>
-          <p:cNvSpPr>
-            <a:spLocks xmlns:a="http://schemas.openxmlformats.org/drawingml/2006/main" noGrp="1"/>
-          </p:cNvSpPr>
-          <p:nvPr/>
-        </p:nvSpPr>
-        <p:spPr>
-          <a:xfrm xmlns:a="http://schemas.openxmlformats.org/drawingml/2006/main">
-            <a:off x="762000" y="3705225"/>
+              <a:defRPr sz="1275" b="0">
+                <a:solidFill>
+                  <a:srgbClr val="6B7280"/>
+                </a:solidFill>
+                <a:latin typeface="Arial"/>
+                <a:ea typeface="Arial"/>
+                <a:cs typeface="Arial"/>
+              </a:defRPr>
+            </a:pPr>
+            <a:r>
+              <a:rPr sz="1275" b="0">
+                <a:solidFill>
+                  <a:srgbClr val="6B7280"/>
+                </a:solidFill>
+                <a:latin typeface="Arial"/>
+                <a:ea typeface="Arial"/>
+                <a:cs typeface="Arial"/>
+              </a:rPr>
+              <a:t>CHANGE (MODIFY)</a:t>
+            </a:r>
+          </a:p>
+        </p:txBody>
+      </p:sp>
+      <p:sp>
+        <p:nvSpPr>
+          <p:cNvPr id="10" name="">
+            <a:extLst xmlns:a="http://schemas.openxmlformats.org/drawingml/2006/main">
+              <a:ext uri="{FF2B5EF4-FFF2-40B4-BE49-F238E27FC236}">
+                <a16:creationId xmlns:a16="http://schemas.microsoft.com/office/drawing/2014/main" id="{4CF1C17D-7FD2-41D5-AB42-0684D5BD21E5}"/>
+              </a:ext>
+            </a:extLst>
+          </p:cNvPr>
+          <p:cNvSpPr>
+            <a:spLocks xmlns:a="http://schemas.openxmlformats.org/drawingml/2006/main" noGrp="1"/>
+          </p:cNvSpPr>
+          <p:nvPr/>
+        </p:nvSpPr>
+        <p:spPr>
+          <a:xfrm xmlns:a="http://schemas.openxmlformats.org/drawingml/2006/main">
+            <a:off x="762000" y="3429000"/>
             <a:ext cx="5810250" cy="9525"/>
           </a:xfrm>
           <a:prstGeom xmlns:a="http://schemas.openxmlformats.org/drawingml/2006/main" prst="rect">
@@ -8582,22 +8338,22 @@
       </p:sp>
       <p:sp>
         <p:nvSpPr>
-          <p:cNvPr id="12" name="">
-            <a:extLst xmlns:a="http://schemas.openxmlformats.org/drawingml/2006/main">
-              <a:ext uri="{FF2B5EF4-FFF2-40B4-BE49-F238E27FC236}">
-                <a16:creationId xmlns:a16="http://schemas.microsoft.com/office/drawing/2014/main" id="{7973FFBD-BC04-438A-94EA-BCE9A60633A4}"/>
-              </a:ext>
-            </a:extLst>
-          </p:cNvPr>
-          <p:cNvSpPr>
-            <a:spLocks xmlns:a="http://schemas.openxmlformats.org/drawingml/2006/main" noGrp="1"/>
-          </p:cNvSpPr>
-          <p:nvPr/>
-        </p:nvSpPr>
-        <p:spPr>
-          <a:xfrm xmlns:a="http://schemas.openxmlformats.org/drawingml/2006/main">
-            <a:off x="762000" y="3838575"/>
-            <a:ext cx="5905500" cy="523875"/>
+          <p:cNvPr id="11" name="">
+            <a:extLst xmlns:a="http://schemas.openxmlformats.org/drawingml/2006/main">
+              <a:ext uri="{FF2B5EF4-FFF2-40B4-BE49-F238E27FC236}">
+                <a16:creationId xmlns:a16="http://schemas.microsoft.com/office/drawing/2014/main" id="{38A738F6-3669-49D7-9DCC-6BFED673CB7A}"/>
+              </a:ext>
+            </a:extLst>
+          </p:cNvPr>
+          <p:cNvSpPr>
+            <a:spLocks xmlns:a="http://schemas.openxmlformats.org/drawingml/2006/main" noGrp="1"/>
+          </p:cNvSpPr>
+          <p:nvPr/>
+        </p:nvSpPr>
+        <p:spPr>
+          <a:xfrm xmlns:a="http://schemas.openxmlformats.org/drawingml/2006/main">
+            <a:off x="762000" y="3552825"/>
+            <a:ext cx="5905500" cy="504825"/>
           </a:xfrm>
           <a:prstGeom xmlns:a="http://schemas.openxmlformats.org/drawingml/2006/main" prst="rect">
             <a:avLst/>
@@ -8614,47 +8370,70 @@
           <a:lstStyle xmlns:a="http://schemas.openxmlformats.org/drawingml/2006/main"/>
           <a:p xmlns:a="http://schemas.openxmlformats.org/drawingml/2006/main">
             <a:pPr>
-              <a:defRPr sz="1950" b="0">
-                <a:solidFill>
-                  <a:srgbClr val="111827"/>
-                </a:solidFill>
-                <a:latin typeface="Arial"/>
-                <a:ea typeface="Arial"/>
-                <a:cs typeface="Arial"/>
-              </a:defRPr>
-            </a:pPr>
-            <a:r>
-              <a:rPr sz="1950" b="0">
-                <a:solidFill>
-                  <a:srgbClr val="111827"/>
-                </a:solidFill>
-                <a:latin typeface="Arial"/>
-                <a:ea typeface="Arial"/>
-                <a:cs typeface="Arial"/>
-              </a:rPr>
-              <a:t>Check neighbors, shared outages, and prediction ranges</a:t>
-            </a:r>
-          </a:p>
-        </p:txBody>
-      </p:sp>
-      <p:sp>
-        <p:nvSpPr>
-          <p:cNvPr id="13" name="">
-            <a:extLst xmlns:a="http://schemas.openxmlformats.org/drawingml/2006/main">
-              <a:ext uri="{FF2B5EF4-FFF2-40B4-BE49-F238E27FC236}">
-                <a16:creationId xmlns:a16="http://schemas.microsoft.com/office/drawing/2014/main" id="{8E83B950-C690-455E-9FF9-AEC7B12A3B6D}"/>
-              </a:ext>
-            </a:extLst>
-          </p:cNvPr>
-          <p:cNvSpPr>
-            <a:spLocks xmlns:a="http://schemas.openxmlformats.org/drawingml/2006/main" noGrp="1"/>
-          </p:cNvSpPr>
-          <p:nvPr/>
-        </p:nvSpPr>
-        <p:spPr>
-          <a:xfrm xmlns:a="http://schemas.openxmlformats.org/drawingml/2006/main">
-            <a:off x="762000" y="4495800"/>
-            <a:ext cx="5762625" cy="266700"/>
+              <a:defRPr sz="1650" b="0">
+                <a:solidFill>
+                  <a:srgbClr val="111827"/>
+                </a:solidFill>
+                <a:latin typeface="Arial"/>
+                <a:ea typeface="Arial"/>
+                <a:cs typeface="Arial"/>
+              </a:defRPr>
+            </a:pPr>
+            <a:r>
+              <a:rPr sz="1650" b="0">
+                <a:solidFill>
+                  <a:srgbClr val="111827"/>
+                </a:solidFill>
+                <a:latin typeface="Arial"/>
+                <a:ea typeface="Arial"/>
+                <a:cs typeface="Arial"/>
+              </a:rPr>
+              <a:t>E2: biased neighbors. E5: ranges miss 90%.</a:t>
+            </a:r>
+          </a:p>
+          <a:p xmlns:a="http://schemas.openxmlformats.org/drawingml/2006/main">
+            <a:pPr>
+              <a:defRPr sz="1650" b="0">
+                <a:solidFill>
+                  <a:srgbClr val="111827"/>
+                </a:solidFill>
+                <a:latin typeface="Arial"/>
+                <a:ea typeface="Arial"/>
+                <a:cs typeface="Arial"/>
+              </a:defRPr>
+            </a:pPr>
+            <a:r>
+              <a:rPr sz="1650" b="0">
+                <a:solidFill>
+                  <a:srgbClr val="111827"/>
+                </a:solidFill>
+                <a:latin typeface="Arial"/>
+                <a:ea typeface="Arial"/>
+                <a:cs typeface="Arial"/>
+              </a:rPr>
+              <a:t>Improve gaps/ranges and add area balances.</a:t>
+            </a:r>
+          </a:p>
+        </p:txBody>
+      </p:sp>
+      <p:sp>
+        <p:nvSpPr>
+          <p:cNvPr id="12" name="">
+            <a:extLst xmlns:a="http://schemas.openxmlformats.org/drawingml/2006/main">
+              <a:ext uri="{FF2B5EF4-FFF2-40B4-BE49-F238E27FC236}">
+                <a16:creationId xmlns:a16="http://schemas.microsoft.com/office/drawing/2014/main" id="{DAE686BD-55C5-4E1C-B71A-32E73531B1C8}"/>
+              </a:ext>
+            </a:extLst>
+          </p:cNvPr>
+          <p:cNvSpPr>
+            <a:spLocks xmlns:a="http://schemas.openxmlformats.org/drawingml/2006/main" noGrp="1"/>
+          </p:cNvSpPr>
+          <p:nvPr/>
+        </p:nvSpPr>
+        <p:spPr>
+          <a:xfrm xmlns:a="http://schemas.openxmlformats.org/drawingml/2006/main">
+            <a:off x="762000" y="4171950"/>
+            <a:ext cx="5762625" cy="219075"/>
           </a:xfrm>
           <a:prstGeom xmlns:a="http://schemas.openxmlformats.org/drawingml/2006/main" prst="rect">
             <a:avLst/>
@@ -8671,46 +8450,46 @@
           <a:lstStyle xmlns:a="http://schemas.openxmlformats.org/drawingml/2006/main"/>
           <a:p xmlns:a="http://schemas.openxmlformats.org/drawingml/2006/main">
             <a:pPr>
-              <a:defRPr sz="1425" b="0">
-                <a:solidFill>
-                  <a:srgbClr val="6B7280"/>
-                </a:solidFill>
-                <a:latin typeface="Arial"/>
-                <a:ea typeface="Arial"/>
-                <a:cs typeface="Arial"/>
-              </a:defRPr>
-            </a:pPr>
-            <a:r>
-              <a:rPr sz="1425" b="0">
-                <a:solidFill>
-                  <a:srgbClr val="6B7280"/>
-                </a:solidFill>
-                <a:latin typeface="Arial"/>
-                <a:ea typeface="Arial"/>
-                <a:cs typeface="Arial"/>
-              </a:rPr>
-              <a:t>REJECT / DEFER</a:t>
-            </a:r>
-          </a:p>
-        </p:txBody>
-      </p:sp>
-      <p:sp>
-        <p:nvSpPr>
-          <p:cNvPr id="14" name="">
-            <a:extLst xmlns:a="http://schemas.openxmlformats.org/drawingml/2006/main">
-              <a:ext uri="{FF2B5EF4-FFF2-40B4-BE49-F238E27FC236}">
-                <a16:creationId xmlns:a16="http://schemas.microsoft.com/office/drawing/2014/main" id="{9159A556-CC47-4A84-B1B3-D90BEBF37615}"/>
-              </a:ext>
-            </a:extLst>
-          </p:cNvPr>
-          <p:cNvSpPr>
-            <a:spLocks xmlns:a="http://schemas.openxmlformats.org/drawingml/2006/main" noGrp="1"/>
-          </p:cNvSpPr>
-          <p:nvPr/>
-        </p:nvSpPr>
-        <p:spPr>
-          <a:xfrm xmlns:a="http://schemas.openxmlformats.org/drawingml/2006/main">
-            <a:off x="762000" y="4819650"/>
+              <a:defRPr sz="1275" b="0">
+                <a:solidFill>
+                  <a:srgbClr val="6B7280"/>
+                </a:solidFill>
+                <a:latin typeface="Arial"/>
+                <a:ea typeface="Arial"/>
+                <a:cs typeface="Arial"/>
+              </a:defRPr>
+            </a:pPr>
+            <a:r>
+              <a:rPr sz="1275" b="0">
+                <a:solidFill>
+                  <a:srgbClr val="6B7280"/>
+                </a:solidFill>
+                <a:latin typeface="Arial"/>
+                <a:ea typeface="Arial"/>
+                <a:cs typeface="Arial"/>
+              </a:rPr>
+              <a:t>REJECT</a:t>
+            </a:r>
+          </a:p>
+        </p:txBody>
+      </p:sp>
+      <p:sp>
+        <p:nvSpPr>
+          <p:cNvPr id="13" name="">
+            <a:extLst xmlns:a="http://schemas.openxmlformats.org/drawingml/2006/main">
+              <a:ext uri="{FF2B5EF4-FFF2-40B4-BE49-F238E27FC236}">
+                <a16:creationId xmlns:a16="http://schemas.microsoft.com/office/drawing/2014/main" id="{F0D3DDFE-9FB3-49AB-BD8F-3068DA639D7B}"/>
+              </a:ext>
+            </a:extLst>
+          </p:cNvPr>
+          <p:cNvSpPr>
+            <a:spLocks xmlns:a="http://schemas.openxmlformats.org/drawingml/2006/main" noGrp="1"/>
+          </p:cNvSpPr>
+          <p:nvPr/>
+        </p:nvSpPr>
+        <p:spPr>
+          <a:xfrm xmlns:a="http://schemas.openxmlformats.org/drawingml/2006/main">
+            <a:off x="762000" y="4419600"/>
             <a:ext cx="5810250" cy="9525"/>
           </a:xfrm>
           <a:prstGeom xmlns:a="http://schemas.openxmlformats.org/drawingml/2006/main" prst="rect">
@@ -8726,22 +8505,22 @@
       </p:sp>
       <p:sp>
         <p:nvSpPr>
-          <p:cNvPr id="15" name="">
-            <a:extLst xmlns:a="http://schemas.openxmlformats.org/drawingml/2006/main">
-              <a:ext uri="{FF2B5EF4-FFF2-40B4-BE49-F238E27FC236}">
-                <a16:creationId xmlns:a16="http://schemas.microsoft.com/office/drawing/2014/main" id="{0C2DC4B7-B7AA-47D4-BA1F-E2D3EC19C317}"/>
-              </a:ext>
-            </a:extLst>
-          </p:cNvPr>
-          <p:cNvSpPr>
-            <a:spLocks xmlns:a="http://schemas.openxmlformats.org/drawingml/2006/main" noGrp="1"/>
-          </p:cNvSpPr>
-          <p:nvPr/>
-        </p:nvSpPr>
-        <p:spPr>
-          <a:xfrm xmlns:a="http://schemas.openxmlformats.org/drawingml/2006/main">
-            <a:off x="762000" y="4953000"/>
-            <a:ext cx="5905500" cy="657225"/>
+          <p:cNvPr id="14" name="">
+            <a:extLst xmlns:a="http://schemas.openxmlformats.org/drawingml/2006/main">
+              <a:ext uri="{FF2B5EF4-FFF2-40B4-BE49-F238E27FC236}">
+                <a16:creationId xmlns:a16="http://schemas.microsoft.com/office/drawing/2014/main" id="{2954F798-9AFA-4BE2-A1F0-13954321FA1B}"/>
+              </a:ext>
+            </a:extLst>
+          </p:cNvPr>
+          <p:cNvSpPr>
+            <a:spLocks xmlns:a="http://schemas.openxmlformats.org/drawingml/2006/main" noGrp="1"/>
+          </p:cNvSpPr>
+          <p:nvPr/>
+        </p:nvSpPr>
+        <p:spPr>
+          <a:xfrm xmlns:a="http://schemas.openxmlformats.org/drawingml/2006/main">
+            <a:off x="762000" y="4543425"/>
+            <a:ext cx="5905500" cy="504825"/>
           </a:xfrm>
           <a:prstGeom xmlns:a="http://schemas.openxmlformats.org/drawingml/2006/main" prst="rect">
             <a:avLst/>
@@ -8758,179 +8537,70 @@
           <a:lstStyle xmlns:a="http://schemas.openxmlformats.org/drawingml/2006/main"/>
           <a:p xmlns:a="http://schemas.openxmlformats.org/drawingml/2006/main">
             <a:pPr>
-              <a:defRPr sz="1800" b="0">
-                <a:solidFill>
-                  <a:srgbClr val="111827"/>
-                </a:solidFill>
-                <a:latin typeface="Arial"/>
-                <a:ea typeface="Arial"/>
-                <a:cs typeface="Arial"/>
-              </a:defRPr>
-            </a:pPr>
-            <a:r>
-              <a:rPr sz="1800" b="0">
-                <a:solidFill>
-                  <a:srgbClr val="111827"/>
-                </a:solidFill>
-                <a:latin typeface="Arial"/>
-                <a:ea typeface="Arial"/>
-                <a:cs typeface="Arial"/>
-              </a:rPr>
-              <a:t>R2 is not confidence; wait on neural and generative LLM models</a:t>
-            </a:r>
-          </a:p>
-        </p:txBody>
-      </p:sp>
-      <p:sp>
-        <p:nvSpPr>
-          <p:cNvPr id="16" name="">
-            <a:extLst xmlns:a="http://schemas.openxmlformats.org/drawingml/2006/main">
-              <a:ext uri="{FF2B5EF4-FFF2-40B4-BE49-F238E27FC236}">
-                <a16:creationId xmlns:a16="http://schemas.microsoft.com/office/drawing/2014/main" id="{BC8E1954-1287-47D0-835F-2071120361EA}"/>
-              </a:ext>
-            </a:extLst>
-          </p:cNvPr>
-          <p:cNvSpPr>
-            <a:spLocks xmlns:a="http://schemas.openxmlformats.org/drawingml/2006/main" noGrp="1"/>
-          </p:cNvSpPr>
-          <p:nvPr/>
-        </p:nvSpPr>
-        <p:spPr>
-          <a:xfrm xmlns:a="http://schemas.openxmlformats.org/drawingml/2006/main">
-            <a:off x="7191375" y="2047875"/>
-            <a:ext cx="4286250" cy="3333750"/>
-          </a:xfrm>
-          <a:prstGeom xmlns:a="http://schemas.openxmlformats.org/drawingml/2006/main" prst="ellipse">
-            <a:avLst/>
-          </a:prstGeom>
-          <a:gradFill xmlns:a="http://schemas.openxmlformats.org/drawingml/2006/main">
-            <a:gsLst>
-              <a:gs pos="0">
-                <a:srgbClr val="9382FF">
-                  <a:alpha val="45000"/>
-                </a:srgbClr>
-              </a:gs>
-              <a:gs pos="35000">
-                <a:srgbClr val="9382FF">
-                  <a:alpha val="18000"/>
-                </a:srgbClr>
-              </a:gs>
-              <a:gs pos="65000">
-                <a:srgbClr val="9382FF">
-                  <a:alpha val="4000"/>
-                </a:srgbClr>
-              </a:gs>
-              <a:gs pos="100000">
-                <a:srgbClr val="9382FF">
-                  <a:alpha val="0"/>
-                </a:srgbClr>
-              </a:gs>
-            </a:gsLst>
-            <a:path path="shape"/>
-          </a:gradFill>
-          <a:ln xmlns:a="http://schemas.openxmlformats.org/drawingml/2006/main" w="0">
-            <a:noFill/>
-          </a:ln>
-        </p:spPr>
-      </p:sp>
-      <p:sp>
-        <p:nvSpPr>
-          <p:cNvPr id="17" name="">
-            <a:extLst xmlns:a="http://schemas.openxmlformats.org/drawingml/2006/main">
-              <a:ext uri="{FF2B5EF4-FFF2-40B4-BE49-F238E27FC236}">
-                <a16:creationId xmlns:a16="http://schemas.microsoft.com/office/drawing/2014/main" id="{C31EB9BA-E0B9-493B-BA5F-9B30D9C0CB1E}"/>
-              </a:ext>
-            </a:extLst>
-          </p:cNvPr>
-          <p:cNvSpPr>
-            <a:spLocks xmlns:a="http://schemas.openxmlformats.org/drawingml/2006/main" noGrp="1"/>
-          </p:cNvSpPr>
-          <p:nvPr/>
-        </p:nvSpPr>
-        <p:spPr>
-          <a:xfrm xmlns:a="http://schemas.openxmlformats.org/drawingml/2006/main">
-            <a:off x="7953375" y="2352675"/>
-            <a:ext cx="2571750" cy="2571750"/>
-          </a:xfrm>
-          <a:prstGeom xmlns:a="http://schemas.openxmlformats.org/drawingml/2006/main" prst="ellipse">
-            <a:avLst/>
-          </a:prstGeom>
-          <a:gradFill xmlns:a="http://schemas.openxmlformats.org/drawingml/2006/main">
-            <a:gsLst>
-              <a:gs pos="0">
-                <a:srgbClr val="FFFFFF"/>
-              </a:gs>
-              <a:gs pos="40000">
-                <a:srgbClr val="EEEBFF"/>
-              </a:gs>
-              <a:gs pos="75000">
-                <a:srgbClr val="C8BFFF"/>
-              </a:gs>
-              <a:gs pos="100000">
-                <a:srgbClr val="9382FF">
-                  <a:alpha val="45000"/>
-                </a:srgbClr>
-              </a:gs>
-            </a:gsLst>
-            <a:path path="shape"/>
-          </a:gradFill>
-          <a:ln xmlns:a="http://schemas.openxmlformats.org/drawingml/2006/main" w="9525">
-            <a:solidFill>
-              <a:srgbClr val="E5E7EB"/>
-            </a:solidFill>
-          </a:ln>
-        </p:spPr>
-      </p:sp>
-      <p:sp>
-        <p:nvSpPr>
-          <p:cNvPr id="18" name="">
-            <a:extLst xmlns:a="http://schemas.openxmlformats.org/drawingml/2006/main">
-              <a:ext uri="{FF2B5EF4-FFF2-40B4-BE49-F238E27FC236}">
-                <a16:creationId xmlns:a16="http://schemas.microsoft.com/office/drawing/2014/main" id="{74D1C4D2-290A-46AB-869A-F96949902A5C}"/>
-              </a:ext>
-            </a:extLst>
-          </p:cNvPr>
-          <p:cNvSpPr>
-            <a:spLocks xmlns:a="http://schemas.openxmlformats.org/drawingml/2006/main" noGrp="1"/>
-          </p:cNvSpPr>
-          <p:nvPr/>
-        </p:nvSpPr>
-        <p:spPr>
-          <a:xfrm xmlns:a="http://schemas.openxmlformats.org/drawingml/2006/main">
-            <a:off x="7648575" y="3333750"/>
-            <a:ext cx="3190875" cy="714375"/>
-          </a:xfrm>
-          <a:prstGeom xmlns:a="http://schemas.openxmlformats.org/drawingml/2006/main" prst="ellipse">
-            <a:avLst/>
-          </a:prstGeom>
-          <a:noFill xmlns:a="http://schemas.openxmlformats.org/drawingml/2006/main"/>
-          <a:ln xmlns:a="http://schemas.openxmlformats.org/drawingml/2006/main" w="9525">
-            <a:solidFill>
-              <a:srgbClr val="9CA3AF">
-                <a:alpha val="60000"/>
-              </a:srgbClr>
-            </a:solidFill>
-          </a:ln>
-        </p:spPr>
-      </p:sp>
-      <p:sp>
-        <p:nvSpPr>
-          <p:cNvPr id="19" name="">
-            <a:extLst xmlns:a="http://schemas.openxmlformats.org/drawingml/2006/main">
-              <a:ext uri="{FF2B5EF4-FFF2-40B4-BE49-F238E27FC236}">
-                <a16:creationId xmlns:a16="http://schemas.microsoft.com/office/drawing/2014/main" id="{1476BC79-5BB6-4DF1-BD58-D7A1FD20CEC1}"/>
-              </a:ext>
-            </a:extLst>
-          </p:cNvPr>
-          <p:cNvSpPr>
-            <a:spLocks xmlns:a="http://schemas.openxmlformats.org/drawingml/2006/main" noGrp="1"/>
-          </p:cNvSpPr>
-          <p:nvPr/>
-        </p:nvSpPr>
-        <p:spPr>
-          <a:xfrm xmlns:a="http://schemas.openxmlformats.org/drawingml/2006/main">
-            <a:off x="762000" y="5905500"/>
-            <a:ext cx="10763250" cy="314325"/>
+              <a:defRPr sz="1650" b="0">
+                <a:solidFill>
+                  <a:srgbClr val="111827"/>
+                </a:solidFill>
+                <a:latin typeface="Arial"/>
+                <a:ea typeface="Arial"/>
+                <a:cs typeface="Arial"/>
+              </a:defRPr>
+            </a:pPr>
+            <a:r>
+              <a:rPr sz="1650" b="0">
+                <a:solidFill>
+                  <a:srgbClr val="111827"/>
+                </a:solidFill>
+                <a:latin typeface="Arial"/>
+                <a:ea typeface="Arial"/>
+                <a:cs typeface="Arial"/>
+              </a:rPr>
+              <a:t>E5: R2 is fit, not confidence.</a:t>
+            </a:r>
+          </a:p>
+          <a:p xmlns:a="http://schemas.openxmlformats.org/drawingml/2006/main">
+            <a:pPr>
+              <a:defRPr sz="1650" b="0">
+                <a:solidFill>
+                  <a:srgbClr val="111827"/>
+                </a:solidFill>
+                <a:latin typeface="Arial"/>
+                <a:ea typeface="Arial"/>
+                <a:cs typeface="Arial"/>
+              </a:defRPr>
+            </a:pPr>
+            <a:r>
+              <a:rPr sz="1650" b="0">
+                <a:solidFill>
+                  <a:srgbClr val="111827"/>
+                </a:solidFill>
+                <a:latin typeface="Arial"/>
+                <a:ea typeface="Arial"/>
+                <a:cs typeface="Arial"/>
+              </a:rPr>
+              <a:t>Cooling use is not regional ecosystem impact.</a:t>
+            </a:r>
+          </a:p>
+        </p:txBody>
+      </p:sp>
+      <p:sp>
+        <p:nvSpPr>
+          <p:cNvPr id="15" name="">
+            <a:extLst xmlns:a="http://schemas.openxmlformats.org/drawingml/2006/main">
+              <a:ext uri="{FF2B5EF4-FFF2-40B4-BE49-F238E27FC236}">
+                <a16:creationId xmlns:a16="http://schemas.microsoft.com/office/drawing/2014/main" id="{970B6952-D60D-4E8E-83C0-389EB8D7CA06}"/>
+              </a:ext>
+            </a:extLst>
+          </p:cNvPr>
+          <p:cNvSpPr>
+            <a:spLocks xmlns:a="http://schemas.openxmlformats.org/drawingml/2006/main" noGrp="1"/>
+          </p:cNvSpPr>
+          <p:nvPr/>
+        </p:nvSpPr>
+        <p:spPr>
+          <a:xfrm xmlns:a="http://schemas.openxmlformats.org/drawingml/2006/main">
+            <a:off x="762000" y="5133975"/>
+            <a:ext cx="5762625" cy="219075"/>
           </a:xfrm>
           <a:prstGeom xmlns:a="http://schemas.openxmlformats.org/drawingml/2006/main" prst="rect">
             <a:avLst/>
@@ -8947,47 +8617,77 @@
           <a:lstStyle xmlns:a="http://schemas.openxmlformats.org/drawingml/2006/main"/>
           <a:p xmlns:a="http://schemas.openxmlformats.org/drawingml/2006/main">
             <a:pPr>
-              <a:defRPr sz="1800" b="0">
-                <a:solidFill>
-                  <a:srgbClr val="111827"/>
-                </a:solidFill>
-                <a:latin typeface="Arial"/>
-                <a:ea typeface="Arial"/>
-                <a:cs typeface="Arial"/>
-              </a:defRPr>
-            </a:pPr>
-            <a:r>
-              <a:rPr sz="1800" b="0">
-                <a:solidFill>
-                  <a:srgbClr val="111827"/>
-                </a:solidFill>
-                <a:latin typeface="Arial"/>
-                <a:ea typeface="Arial"/>
-                <a:cs typeface="Arial"/>
-              </a:rPr>
-              <a:t>Will it work during drought at an unseen facility, with reliable prediction ranges?</a:t>
-            </a:r>
-          </a:p>
-        </p:txBody>
-      </p:sp>
-      <p:sp>
-        <p:nvSpPr>
-          <p:cNvPr id="20" name="">
-            <a:extLst xmlns:a="http://schemas.openxmlformats.org/drawingml/2006/main">
-              <a:ext uri="{FF2B5EF4-FFF2-40B4-BE49-F238E27FC236}">
-                <a16:creationId xmlns:a16="http://schemas.microsoft.com/office/drawing/2014/main" id="{54023D29-3BEE-4577-B588-DAF9D70A30C2}"/>
-              </a:ext>
-            </a:extLst>
-          </p:cNvPr>
-          <p:cNvSpPr>
-            <a:spLocks xmlns:a="http://schemas.openxmlformats.org/drawingml/2006/main" noGrp="1"/>
-          </p:cNvSpPr>
-          <p:nvPr/>
-        </p:nvSpPr>
-        <p:spPr>
-          <a:xfrm xmlns:a="http://schemas.openxmlformats.org/drawingml/2006/main">
-            <a:off x="7953375" y="5124450"/>
-            <a:ext cx="3476625" cy="619125"/>
+              <a:defRPr sz="1275" b="0">
+                <a:solidFill>
+                  <a:srgbClr val="6B7280"/>
+                </a:solidFill>
+                <a:latin typeface="Arial"/>
+                <a:ea typeface="Arial"/>
+                <a:cs typeface="Arial"/>
+              </a:defRPr>
+            </a:pPr>
+            <a:r>
+              <a:rPr sz="1275" b="0">
+                <a:solidFill>
+                  <a:srgbClr val="6B7280"/>
+                </a:solidFill>
+                <a:latin typeface="Arial"/>
+                <a:ea typeface="Arial"/>
+                <a:cs typeface="Arial"/>
+              </a:rPr>
+              <a:t>DEFER</a:t>
+            </a:r>
+          </a:p>
+        </p:txBody>
+      </p:sp>
+      <p:sp>
+        <p:nvSpPr>
+          <p:cNvPr id="16" name="">
+            <a:extLst xmlns:a="http://schemas.openxmlformats.org/drawingml/2006/main">
+              <a:ext uri="{FF2B5EF4-FFF2-40B4-BE49-F238E27FC236}">
+                <a16:creationId xmlns:a16="http://schemas.microsoft.com/office/drawing/2014/main" id="{4A9D27A1-3CD4-417F-9C4B-9B3EF23C8B4E}"/>
+              </a:ext>
+            </a:extLst>
+          </p:cNvPr>
+          <p:cNvSpPr>
+            <a:spLocks xmlns:a="http://schemas.openxmlformats.org/drawingml/2006/main" noGrp="1"/>
+          </p:cNvSpPr>
+          <p:nvPr/>
+        </p:nvSpPr>
+        <p:spPr>
+          <a:xfrm xmlns:a="http://schemas.openxmlformats.org/drawingml/2006/main">
+            <a:off x="762000" y="5381625"/>
+            <a:ext cx="5810250" cy="9525"/>
+          </a:xfrm>
+          <a:prstGeom xmlns:a="http://schemas.openxmlformats.org/drawingml/2006/main" prst="rect">
+            <a:avLst/>
+          </a:prstGeom>
+          <a:solidFill xmlns:a="http://schemas.openxmlformats.org/drawingml/2006/main">
+            <a:srgbClr val="E5E7EB"/>
+          </a:solidFill>
+          <a:ln xmlns:a="http://schemas.openxmlformats.org/drawingml/2006/main" w="0">
+            <a:noFill/>
+          </a:ln>
+        </p:spPr>
+      </p:sp>
+      <p:sp>
+        <p:nvSpPr>
+          <p:cNvPr id="17" name="">
+            <a:extLst xmlns:a="http://schemas.openxmlformats.org/drawingml/2006/main">
+              <a:ext uri="{FF2B5EF4-FFF2-40B4-BE49-F238E27FC236}">
+                <a16:creationId xmlns:a16="http://schemas.microsoft.com/office/drawing/2014/main" id="{56B1C13E-660F-4DCB-98A7-7F8B761DA567}"/>
+              </a:ext>
+            </a:extLst>
+          </p:cNvPr>
+          <p:cNvSpPr>
+            <a:spLocks xmlns:a="http://schemas.openxmlformats.org/drawingml/2006/main" noGrp="1"/>
+          </p:cNvSpPr>
+          <p:nvPr/>
+        </p:nvSpPr>
+        <p:spPr>
+          <a:xfrm xmlns:a="http://schemas.openxmlformats.org/drawingml/2006/main">
+            <a:off x="762000" y="5505450"/>
+            <a:ext cx="5905500" cy="295275"/>
           </a:xfrm>
           <a:prstGeom xmlns:a="http://schemas.openxmlformats.org/drawingml/2006/main" prst="rect">
             <a:avLst/>
@@ -9004,6 +8704,120 @@
           <a:lstStyle xmlns:a="http://schemas.openxmlformats.org/drawingml/2006/main"/>
           <a:p xmlns:a="http://schemas.openxmlformats.org/drawingml/2006/main">
             <a:pPr>
+              <a:defRPr sz="1650" b="0">
+                <a:solidFill>
+                  <a:srgbClr val="111827"/>
+                </a:solidFill>
+                <a:latin typeface="Arial"/>
+                <a:ea typeface="Arial"/>
+                <a:cs typeface="Arial"/>
+              </a:defRPr>
+            </a:pPr>
+            <a:r>
+              <a:rPr sz="1650" b="0">
+                <a:solidFill>
+                  <a:srgbClr val="111827"/>
+                </a:solidFill>
+                <a:latin typeface="Arial"/>
+                <a:ea typeface="Arial"/>
+                <a:cs typeface="Arial"/>
+              </a:rPr>
+              <a:t>No neural/LLM benchmark or regional labels yet.</a:t>
+            </a:r>
+          </a:p>
+        </p:txBody>
+      </p:sp>
+      <p:sp>
+        <p:nvSpPr>
+          <p:cNvPr id="18" name="">
+            <a:extLst xmlns:a="http://schemas.openxmlformats.org/drawingml/2006/main">
+              <a:ext uri="{FF2B5EF4-FFF2-40B4-BE49-F238E27FC236}">
+                <a16:creationId xmlns:a16="http://schemas.microsoft.com/office/drawing/2014/main" id="{7AC6AB5B-A2E4-4A0A-AF39-465BCC362DC8}"/>
+              </a:ext>
+            </a:extLst>
+          </p:cNvPr>
+          <p:cNvSpPr>
+            <a:spLocks xmlns:a="http://schemas.openxmlformats.org/drawingml/2006/main" noGrp="1"/>
+          </p:cNvSpPr>
+          <p:nvPr/>
+        </p:nvSpPr>
+        <p:spPr>
+          <a:xfrm xmlns:a="http://schemas.openxmlformats.org/drawingml/2006/main">
+            <a:off x="762000" y="5905500"/>
+            <a:ext cx="10763250" cy="314325"/>
+          </a:xfrm>
+          <a:prstGeom xmlns:a="http://schemas.openxmlformats.org/drawingml/2006/main" prst="rect">
+            <a:avLst/>
+          </a:prstGeom>
+          <a:noFill xmlns:a="http://schemas.openxmlformats.org/drawingml/2006/main"/>
+          <a:ln xmlns:a="http://schemas.openxmlformats.org/drawingml/2006/main" w="0">
+            <a:noFill/>
+          </a:ln>
+        </p:spPr>
+        <p:txBody>
+          <a:bodyPr xmlns:a="http://schemas.openxmlformats.org/drawingml/2006/main" lIns="0" tIns="0" rIns="0" bIns="0">
+            <a:noAutofit/>
+          </a:bodyPr>
+          <a:lstStyle xmlns:a="http://schemas.openxmlformats.org/drawingml/2006/main"/>
+          <a:p xmlns:a="http://schemas.openxmlformats.org/drawingml/2006/main">
+            <a:pPr>
+              <a:defRPr sz="1800" b="0">
+                <a:solidFill>
+                  <a:srgbClr val="111827"/>
+                </a:solidFill>
+                <a:latin typeface="Arial"/>
+                <a:ea typeface="Arial"/>
+                <a:cs typeface="Arial"/>
+              </a:defRPr>
+            </a:pPr>
+            <a:r>
+              <a:rPr sz="1800" b="0">
+                <a:solidFill>
+                  <a:srgbClr val="111827"/>
+                </a:solidFill>
+                <a:latin typeface="Arial"/>
+                <a:ea typeface="Arial"/>
+                <a:cs typeface="Arial"/>
+              </a:rPr>
+              <a:t>Can we validate seasonal reserve and watershed impacts in an unseen area?</a:t>
+            </a:r>
+          </a:p>
+        </p:txBody>
+      </p:sp>
+      <p:sp>
+        <p:nvSpPr>
+          <p:cNvPr id="19" name="">
+            <a:extLst xmlns:a="http://schemas.openxmlformats.org/drawingml/2006/main">
+              <a:ext uri="{FF2B5EF4-FFF2-40B4-BE49-F238E27FC236}">
+                <a16:creationId xmlns:a16="http://schemas.microsoft.com/office/drawing/2014/main" id="{3811D772-3A24-4C59-B8CF-C5E05D800A0D}"/>
+              </a:ext>
+            </a:extLst>
+          </p:cNvPr>
+          <p:cNvSpPr>
+            <a:spLocks xmlns:a="http://schemas.openxmlformats.org/drawingml/2006/main" noGrp="1"/>
+          </p:cNvSpPr>
+          <p:nvPr/>
+        </p:nvSpPr>
+        <p:spPr>
+          <a:xfrm xmlns:a="http://schemas.openxmlformats.org/drawingml/2006/main">
+            <a:off x="7953375" y="5124450"/>
+            <a:ext cx="3476625" cy="619125"/>
+          </a:xfrm>
+          <a:prstGeom xmlns:a="http://schemas.openxmlformats.org/drawingml/2006/main" prst="rect">
+            <a:avLst/>
+          </a:prstGeom>
+          <a:noFill xmlns:a="http://schemas.openxmlformats.org/drawingml/2006/main"/>
+          <a:ln xmlns:a="http://schemas.openxmlformats.org/drawingml/2006/main" w="0">
+            <a:noFill/>
+          </a:ln>
+        </p:spPr>
+        <p:txBody>
+          <a:bodyPr xmlns:a="http://schemas.openxmlformats.org/drawingml/2006/main" lIns="0" tIns="0" rIns="0" bIns="0">
+            <a:noAutofit/>
+          </a:bodyPr>
+          <a:lstStyle xmlns:a="http://schemas.openxmlformats.org/drawingml/2006/main"/>
+          <a:p xmlns:a="http://schemas.openxmlformats.org/drawingml/2006/main">
+            <a:pPr>
               <a:defRPr sz="1275" b="0">
                 <a:solidFill>
                   <a:srgbClr val="6B7280"/>
@@ -9022,7 +8836,7 @@
                 <a:ea typeface="Arial"/>
                 <a:cs typeface="Arial"/>
               </a:rPr>
-              <a:t>Shaun: code + ranges</a:t>
+              <a:t>Shaun: code + area integration</a:t>
             </a:r>
           </a:p>
           <a:p xmlns:a="http://schemas.openxmlformats.org/drawingml/2006/main">
@@ -9045,7 +8859,7 @@
                 <a:ea typeface="Arial"/>
                 <a:cs typeface="Arial"/>
               </a:rPr>
-              <a:t>Troy: data + drought</a:t>
+              <a:t>Troy: data + grounding</a:t>
             </a:r>
           </a:p>
           <a:p xmlns:a="http://schemas.openxmlformats.org/drawingml/2006/main">
@@ -9068,7 +8882,7 @@
                 <a:ea typeface="Arial"/>
                 <a:cs typeface="Arial"/>
               </a:rPr>
-              <a:t>Scott: permits + evidence</a:t>
+              <a:t>Scott: evaluation + evidence</a:t>
             </a:r>
           </a:p>
         </p:txBody>
@@ -9076,7 +8890,7 @@
     </p:spTree>
     <p:extLst>
       <p:ext uri="{BB962C8B-B14F-4D97-AF65-F5344CB8AC3E}">
-        <p14:creationId xmlns:p14="http://schemas.microsoft.com/office/powerpoint/2010/main" val="1973296022"/>
+        <p14:creationId xmlns:p14="http://schemas.microsoft.com/office/powerpoint/2010/main" val="918255602"/>
       </p:ext>
     </p:extLst>
   </p:cSld>

</xml_diff>